<commit_message>
Slide 5: Reduce box sizes, eliminate empty space, and add Business Model architecture
</commit_message>
<xml_diff>
--- a/SIH2026_Idea_Presentation_E-Waste_Setu.pptx
+++ b/SIH2026_Idea_Presentation_E-Waste_Setu.pptx
@@ -10838,8 +10838,8 @@
         </p:nvSpPr>
         <p:spPr>
           <a:xfrm>
-            <a:off x="548640" y="987552"/>
-            <a:ext cx="11091672" cy="292608"/>
+            <a:off x="548640" y="969264"/>
+            <a:ext cx="11091672" cy="237744"/>
           </a:xfrm>
           <a:prstGeom prst="rect">
             <a:avLst/>
@@ -10854,16 +10854,16 @@
           <a:p>
             <a:pPr algn="l"/>
             <a:r>
-              <a:rPr b="1" sz="1200">
+              <a:rPr b="1" sz="1150">
                 <a:solidFill>
                   <a:srgbClr val="0F172A"/>
                 </a:solidFill>
                 <a:latin typeface="Arial"/>
               </a:rPr>
-              <a:t>Stakeholder Value Transformation: </a:t>
-            </a:r>
-            <a:r>
-              <a:rPr b="0" sz="1050">
+              <a:t>Stakeholder Value Transformation &amp; Commercial Viability: </a:t>
+            </a:r>
+            <a:r>
+              <a:rPr b="0" sz="1000">
                 <a:solidFill>
                   <a:srgbClr val="166534"/>
                 </a:solidFill>
@@ -10882,8 +10882,8 @@
         </p:nvSpPr>
         <p:spPr>
           <a:xfrm>
-            <a:off x="548640" y="1316736"/>
-            <a:ext cx="2679192" cy="3035808"/>
+            <a:off x="548640" y="1225296"/>
+            <a:ext cx="2679192" cy="1828800"/>
           </a:xfrm>
           <a:prstGeom prst="roundRect">
             <a:avLst/>
@@ -10891,7 +10891,7 @@
           <a:solidFill>
             <a:srgbClr val="FFFFFF"/>
           </a:solidFill>
-          <a:ln w="17780">
+          <a:ln w="16510">
             <a:solidFill>
               <a:srgbClr val="166534"/>
             </a:solidFill>
@@ -10912,12 +10912,12 @@
           </a:fontRef>
         </p:style>
         <p:txBody>
-          <a:bodyPr rtlCol="0" anchor="t" wrap="square" lIns="109728" rIns="109728" tIns="109728" bIns="73152"/>
+          <a:bodyPr rtlCol="0" anchor="t" wrap="square" lIns="73152" rIns="73152" bIns="27432"/>
           <a:lstStyle/>
           <a:p>
             <a:pPr algn="l"/>
             <a:r>
-              <a:rPr b="1" sz="960">
+              <a:rPr b="1" sz="880">
                 <a:solidFill>
                   <a:srgbClr val="166534"/>
                 </a:solidFill>
@@ -10929,14 +10929,14 @@
           <a:p>
             <a:pPr algn="l">
               <a:spcBef>
-                <a:spcPts val="50"/>
-              </a:spcBef>
-              <a:spcAft>
-                <a:spcPts val="350"/>
-              </a:spcAft>
-            </a:pPr>
-            <a:r>
-              <a:rPr b="0" sz="740">
+                <a:spcPts val="0"/>
+              </a:spcBef>
+              <a:spcAft>
+                <a:spcPts val="100"/>
+              </a:spcAft>
+            </a:pPr>
+            <a:r>
+              <a:rPr b="0" sz="680">
                 <a:solidFill>
                   <a:srgbClr val="64748B"/>
                 </a:solidFill>
@@ -10948,164 +10948,248 @@
           <a:p>
             <a:pPr algn="l">
               <a:spcBef>
+                <a:spcPts val="20"/>
+              </a:spcBef>
+              <a:spcAft>
+                <a:spcPts val="20"/>
+              </a:spcAft>
+            </a:pPr>
+            <a:r>
+              <a:rPr b="1" sz="710">
+                <a:solidFill>
+                  <a:srgbClr val="991B1B"/>
+                </a:solidFill>
+                <a:latin typeface="Calibri"/>
+              </a:rPr>
+              <a:t>BEFORE:</a:t>
+            </a:r>
+          </a:p>
+          <a:p>
+            <a:pPr algn="l">
+              <a:spcBef>
+                <a:spcPts val="20"/>
+              </a:spcBef>
+              <a:spcAft>
+                <a:spcPts val="0"/>
+              </a:spcAft>
+            </a:pPr>
+            <a:r>
+              <a:rPr b="1" sz="680">
+                <a:solidFill>
+                  <a:srgbClr val="B91C1C"/>
+                </a:solidFill>
+                <a:latin typeface="Calibri"/>
+              </a:rPr>
+              <a:t>• </a:t>
+            </a:r>
+            <a:r>
+              <a:rPr b="0" sz="670">
+                <a:solidFill>
+                  <a:srgbClr val="334155"/>
+                </a:solidFill>
+                <a:latin typeface="Calibri"/>
+              </a:rPr>
+              <a:t>Volatile scrap prices dictated by middlemen</a:t>
+            </a:r>
+          </a:p>
+          <a:p>
+            <a:pPr algn="l">
+              <a:spcBef>
+                <a:spcPts val="20"/>
+              </a:spcBef>
+              <a:spcAft>
+                <a:spcPts val="0"/>
+              </a:spcAft>
+            </a:pPr>
+            <a:r>
+              <a:rPr b="1" sz="680">
+                <a:solidFill>
+                  <a:srgbClr val="B91C1C"/>
+                </a:solidFill>
+                <a:latin typeface="Calibri"/>
+              </a:rPr>
+              <a:t>• </a:t>
+            </a:r>
+            <a:r>
+              <a:rPr b="0" sz="670">
+                <a:solidFill>
+                  <a:srgbClr val="334155"/>
+                </a:solidFill>
+                <a:latin typeface="Calibri"/>
+              </a:rPr>
+              <a:t>Zero direct access to authorized recyclers</a:t>
+            </a:r>
+          </a:p>
+          <a:p>
+            <a:pPr algn="l">
+              <a:spcBef>
+                <a:spcPts val="20"/>
+              </a:spcBef>
+              <a:spcAft>
+                <a:spcPts val="0"/>
+              </a:spcAft>
+            </a:pPr>
+            <a:r>
+              <a:rPr b="1" sz="680">
+                <a:solidFill>
+                  <a:srgbClr val="B91C1C"/>
+                </a:solidFill>
+                <a:latin typeface="Calibri"/>
+              </a:rPr>
+              <a:t>• </a:t>
+            </a:r>
+            <a:r>
+              <a:rPr b="0" sz="670">
+                <a:solidFill>
+                  <a:srgbClr val="334155"/>
+                </a:solidFill>
+                <a:latin typeface="Calibri"/>
+              </a:rPr>
+              <a:t>Frequent weight &amp; cash payment disputes</a:t>
+            </a:r>
+          </a:p>
+          <a:p>
+            <a:pPr algn="l">
+              <a:spcBef>
+                <a:spcPts val="20"/>
+              </a:spcBef>
+              <a:spcAft>
+                <a:spcPts val="0"/>
+              </a:spcAft>
+            </a:pPr>
+            <a:r>
+              <a:rPr b="1" sz="680">
+                <a:solidFill>
+                  <a:srgbClr val="B91C1C"/>
+                </a:solidFill>
+                <a:latin typeface="Calibri"/>
+              </a:rPr>
+              <a:t>• </a:t>
+            </a:r>
+            <a:r>
+              <a:rPr b="0" sz="670">
+                <a:solidFill>
+                  <a:srgbClr val="334155"/>
+                </a:solidFill>
+                <a:latin typeface="Calibri"/>
+              </a:rPr>
+              <a:t>No transaction records or credit history</a:t>
+            </a:r>
+          </a:p>
+          <a:p>
+            <a:pPr algn="l">
+              <a:spcBef>
                 <a:spcPts val="150"/>
               </a:spcBef>
               <a:spcAft>
-                <a:spcPts val="100"/>
-              </a:spcAft>
-            </a:pPr>
-            <a:r>
-              <a:rPr b="1" sz="780">
-                <a:solidFill>
-                  <a:srgbClr val="991B1B"/>
-                </a:solidFill>
-                <a:latin typeface="Calibri"/>
-              </a:rPr>
-              <a:t>BEFORE:</a:t>
-            </a:r>
-          </a:p>
-          <a:p>
-            <a:pPr algn="l">
-              <a:spcBef>
-                <a:spcPts val="100"/>
-              </a:spcBef>
-              <a:spcAft>
                 <a:spcPts val="20"/>
               </a:spcAft>
             </a:pPr>
             <a:r>
-              <a:rPr b="1" sz="740">
-                <a:solidFill>
-                  <a:srgbClr val="B91C1C"/>
-                </a:solidFill>
-                <a:latin typeface="Calibri"/>
-              </a:rPr>
-              <a:t>• </a:t>
-            </a:r>
-            <a:r>
-              <a:rPr b="0" sz="730">
-                <a:solidFill>
-                  <a:srgbClr val="334155"/>
-                </a:solidFill>
-                <a:latin typeface="Calibri"/>
-              </a:rPr>
-              <a:t>Volatile scrap prices dictated by middlemen</a:t>
-            </a:r>
-          </a:p>
-          <a:p>
-            <a:pPr algn="l">
-              <a:spcBef>
-                <a:spcPts val="100"/>
-              </a:spcBef>
-              <a:spcAft>
+              <a:rPr b="1" sz="710">
+                <a:solidFill>
+                  <a:srgbClr val="166534"/>
+                </a:solidFill>
+                <a:latin typeface="Calibri"/>
+              </a:rPr>
+              <a:t>AFTER (WITH E-WASTE SETU):</a:t>
+            </a:r>
+          </a:p>
+          <a:p>
+            <a:pPr algn="l">
+              <a:spcBef>
                 <a:spcPts val="20"/>
-              </a:spcAft>
-            </a:pPr>
-            <a:r>
-              <a:rPr b="1" sz="740">
-                <a:solidFill>
-                  <a:srgbClr val="B91C1C"/>
-                </a:solidFill>
-                <a:latin typeface="Calibri"/>
-              </a:rPr>
-              <a:t>• </a:t>
-            </a:r>
-            <a:r>
-              <a:rPr b="0" sz="730">
-                <a:solidFill>
-                  <a:srgbClr val="334155"/>
-                </a:solidFill>
-                <a:latin typeface="Calibri"/>
-              </a:rPr>
-              <a:t>Zero direct access to authorized recyclers</a:t>
-            </a:r>
-          </a:p>
-          <a:p>
-            <a:pPr algn="l">
-              <a:spcBef>
-                <a:spcPts val="100"/>
-              </a:spcBef>
-              <a:spcAft>
+              </a:spcBef>
+              <a:spcAft>
+                <a:spcPts val="0"/>
+              </a:spcAft>
+            </a:pPr>
+            <a:r>
+              <a:rPr b="1" sz="680">
+                <a:solidFill>
+                  <a:srgbClr val="166534"/>
+                </a:solidFill>
+                <a:latin typeface="Calibri"/>
+              </a:rPr>
+              <a:t>✓ </a:t>
+            </a:r>
+            <a:r>
+              <a:rPr b="0" sz="670">
+                <a:solidFill>
+                  <a:srgbClr val="0F172A"/>
+                </a:solidFill>
+                <a:latin typeface="Calibri"/>
+              </a:rPr>
+              <a:t>Live transparent price benchmark access</a:t>
+            </a:r>
+          </a:p>
+          <a:p>
+            <a:pPr algn="l">
+              <a:spcBef>
                 <a:spcPts val="20"/>
-              </a:spcAft>
-            </a:pPr>
-            <a:r>
-              <a:rPr b="1" sz="740">
-                <a:solidFill>
-                  <a:srgbClr val="B91C1C"/>
-                </a:solidFill>
-                <a:latin typeface="Calibri"/>
-              </a:rPr>
-              <a:t>• </a:t>
-            </a:r>
-            <a:r>
-              <a:rPr b="0" sz="730">
-                <a:solidFill>
-                  <a:srgbClr val="334155"/>
-                </a:solidFill>
-                <a:latin typeface="Calibri"/>
-              </a:rPr>
-              <a:t>Frequent weight &amp; cash payment disputes</a:t>
-            </a:r>
-          </a:p>
-          <a:p>
-            <a:pPr algn="l">
-              <a:spcBef>
-                <a:spcPts val="100"/>
-              </a:spcBef>
-              <a:spcAft>
+              </a:spcBef>
+              <a:spcAft>
+                <a:spcPts val="0"/>
+              </a:spcAft>
+            </a:pPr>
+            <a:r>
+              <a:rPr b="1" sz="680">
+                <a:solidFill>
+                  <a:srgbClr val="166534"/>
+                </a:solidFill>
+                <a:latin typeface="Calibri"/>
+              </a:rPr>
+              <a:t>✓ </a:t>
+            </a:r>
+            <a:r>
+              <a:rPr b="0" sz="670">
+                <a:solidFill>
+                  <a:srgbClr val="0F172A"/>
+                </a:solidFill>
+                <a:latin typeface="Calibri"/>
+              </a:rPr>
+              <a:t>Scale OCR weight &amp; photo evidence</a:t>
+            </a:r>
+          </a:p>
+          <a:p>
+            <a:pPr algn="l">
+              <a:spcBef>
                 <a:spcPts val="20"/>
-              </a:spcAft>
-            </a:pPr>
-            <a:r>
-              <a:rPr b="1" sz="740">
-                <a:solidFill>
-                  <a:srgbClr val="B91C1C"/>
-                </a:solidFill>
-                <a:latin typeface="Calibri"/>
-              </a:rPr>
-              <a:t>• </a:t>
-            </a:r>
-            <a:r>
-              <a:rPr b="0" sz="730">
-                <a:solidFill>
-                  <a:srgbClr val="334155"/>
-                </a:solidFill>
-                <a:latin typeface="Calibri"/>
-              </a:rPr>
-              <a:t>No transaction records or credit history</a:t>
-            </a:r>
-          </a:p>
-          <a:p>
-            <a:pPr algn="l">
-              <a:spcBef>
-                <a:spcPts val="350"/>
-              </a:spcBef>
-              <a:spcAft>
-                <a:spcPts val="100"/>
-              </a:spcAft>
-            </a:pPr>
-            <a:r>
-              <a:rPr b="1" sz="780">
+              </a:spcBef>
+              <a:spcAft>
+                <a:spcPts val="0"/>
+              </a:spcAft>
+            </a:pPr>
+            <a:r>
+              <a:rPr b="1" sz="680">
                 <a:solidFill>
                   <a:srgbClr val="166534"/>
                 </a:solidFill>
                 <a:latin typeface="Calibri"/>
               </a:rPr>
-              <a:t>AFTER (WITH E-WASTE SETU):</a:t>
-            </a:r>
-          </a:p>
-          <a:p>
-            <a:pPr algn="l">
-              <a:spcBef>
-                <a:spcPts val="100"/>
-              </a:spcBef>
-              <a:spcAft>
+              <a:t>✓ </a:t>
+            </a:r>
+            <a:r>
+              <a:rPr b="0" sz="670">
+                <a:solidFill>
+                  <a:srgbClr val="0F172A"/>
+                </a:solidFill>
+                <a:latin typeface="Calibri"/>
+              </a:rPr>
+              <a:t>Instant Cash / UPI verified payment records</a:t>
+            </a:r>
+          </a:p>
+          <a:p>
+            <a:pPr algn="l">
+              <a:spcBef>
                 <a:spcPts val="20"/>
-              </a:spcAft>
-            </a:pPr>
-            <a:r>
-              <a:rPr b="1" sz="740">
+              </a:spcBef>
+              <a:spcAft>
+                <a:spcPts val="0"/>
+              </a:spcAft>
+            </a:pPr>
+            <a:r>
+              <a:rPr b="1" sz="680">
                 <a:solidFill>
                   <a:srgbClr val="166534"/>
                 </a:solidFill>
@@ -11114,26 +11198,26 @@
               <a:t>✓ </a:t>
             </a:r>
             <a:r>
-              <a:rPr b="0" sz="730">
+              <a:rPr b="0" sz="670">
                 <a:solidFill>
                   <a:srgbClr val="0F172A"/>
                 </a:solidFill>
                 <a:latin typeface="Calibri"/>
               </a:rPr>
-              <a:t>Live transparent price benchmark access</a:t>
-            </a:r>
-          </a:p>
-          <a:p>
-            <a:pPr algn="l">
-              <a:spcBef>
-                <a:spcPts val="100"/>
-              </a:spcBef>
-              <a:spcAft>
+              <a:t>Portable digital transaction history</a:t>
+            </a:r>
+          </a:p>
+          <a:p>
+            <a:pPr algn="l">
+              <a:spcBef>
                 <a:spcPts val="20"/>
-              </a:spcAft>
-            </a:pPr>
-            <a:r>
-              <a:rPr b="1" sz="740">
+              </a:spcBef>
+              <a:spcAft>
+                <a:spcPts val="0"/>
+              </a:spcAft>
+            </a:pPr>
+            <a:r>
+              <a:rPr b="1" sz="680">
                 <a:solidFill>
                   <a:srgbClr val="166534"/>
                 </a:solidFill>
@@ -11142,107 +11226,23 @@
               <a:t>✓ </a:t>
             </a:r>
             <a:r>
-              <a:rPr b="0" sz="730">
+              <a:rPr b="0" sz="670">
                 <a:solidFill>
                   <a:srgbClr val="0F172A"/>
                 </a:solidFill>
                 <a:latin typeface="Calibri"/>
               </a:rPr>
-              <a:t>Scale OCR weight &amp; photo evidence</a:t>
-            </a:r>
-          </a:p>
-          <a:p>
-            <a:pPr algn="l">
-              <a:spcBef>
-                <a:spcPts val="100"/>
-              </a:spcBef>
-              <a:spcAft>
-                <a:spcPts val="20"/>
-              </a:spcAft>
-            </a:pPr>
-            <a:r>
-              <a:rPr b="1" sz="740">
-                <a:solidFill>
-                  <a:srgbClr val="166534"/>
-                </a:solidFill>
-                <a:latin typeface="Calibri"/>
-              </a:rPr>
-              <a:t>✓ </a:t>
-            </a:r>
-            <a:r>
-              <a:rPr b="0" sz="730">
-                <a:solidFill>
-                  <a:srgbClr val="0F172A"/>
-                </a:solidFill>
-                <a:latin typeface="Calibri"/>
-              </a:rPr>
-              <a:t>Instant Cash / UPI verified payment records</a:t>
-            </a:r>
-          </a:p>
-          <a:p>
-            <a:pPr algn="l">
-              <a:spcBef>
-                <a:spcPts val="100"/>
-              </a:spcBef>
-              <a:spcAft>
-                <a:spcPts val="20"/>
-              </a:spcAft>
-            </a:pPr>
-            <a:r>
-              <a:rPr b="1" sz="740">
-                <a:solidFill>
-                  <a:srgbClr val="166534"/>
-                </a:solidFill>
-                <a:latin typeface="Calibri"/>
-              </a:rPr>
-              <a:t>✓ </a:t>
-            </a:r>
-            <a:r>
-              <a:rPr b="0" sz="730">
-                <a:solidFill>
-                  <a:srgbClr val="0F172A"/>
-                </a:solidFill>
-                <a:latin typeface="Calibri"/>
-              </a:rPr>
-              <a:t>Portable digital transaction history</a:t>
-            </a:r>
-          </a:p>
-          <a:p>
-            <a:pPr algn="l">
-              <a:spcBef>
-                <a:spcPts val="100"/>
-              </a:spcBef>
-              <a:spcAft>
-                <a:spcPts val="20"/>
-              </a:spcAft>
-            </a:pPr>
-            <a:r>
-              <a:rPr b="1" sz="740">
-                <a:solidFill>
-                  <a:srgbClr val="166534"/>
-                </a:solidFill>
-                <a:latin typeface="Calibri"/>
-              </a:rPr>
-              <a:t>✓ </a:t>
-            </a:r>
-            <a:r>
-              <a:rPr b="0" sz="730">
-                <a:solidFill>
-                  <a:srgbClr val="0F172A"/>
-                </a:solidFill>
-                <a:latin typeface="Calibri"/>
-              </a:rPr>
               <a:t>Safe inclusion into formal recycling streams</a:t>
             </a:r>
           </a:p>
           <a:p>
             <a:pPr algn="l">
               <a:spcBef>
-                <a:spcPts val="450"/>
-              </a:spcBef>
-            </a:pPr>
-            <a:r>
-              <a:rPr b="1" sz="700">
+                <a:spcPts val="150"/>
+              </a:spcBef>
+            </a:pPr>
+            <a:r>
+              <a:rPr b="1" sz="660">
                 <a:solidFill>
                   <a:srgbClr val="166534"/>
                 </a:solidFill>
@@ -11261,8 +11261,8 @@
         </p:nvSpPr>
         <p:spPr>
           <a:xfrm>
-            <a:off x="3355848" y="1316736"/>
-            <a:ext cx="2679192" cy="3035808"/>
+            <a:off x="3355848" y="1225296"/>
+            <a:ext cx="2679192" cy="1828800"/>
           </a:xfrm>
           <a:prstGeom prst="roundRect">
             <a:avLst/>
@@ -11270,7 +11270,7 @@
           <a:solidFill>
             <a:srgbClr val="FFFFFF"/>
           </a:solidFill>
-          <a:ln w="17780">
+          <a:ln w="16510">
             <a:solidFill>
               <a:srgbClr val="B45309"/>
             </a:solidFill>
@@ -11291,12 +11291,12 @@
           </a:fontRef>
         </p:style>
         <p:txBody>
-          <a:bodyPr rtlCol="0" anchor="t" wrap="square" lIns="109728" rIns="109728" tIns="109728" bIns="73152"/>
+          <a:bodyPr rtlCol="0" anchor="t" wrap="square" lIns="73152" rIns="73152" bIns="27432"/>
           <a:lstStyle/>
           <a:p>
             <a:pPr algn="l"/>
             <a:r>
-              <a:rPr b="1" sz="960">
+              <a:rPr b="1" sz="880">
                 <a:solidFill>
                   <a:srgbClr val="B45309"/>
                 </a:solidFill>
@@ -11308,14 +11308,14 @@
           <a:p>
             <a:pPr algn="l">
               <a:spcBef>
-                <a:spcPts val="50"/>
-              </a:spcBef>
-              <a:spcAft>
-                <a:spcPts val="350"/>
-              </a:spcAft>
-            </a:pPr>
-            <a:r>
-              <a:rPr b="0" sz="740">
+                <a:spcPts val="0"/>
+              </a:spcBef>
+              <a:spcAft>
+                <a:spcPts val="100"/>
+              </a:spcAft>
+            </a:pPr>
+            <a:r>
+              <a:rPr b="0" sz="680">
                 <a:solidFill>
                   <a:srgbClr val="64748B"/>
                 </a:solidFill>
@@ -11327,164 +11327,248 @@
           <a:p>
             <a:pPr algn="l">
               <a:spcBef>
+                <a:spcPts val="20"/>
+              </a:spcBef>
+              <a:spcAft>
+                <a:spcPts val="20"/>
+              </a:spcAft>
+            </a:pPr>
+            <a:r>
+              <a:rPr b="1" sz="710">
+                <a:solidFill>
+                  <a:srgbClr val="991B1B"/>
+                </a:solidFill>
+                <a:latin typeface="Calibri"/>
+              </a:rPr>
+              <a:t>BEFORE:</a:t>
+            </a:r>
+          </a:p>
+          <a:p>
+            <a:pPr algn="l">
+              <a:spcBef>
+                <a:spcPts val="20"/>
+              </a:spcBef>
+              <a:spcAft>
+                <a:spcPts val="0"/>
+              </a:spcAft>
+            </a:pPr>
+            <a:r>
+              <a:rPr b="1" sz="680">
+                <a:solidFill>
+                  <a:srgbClr val="B91C1C"/>
+                </a:solidFill>
+                <a:latin typeface="Calibri"/>
+              </a:rPr>
+              <a:t>• </a:t>
+            </a:r>
+            <a:r>
+              <a:rPr b="0" sz="670">
+                <a:solidFill>
+                  <a:srgbClr val="334155"/>
+                </a:solidFill>
+                <a:latin typeface="Calibri"/>
+              </a:rPr>
+              <a:t>Manual paper ledgers prone to loss &amp; error</a:t>
+            </a:r>
+          </a:p>
+          <a:p>
+            <a:pPr algn="l">
+              <a:spcBef>
+                <a:spcPts val="20"/>
+              </a:spcBef>
+              <a:spcAft>
+                <a:spcPts val="0"/>
+              </a:spcAft>
+            </a:pPr>
+            <a:r>
+              <a:rPr b="1" sz="680">
+                <a:solidFill>
+                  <a:srgbClr val="B91C1C"/>
+                </a:solidFill>
+                <a:latin typeface="Calibri"/>
+              </a:rPr>
+              <a:t>• </a:t>
+            </a:r>
+            <a:r>
+              <a:rPr b="0" sz="670">
+                <a:solidFill>
+                  <a:srgbClr val="334155"/>
+                </a:solidFill>
+                <a:latin typeface="Calibri"/>
+              </a:rPr>
+              <a:t>Difficult multi-collector bulk coordination</a:t>
+            </a:r>
+          </a:p>
+          <a:p>
+            <a:pPr algn="l">
+              <a:spcBef>
+                <a:spcPts val="20"/>
+              </a:spcBef>
+              <a:spcAft>
+                <a:spcPts val="0"/>
+              </a:spcAft>
+            </a:pPr>
+            <a:r>
+              <a:rPr b="1" sz="680">
+                <a:solidFill>
+                  <a:srgbClr val="B91C1C"/>
+                </a:solidFill>
+                <a:latin typeface="Calibri"/>
+              </a:rPr>
+              <a:t>• </a:t>
+            </a:r>
+            <a:r>
+              <a:rPr b="0" sz="670">
+                <a:solidFill>
+                  <a:srgbClr val="334155"/>
+                </a:solidFill>
+                <a:latin typeface="Calibri"/>
+              </a:rPr>
+              <a:t>Zero advance visibility of inbound scrap</a:t>
+            </a:r>
+          </a:p>
+          <a:p>
+            <a:pPr algn="l">
+              <a:spcBef>
+                <a:spcPts val="20"/>
+              </a:spcBef>
+              <a:spcAft>
+                <a:spcPts val="0"/>
+              </a:spcAft>
+            </a:pPr>
+            <a:r>
+              <a:rPr b="1" sz="680">
+                <a:solidFill>
+                  <a:srgbClr val="B91C1C"/>
+                </a:solidFill>
+                <a:latin typeface="Calibri"/>
+              </a:rPr>
+              <a:t>• </a:t>
+            </a:r>
+            <a:r>
+              <a:rPr b="0" sz="670">
+                <a:solidFill>
+                  <a:srgbClr val="334155"/>
+                </a:solidFill>
+                <a:latin typeface="Calibri"/>
+              </a:rPr>
+              <a:t>Vulnerability to gray-market scrutiny</a:t>
+            </a:r>
+          </a:p>
+          <a:p>
+            <a:pPr algn="l">
+              <a:spcBef>
                 <a:spcPts val="150"/>
               </a:spcBef>
               <a:spcAft>
-                <a:spcPts val="100"/>
-              </a:spcAft>
-            </a:pPr>
-            <a:r>
-              <a:rPr b="1" sz="780">
-                <a:solidFill>
-                  <a:srgbClr val="991B1B"/>
-                </a:solidFill>
-                <a:latin typeface="Calibri"/>
-              </a:rPr>
-              <a:t>BEFORE:</a:t>
-            </a:r>
-          </a:p>
-          <a:p>
-            <a:pPr algn="l">
-              <a:spcBef>
-                <a:spcPts val="100"/>
-              </a:spcBef>
-              <a:spcAft>
                 <a:spcPts val="20"/>
               </a:spcAft>
             </a:pPr>
             <a:r>
-              <a:rPr b="1" sz="740">
-                <a:solidFill>
-                  <a:srgbClr val="B91C1C"/>
-                </a:solidFill>
-                <a:latin typeface="Calibri"/>
-              </a:rPr>
-              <a:t>• </a:t>
-            </a:r>
-            <a:r>
-              <a:rPr b="0" sz="730">
-                <a:solidFill>
-                  <a:srgbClr val="334155"/>
-                </a:solidFill>
-                <a:latin typeface="Calibri"/>
-              </a:rPr>
-              <a:t>Manual paper ledgers prone to loss &amp; error</a:t>
-            </a:r>
-          </a:p>
-          <a:p>
-            <a:pPr algn="l">
-              <a:spcBef>
-                <a:spcPts val="100"/>
-              </a:spcBef>
-              <a:spcAft>
+              <a:rPr b="1" sz="710">
+                <a:solidFill>
+                  <a:srgbClr val="166534"/>
+                </a:solidFill>
+                <a:latin typeface="Calibri"/>
+              </a:rPr>
+              <a:t>AFTER (WITH E-WASTE SETU):</a:t>
+            </a:r>
+          </a:p>
+          <a:p>
+            <a:pPr algn="l">
+              <a:spcBef>
                 <a:spcPts val="20"/>
-              </a:spcAft>
-            </a:pPr>
-            <a:r>
-              <a:rPr b="1" sz="740">
-                <a:solidFill>
-                  <a:srgbClr val="B91C1C"/>
-                </a:solidFill>
-                <a:latin typeface="Calibri"/>
-              </a:rPr>
-              <a:t>• </a:t>
-            </a:r>
-            <a:r>
-              <a:rPr b="0" sz="730">
-                <a:solidFill>
-                  <a:srgbClr val="334155"/>
-                </a:solidFill>
-                <a:latin typeface="Calibri"/>
-              </a:rPr>
-              <a:t>Difficult multi-collector bulk coordination</a:t>
-            </a:r>
-          </a:p>
-          <a:p>
-            <a:pPr algn="l">
-              <a:spcBef>
-                <a:spcPts val="100"/>
-              </a:spcBef>
-              <a:spcAft>
+              </a:spcBef>
+              <a:spcAft>
+                <a:spcPts val="0"/>
+              </a:spcAft>
+            </a:pPr>
+            <a:r>
+              <a:rPr b="1" sz="680">
+                <a:solidFill>
+                  <a:srgbClr val="166534"/>
+                </a:solidFill>
+                <a:latin typeface="Calibri"/>
+              </a:rPr>
+              <a:t>✓ </a:t>
+            </a:r>
+            <a:r>
+              <a:rPr b="0" sz="670">
+                <a:solidFill>
+                  <a:srgbClr val="0F172A"/>
+                </a:solidFill>
+                <a:latin typeface="Calibri"/>
+              </a:rPr>
+              <a:t>Digital lotting with parent-child tracking</a:t>
+            </a:r>
+          </a:p>
+          <a:p>
+            <a:pPr algn="l">
+              <a:spcBef>
                 <a:spcPts val="20"/>
-              </a:spcAft>
-            </a:pPr>
-            <a:r>
-              <a:rPr b="1" sz="740">
-                <a:solidFill>
-                  <a:srgbClr val="B91C1C"/>
-                </a:solidFill>
-                <a:latin typeface="Calibri"/>
-              </a:rPr>
-              <a:t>• </a:t>
-            </a:r>
-            <a:r>
-              <a:rPr b="0" sz="730">
-                <a:solidFill>
-                  <a:srgbClr val="334155"/>
-                </a:solidFill>
-                <a:latin typeface="Calibri"/>
-              </a:rPr>
-              <a:t>Zero advance visibility of inbound scrap</a:t>
-            </a:r>
-          </a:p>
-          <a:p>
-            <a:pPr algn="l">
-              <a:spcBef>
-                <a:spcPts val="100"/>
-              </a:spcBef>
-              <a:spcAft>
+              </a:spcBef>
+              <a:spcAft>
+                <a:spcPts val="0"/>
+              </a:spcAft>
+            </a:pPr>
+            <a:r>
+              <a:rPr b="1" sz="680">
+                <a:solidFill>
+                  <a:srgbClr val="166534"/>
+                </a:solidFill>
+                <a:latin typeface="Calibri"/>
+              </a:rPr>
+              <a:t>✓ </a:t>
+            </a:r>
+            <a:r>
+              <a:rPr b="0" sz="670">
+                <a:solidFill>
+                  <a:srgbClr val="0F172A"/>
+                </a:solidFill>
+                <a:latin typeface="Calibri"/>
+              </a:rPr>
+              <a:t>Rapid aggregation of small lots into bulk</a:t>
+            </a:r>
+          </a:p>
+          <a:p>
+            <a:pPr algn="l">
+              <a:spcBef>
                 <a:spcPts val="20"/>
-              </a:spcAft>
-            </a:pPr>
-            <a:r>
-              <a:rPr b="1" sz="740">
-                <a:solidFill>
-                  <a:srgbClr val="B91C1C"/>
-                </a:solidFill>
-                <a:latin typeface="Calibri"/>
-              </a:rPr>
-              <a:t>• </a:t>
-            </a:r>
-            <a:r>
-              <a:rPr b="0" sz="730">
-                <a:solidFill>
-                  <a:srgbClr val="334155"/>
-                </a:solidFill>
-                <a:latin typeface="Calibri"/>
-              </a:rPr>
-              <a:t>Vulnerability to gray-market scrutiny</a:t>
-            </a:r>
-          </a:p>
-          <a:p>
-            <a:pPr algn="l">
-              <a:spcBef>
-                <a:spcPts val="350"/>
-              </a:spcBef>
-              <a:spcAft>
-                <a:spcPts val="100"/>
-              </a:spcAft>
-            </a:pPr>
-            <a:r>
-              <a:rPr b="1" sz="780">
+              </a:spcBef>
+              <a:spcAft>
+                <a:spcPts val="0"/>
+              </a:spcAft>
+            </a:pPr>
+            <a:r>
+              <a:rPr b="1" sz="680">
                 <a:solidFill>
                   <a:srgbClr val="166534"/>
                 </a:solidFill>
                 <a:latin typeface="Calibri"/>
               </a:rPr>
-              <a:t>AFTER (WITH E-WASTE SETU):</a:t>
-            </a:r>
-          </a:p>
-          <a:p>
-            <a:pPr algn="l">
-              <a:spcBef>
-                <a:spcPts val="100"/>
-              </a:spcBef>
-              <a:spcAft>
+              <a:t>✓ </a:t>
+            </a:r>
+            <a:r>
+              <a:rPr b="0" sz="670">
+                <a:solidFill>
+                  <a:srgbClr val="0F172A"/>
+                </a:solidFill>
+                <a:latin typeface="Calibri"/>
+              </a:rPr>
+              <a:t>Transparent, tamper-evident purchase ledger</a:t>
+            </a:r>
+          </a:p>
+          <a:p>
+            <a:pPr algn="l">
+              <a:spcBef>
                 <a:spcPts val="20"/>
-              </a:spcAft>
-            </a:pPr>
-            <a:r>
-              <a:rPr b="1" sz="740">
+              </a:spcBef>
+              <a:spcAft>
+                <a:spcPts val="0"/>
+              </a:spcAft>
+            </a:pPr>
+            <a:r>
+              <a:rPr b="1" sz="680">
                 <a:solidFill>
                   <a:srgbClr val="166534"/>
                 </a:solidFill>
@@ -11493,26 +11577,26 @@
               <a:t>✓ </a:t>
             </a:r>
             <a:r>
-              <a:rPr b="0" sz="730">
+              <a:rPr b="0" sz="670">
                 <a:solidFill>
                   <a:srgbClr val="0F172A"/>
                 </a:solidFill>
                 <a:latin typeface="Calibri"/>
               </a:rPr>
-              <a:t>Digital lotting with parent-child tracking</a:t>
-            </a:r>
-          </a:p>
-          <a:p>
-            <a:pPr algn="l">
-              <a:spcBef>
-                <a:spcPts val="100"/>
-              </a:spcBef>
-              <a:spcAft>
+              <a:t>Direct digital coordination with recyclers</a:t>
+            </a:r>
+          </a:p>
+          <a:p>
+            <a:pPr algn="l">
+              <a:spcBef>
                 <a:spcPts val="20"/>
-              </a:spcAft>
-            </a:pPr>
-            <a:r>
-              <a:rPr b="1" sz="740">
+              </a:spcBef>
+              <a:spcAft>
+                <a:spcPts val="0"/>
+              </a:spcAft>
+            </a:pPr>
+            <a:r>
+              <a:rPr b="1" sz="680">
                 <a:solidFill>
                   <a:srgbClr val="166534"/>
                 </a:solidFill>
@@ -11521,113 +11605,29 @@
               <a:t>✓ </a:t>
             </a:r>
             <a:r>
-              <a:rPr b="0" sz="730">
+              <a:rPr b="0" sz="670">
                 <a:solidFill>
                   <a:srgbClr val="0F172A"/>
                 </a:solidFill>
                 <a:latin typeface="Calibri"/>
               </a:rPr>
-              <a:t>Rapid aggregation of small lots into bulk</a:t>
-            </a:r>
-          </a:p>
-          <a:p>
-            <a:pPr algn="l">
-              <a:spcBef>
-                <a:spcPts val="100"/>
-              </a:spcBef>
-              <a:spcAft>
-                <a:spcPts val="20"/>
-              </a:spcAft>
-            </a:pPr>
-            <a:r>
-              <a:rPr b="1" sz="740">
-                <a:solidFill>
-                  <a:srgbClr val="166534"/>
-                </a:solidFill>
-                <a:latin typeface="Calibri"/>
-              </a:rPr>
-              <a:t>✓ </a:t>
-            </a:r>
-            <a:r>
-              <a:rPr b="0" sz="730">
-                <a:solidFill>
-                  <a:srgbClr val="0F172A"/>
-                </a:solidFill>
-                <a:latin typeface="Calibri"/>
-              </a:rPr>
-              <a:t>Transparent, tamper-evident purchase ledger</a:t>
-            </a:r>
-          </a:p>
-          <a:p>
-            <a:pPr algn="l">
-              <a:spcBef>
-                <a:spcPts val="100"/>
-              </a:spcBef>
-              <a:spcAft>
-                <a:spcPts val="20"/>
-              </a:spcAft>
-            </a:pPr>
-            <a:r>
-              <a:rPr b="1" sz="740">
-                <a:solidFill>
-                  <a:srgbClr val="166534"/>
-                </a:solidFill>
-                <a:latin typeface="Calibri"/>
-              </a:rPr>
-              <a:t>✓ </a:t>
-            </a:r>
-            <a:r>
-              <a:rPr b="0" sz="730">
-                <a:solidFill>
-                  <a:srgbClr val="0F172A"/>
-                </a:solidFill>
-                <a:latin typeface="Calibri"/>
-              </a:rPr>
-              <a:t>Direct digital coordination with recyclers</a:t>
-            </a:r>
-          </a:p>
-          <a:p>
-            <a:pPr algn="l">
-              <a:spcBef>
-                <a:spcPts val="100"/>
-              </a:spcBef>
-              <a:spcAft>
-                <a:spcPts val="20"/>
-              </a:spcAft>
-            </a:pPr>
-            <a:r>
-              <a:rPr b="1" sz="740">
-                <a:solidFill>
-                  <a:srgbClr val="166534"/>
-                </a:solidFill>
-                <a:latin typeface="Calibri"/>
-              </a:rPr>
-              <a:t>✓ </a:t>
-            </a:r>
-            <a:r>
-              <a:rPr b="0" sz="730">
-                <a:solidFill>
-                  <a:srgbClr val="0F172A"/>
-                </a:solidFill>
-                <a:latin typeface="Calibri"/>
-              </a:rPr>
               <a:t>Certified formal collection hub status</a:t>
             </a:r>
           </a:p>
           <a:p>
             <a:pPr algn="l">
               <a:spcBef>
-                <a:spcPts val="450"/>
-              </a:spcBef>
-            </a:pPr>
-            <a:r>
-              <a:rPr b="1" sz="700">
+                <a:spcPts val="150"/>
+              </a:spcBef>
+            </a:pPr>
+            <a:r>
+              <a:rPr b="1" sz="660">
                 <a:solidFill>
                   <a:srgbClr val="B45309"/>
                 </a:solidFill>
                 <a:latin typeface="Calibri"/>
               </a:rPr>
-              <a:t>VALUE: Digital lotting &amp; transition to certified collection hubs</a:t>
+              <a:t>VALUE: Digital lotting &amp; transition to certified hubs</a:t>
             </a:r>
           </a:p>
         </p:txBody>
@@ -11640,8 +11640,8 @@
         </p:nvSpPr>
         <p:spPr>
           <a:xfrm>
-            <a:off x="6163056" y="1316736"/>
-            <a:ext cx="2679192" cy="3035808"/>
+            <a:off x="6163056" y="1225296"/>
+            <a:ext cx="2679192" cy="1828800"/>
           </a:xfrm>
           <a:prstGeom prst="roundRect">
             <a:avLst/>
@@ -11649,7 +11649,7 @@
           <a:solidFill>
             <a:srgbClr val="FFFFFF"/>
           </a:solidFill>
-          <a:ln w="17780">
+          <a:ln w="16510">
             <a:solidFill>
               <a:srgbClr val="1E40AF"/>
             </a:solidFill>
@@ -11670,12 +11670,12 @@
           </a:fontRef>
         </p:style>
         <p:txBody>
-          <a:bodyPr rtlCol="0" anchor="t" wrap="square" lIns="109728" rIns="109728" tIns="109728" bIns="73152"/>
+          <a:bodyPr rtlCol="0" anchor="t" wrap="square" lIns="73152" rIns="73152" bIns="27432"/>
           <a:lstStyle/>
           <a:p>
             <a:pPr algn="l"/>
             <a:r>
-              <a:rPr b="1" sz="960">
+              <a:rPr b="1" sz="880">
                 <a:solidFill>
                   <a:srgbClr val="1E40AF"/>
                 </a:solidFill>
@@ -11687,14 +11687,14 @@
           <a:p>
             <a:pPr algn="l">
               <a:spcBef>
-                <a:spcPts val="50"/>
-              </a:spcBef>
-              <a:spcAft>
-                <a:spcPts val="350"/>
-              </a:spcAft>
-            </a:pPr>
-            <a:r>
-              <a:rPr b="0" sz="740">
+                <a:spcPts val="0"/>
+              </a:spcBef>
+              <a:spcAft>
+                <a:spcPts val="100"/>
+              </a:spcAft>
+            </a:pPr>
+            <a:r>
+              <a:rPr b="0" sz="680">
                 <a:solidFill>
                   <a:srgbClr val="64748B"/>
                 </a:solidFill>
@@ -11706,164 +11706,248 @@
           <a:p>
             <a:pPr algn="l">
               <a:spcBef>
+                <a:spcPts val="20"/>
+              </a:spcBef>
+              <a:spcAft>
+                <a:spcPts val="20"/>
+              </a:spcAft>
+            </a:pPr>
+            <a:r>
+              <a:rPr b="1" sz="710">
+                <a:solidFill>
+                  <a:srgbClr val="991B1B"/>
+                </a:solidFill>
+                <a:latin typeface="Calibri"/>
+              </a:rPr>
+              <a:t>BEFORE:</a:t>
+            </a:r>
+          </a:p>
+          <a:p>
+            <a:pPr algn="l">
+              <a:spcBef>
+                <a:spcPts val="20"/>
+              </a:spcBef>
+              <a:spcAft>
+                <a:spcPts val="0"/>
+              </a:spcAft>
+            </a:pPr>
+            <a:r>
+              <a:rPr b="1" sz="680">
+                <a:solidFill>
+                  <a:srgbClr val="B91C1C"/>
+                </a:solidFill>
+                <a:latin typeface="Calibri"/>
+              </a:rPr>
+              <a:t>• </a:t>
+            </a:r>
+            <a:r>
+              <a:rPr b="0" sz="670">
+                <a:solidFill>
+                  <a:srgbClr val="334155"/>
+                </a:solidFill>
+                <a:latin typeface="Calibri"/>
+              </a:rPr>
+              <a:t>Fragmented supply bypassing formal plants</a:t>
+            </a:r>
+          </a:p>
+          <a:p>
+            <a:pPr algn="l">
+              <a:spcBef>
+                <a:spcPts val="20"/>
+              </a:spcBef>
+              <a:spcAft>
+                <a:spcPts val="0"/>
+              </a:spcAft>
+            </a:pPr>
+            <a:r>
+              <a:rPr b="1" sz="680">
+                <a:solidFill>
+                  <a:srgbClr val="B91C1C"/>
+                </a:solidFill>
+                <a:latin typeface="Calibri"/>
+              </a:rPr>
+              <a:t>• </a:t>
+            </a:r>
+            <a:r>
+              <a:rPr b="0" sz="670">
+                <a:solidFill>
+                  <a:srgbClr val="334155"/>
+                </a:solidFill>
+                <a:latin typeface="Calibri"/>
+              </a:rPr>
+              <a:t>Unverified scrap origin &amp; quality disputes</a:t>
+            </a:r>
+          </a:p>
+          <a:p>
+            <a:pPr algn="l">
+              <a:spcBef>
+                <a:spcPts val="20"/>
+              </a:spcBef>
+              <a:spcAft>
+                <a:spcPts val="0"/>
+              </a:spcAft>
+            </a:pPr>
+            <a:r>
+              <a:rPr b="1" sz="680">
+                <a:solidFill>
+                  <a:srgbClr val="B91C1C"/>
+                </a:solidFill>
+                <a:latin typeface="Calibri"/>
+              </a:rPr>
+              <a:t>• </a:t>
+            </a:r>
+            <a:r>
+              <a:rPr b="0" sz="670">
+                <a:solidFill>
+                  <a:srgbClr val="334155"/>
+                </a:solidFill>
+                <a:latin typeface="Calibri"/>
+              </a:rPr>
+              <a:t>Manual paper manifests with audit gaps</a:t>
+            </a:r>
+          </a:p>
+          <a:p>
+            <a:pPr algn="l">
+              <a:spcBef>
+                <a:spcPts val="20"/>
+              </a:spcBef>
+              <a:spcAft>
+                <a:spcPts val="0"/>
+              </a:spcAft>
+            </a:pPr>
+            <a:r>
+              <a:rPr b="1" sz="680">
+                <a:solidFill>
+                  <a:srgbClr val="B91C1C"/>
+                </a:solidFill>
+                <a:latin typeface="Calibri"/>
+              </a:rPr>
+              <a:t>• </a:t>
+            </a:r>
+            <a:r>
+              <a:rPr b="0" sz="670">
+                <a:solidFill>
+                  <a:srgbClr val="334155"/>
+                </a:solidFill>
+                <a:latin typeface="Calibri"/>
+              </a:rPr>
+              <a:t>Severe plant capacity under-utilization</a:t>
+            </a:r>
+          </a:p>
+          <a:p>
+            <a:pPr algn="l">
+              <a:spcBef>
                 <a:spcPts val="150"/>
               </a:spcBef>
               <a:spcAft>
-                <a:spcPts val="100"/>
-              </a:spcAft>
-            </a:pPr>
-            <a:r>
-              <a:rPr b="1" sz="780">
-                <a:solidFill>
-                  <a:srgbClr val="991B1B"/>
-                </a:solidFill>
-                <a:latin typeface="Calibri"/>
-              </a:rPr>
-              <a:t>BEFORE:</a:t>
-            </a:r>
-          </a:p>
-          <a:p>
-            <a:pPr algn="l">
-              <a:spcBef>
-                <a:spcPts val="100"/>
-              </a:spcBef>
-              <a:spcAft>
                 <a:spcPts val="20"/>
               </a:spcAft>
             </a:pPr>
             <a:r>
-              <a:rPr b="1" sz="740">
-                <a:solidFill>
-                  <a:srgbClr val="B91C1C"/>
-                </a:solidFill>
-                <a:latin typeface="Calibri"/>
-              </a:rPr>
-              <a:t>• </a:t>
-            </a:r>
-            <a:r>
-              <a:rPr b="0" sz="730">
-                <a:solidFill>
-                  <a:srgbClr val="334155"/>
-                </a:solidFill>
-                <a:latin typeface="Calibri"/>
-              </a:rPr>
-              <a:t>Fragmented supply bypassing formal plants</a:t>
-            </a:r>
-          </a:p>
-          <a:p>
-            <a:pPr algn="l">
-              <a:spcBef>
-                <a:spcPts val="100"/>
-              </a:spcBef>
-              <a:spcAft>
+              <a:rPr b="1" sz="710">
+                <a:solidFill>
+                  <a:srgbClr val="166534"/>
+                </a:solidFill>
+                <a:latin typeface="Calibri"/>
+              </a:rPr>
+              <a:t>AFTER (WITH E-WASTE SETU):</a:t>
+            </a:r>
+          </a:p>
+          <a:p>
+            <a:pPr algn="l">
+              <a:spcBef>
                 <a:spcPts val="20"/>
-              </a:spcAft>
-            </a:pPr>
-            <a:r>
-              <a:rPr b="1" sz="740">
-                <a:solidFill>
-                  <a:srgbClr val="B91C1C"/>
-                </a:solidFill>
-                <a:latin typeface="Calibri"/>
-              </a:rPr>
-              <a:t>• </a:t>
-            </a:r>
-            <a:r>
-              <a:rPr b="0" sz="730">
-                <a:solidFill>
-                  <a:srgbClr val="334155"/>
-                </a:solidFill>
-                <a:latin typeface="Calibri"/>
-              </a:rPr>
-              <a:t>Unverified scrap origin &amp; quality disputes</a:t>
-            </a:r>
-          </a:p>
-          <a:p>
-            <a:pPr algn="l">
-              <a:spcBef>
-                <a:spcPts val="100"/>
-              </a:spcBef>
-              <a:spcAft>
+              </a:spcBef>
+              <a:spcAft>
+                <a:spcPts val="0"/>
+              </a:spcAft>
+            </a:pPr>
+            <a:r>
+              <a:rPr b="1" sz="680">
+                <a:solidFill>
+                  <a:srgbClr val="166534"/>
+                </a:solidFill>
+                <a:latin typeface="Calibri"/>
+              </a:rPr>
+              <a:t>✓ </a:t>
+            </a:r>
+            <a:r>
+              <a:rPr b="0" sz="670">
+                <a:solidFill>
+                  <a:srgbClr val="0F172A"/>
+                </a:solidFill>
+                <a:latin typeface="Calibri"/>
+              </a:rPr>
+              <a:t>Pre-segregated, quality-graded bulk lots</a:t>
+            </a:r>
+          </a:p>
+          <a:p>
+            <a:pPr algn="l">
+              <a:spcBef>
                 <a:spcPts val="20"/>
-              </a:spcAft>
-            </a:pPr>
-            <a:r>
-              <a:rPr b="1" sz="740">
-                <a:solidFill>
-                  <a:srgbClr val="B91C1C"/>
-                </a:solidFill>
-                <a:latin typeface="Calibri"/>
-              </a:rPr>
-              <a:t>• </a:t>
-            </a:r>
-            <a:r>
-              <a:rPr b="0" sz="730">
-                <a:solidFill>
-                  <a:srgbClr val="334155"/>
-                </a:solidFill>
-                <a:latin typeface="Calibri"/>
-              </a:rPr>
-              <a:t>Manual paper manifests with audit gaps</a:t>
-            </a:r>
-          </a:p>
-          <a:p>
-            <a:pPr algn="l">
-              <a:spcBef>
-                <a:spcPts val="100"/>
-              </a:spcBef>
-              <a:spcAft>
+              </a:spcBef>
+              <a:spcAft>
+                <a:spcPts val="0"/>
+              </a:spcAft>
+            </a:pPr>
+            <a:r>
+              <a:rPr b="1" sz="680">
+                <a:solidFill>
+                  <a:srgbClr val="166534"/>
+                </a:solidFill>
+                <a:latin typeface="Calibri"/>
+              </a:rPr>
+              <a:t>✓ </a:t>
+            </a:r>
+            <a:r>
+              <a:rPr b="0" sz="670">
+                <a:solidFill>
+                  <a:srgbClr val="0F172A"/>
+                </a:solidFill>
+                <a:latin typeface="Calibri"/>
+              </a:rPr>
+              <a:t>Location-based spatial sourcing &amp; routing</a:t>
+            </a:r>
+          </a:p>
+          <a:p>
+            <a:pPr algn="l">
+              <a:spcBef>
                 <a:spcPts val="20"/>
-              </a:spcAft>
-            </a:pPr>
-            <a:r>
-              <a:rPr b="1" sz="740">
-                <a:solidFill>
-                  <a:srgbClr val="B91C1C"/>
-                </a:solidFill>
-                <a:latin typeface="Calibri"/>
-              </a:rPr>
-              <a:t>• </a:t>
-            </a:r>
-            <a:r>
-              <a:rPr b="0" sz="730">
-                <a:solidFill>
-                  <a:srgbClr val="334155"/>
-                </a:solidFill>
-                <a:latin typeface="Calibri"/>
-              </a:rPr>
-              <a:t>Severe plant capacity under-utilization</a:t>
-            </a:r>
-          </a:p>
-          <a:p>
-            <a:pPr algn="l">
-              <a:spcBef>
-                <a:spcPts val="350"/>
-              </a:spcBef>
-              <a:spcAft>
-                <a:spcPts val="100"/>
-              </a:spcAft>
-            </a:pPr>
-            <a:r>
-              <a:rPr b="1" sz="780">
+              </a:spcBef>
+              <a:spcAft>
+                <a:spcPts val="0"/>
+              </a:spcAft>
+            </a:pPr>
+            <a:r>
+              <a:rPr b="1" sz="680">
                 <a:solidFill>
                   <a:srgbClr val="166534"/>
                 </a:solidFill>
                 <a:latin typeface="Calibri"/>
               </a:rPr>
-              <a:t>AFTER (WITH E-WASTE SETU):</a:t>
-            </a:r>
-          </a:p>
-          <a:p>
-            <a:pPr algn="l">
-              <a:spcBef>
-                <a:spcPts val="100"/>
-              </a:spcBef>
-              <a:spcAft>
+              <a:t>✓ </a:t>
+            </a:r>
+            <a:r>
+              <a:rPr b="0" sz="670">
+                <a:solidFill>
+                  <a:srgbClr val="0F172A"/>
+                </a:solidFill>
+                <a:latin typeface="Calibri"/>
+              </a:rPr>
+              <a:t>Cryptographic QR custody &amp; intake check</a:t>
+            </a:r>
+          </a:p>
+          <a:p>
+            <a:pPr algn="l">
+              <a:spcBef>
                 <a:spcPts val="20"/>
-              </a:spcAft>
-            </a:pPr>
-            <a:r>
-              <a:rPr b="1" sz="740">
+              </a:spcBef>
+              <a:spcAft>
+                <a:spcPts val="0"/>
+              </a:spcAft>
+            </a:pPr>
+            <a:r>
+              <a:rPr b="1" sz="680">
                 <a:solidFill>
                   <a:srgbClr val="166534"/>
                 </a:solidFill>
@@ -11872,26 +11956,26 @@
               <a:t>✓ </a:t>
             </a:r>
             <a:r>
-              <a:rPr b="0" sz="730">
+              <a:rPr b="0" sz="670">
                 <a:solidFill>
                   <a:srgbClr val="0F172A"/>
                 </a:solidFill>
                 <a:latin typeface="Calibri"/>
               </a:rPr>
-              <a:t>Pre-segregated, quality-graded bulk lots</a:t>
-            </a:r>
-          </a:p>
-          <a:p>
-            <a:pPr algn="l">
-              <a:spcBef>
-                <a:spcPts val="100"/>
-              </a:spcBef>
-              <a:spcAft>
+              <a:t>Verifiable chain-of-custody to smelting</a:t>
+            </a:r>
+          </a:p>
+          <a:p>
+            <a:pPr algn="l">
+              <a:spcBef>
                 <a:spcPts val="20"/>
-              </a:spcAft>
-            </a:pPr>
-            <a:r>
-              <a:rPr b="1" sz="740">
+              </a:spcBef>
+              <a:spcAft>
+                <a:spcPts val="0"/>
+              </a:spcAft>
+            </a:pPr>
+            <a:r>
+              <a:rPr b="1" sz="680">
                 <a:solidFill>
                   <a:srgbClr val="166534"/>
                 </a:solidFill>
@@ -11900,107 +11984,23 @@
               <a:t>✓ </a:t>
             </a:r>
             <a:r>
-              <a:rPr b="0" sz="730">
+              <a:rPr b="0" sz="670">
                 <a:solidFill>
                   <a:srgbClr val="0F172A"/>
                 </a:solidFill>
                 <a:latin typeface="Calibri"/>
               </a:rPr>
-              <a:t>Location-based spatial sourcing &amp; routing</a:t>
-            </a:r>
-          </a:p>
-          <a:p>
-            <a:pPr algn="l">
-              <a:spcBef>
-                <a:spcPts val="100"/>
-              </a:spcBef>
-              <a:spcAft>
-                <a:spcPts val="20"/>
-              </a:spcAft>
-            </a:pPr>
-            <a:r>
-              <a:rPr b="1" sz="740">
-                <a:solidFill>
-                  <a:srgbClr val="166534"/>
-                </a:solidFill>
-                <a:latin typeface="Calibri"/>
-              </a:rPr>
-              <a:t>✓ </a:t>
-            </a:r>
-            <a:r>
-              <a:rPr b="0" sz="730">
-                <a:solidFill>
-                  <a:srgbClr val="0F172A"/>
-                </a:solidFill>
-                <a:latin typeface="Calibri"/>
-              </a:rPr>
-              <a:t>Cryptographic QR custody &amp; intake check</a:t>
-            </a:r>
-          </a:p>
-          <a:p>
-            <a:pPr algn="l">
-              <a:spcBef>
-                <a:spcPts val="100"/>
-              </a:spcBef>
-              <a:spcAft>
-                <a:spcPts val="20"/>
-              </a:spcAft>
-            </a:pPr>
-            <a:r>
-              <a:rPr b="1" sz="740">
-                <a:solidFill>
-                  <a:srgbClr val="166534"/>
-                </a:solidFill>
-                <a:latin typeface="Calibri"/>
-              </a:rPr>
-              <a:t>✓ </a:t>
-            </a:r>
-            <a:r>
-              <a:rPr b="0" sz="730">
-                <a:solidFill>
-                  <a:srgbClr val="0F172A"/>
-                </a:solidFill>
-                <a:latin typeface="Calibri"/>
-              </a:rPr>
-              <a:t>Verifiable chain-of-custody to smelting</a:t>
-            </a:r>
-          </a:p>
-          <a:p>
-            <a:pPr algn="l">
-              <a:spcBef>
-                <a:spcPts val="100"/>
-              </a:spcBef>
-              <a:spcAft>
-                <a:spcPts val="20"/>
-              </a:spcAft>
-            </a:pPr>
-            <a:r>
-              <a:rPr b="1" sz="740">
-                <a:solidFill>
-                  <a:srgbClr val="166534"/>
-                </a:solidFill>
-                <a:latin typeface="Calibri"/>
-              </a:rPr>
-              <a:t>✓ </a:t>
-            </a:r>
-            <a:r>
-              <a:rPr b="0" sz="730">
-                <a:solidFill>
-                  <a:srgbClr val="0F172A"/>
-                </a:solidFill>
-                <a:latin typeface="Calibri"/>
-              </a:rPr>
               <a:t>Predictable supply &amp; higher throughput</a:t>
             </a:r>
           </a:p>
           <a:p>
             <a:pPr algn="l">
               <a:spcBef>
-                <a:spcPts val="450"/>
-              </a:spcBef>
-            </a:pPr>
-            <a:r>
-              <a:rPr b="1" sz="700">
+                <a:spcPts val="150"/>
+              </a:spcBef>
+            </a:pPr>
+            <a:r>
+              <a:rPr b="1" sz="660">
                 <a:solidFill>
                   <a:srgbClr val="1E40AF"/>
                 </a:solidFill>
@@ -12019,8 +12019,8 @@
         </p:nvSpPr>
         <p:spPr>
           <a:xfrm>
-            <a:off x="8970264" y="1316736"/>
-            <a:ext cx="2679192" cy="3035808"/>
+            <a:off x="8970264" y="1225296"/>
+            <a:ext cx="2679192" cy="1828800"/>
           </a:xfrm>
           <a:prstGeom prst="roundRect">
             <a:avLst/>
@@ -12028,7 +12028,7 @@
           <a:solidFill>
             <a:srgbClr val="FFFFFF"/>
           </a:solidFill>
-          <a:ln w="17780">
+          <a:ln w="16510">
             <a:solidFill>
               <a:srgbClr val="6D28D9"/>
             </a:solidFill>
@@ -12049,12 +12049,12 @@
           </a:fontRef>
         </p:style>
         <p:txBody>
-          <a:bodyPr rtlCol="0" anchor="t" wrap="square" lIns="109728" rIns="109728" tIns="109728" bIns="73152"/>
+          <a:bodyPr rtlCol="0" anchor="t" wrap="square" lIns="73152" rIns="73152" bIns="27432"/>
           <a:lstStyle/>
           <a:p>
             <a:pPr algn="l"/>
             <a:r>
-              <a:rPr b="1" sz="960">
+              <a:rPr b="1" sz="880">
                 <a:solidFill>
                   <a:srgbClr val="6D28D9"/>
                 </a:solidFill>
@@ -12066,14 +12066,14 @@
           <a:p>
             <a:pPr algn="l">
               <a:spcBef>
-                <a:spcPts val="50"/>
-              </a:spcBef>
-              <a:spcAft>
-                <a:spcPts val="350"/>
-              </a:spcAft>
-            </a:pPr>
-            <a:r>
-              <a:rPr b="0" sz="740">
+                <a:spcPts val="0"/>
+              </a:spcBef>
+              <a:spcAft>
+                <a:spcPts val="100"/>
+              </a:spcAft>
+            </a:pPr>
+            <a:r>
+              <a:rPr b="0" sz="680">
                 <a:solidFill>
                   <a:srgbClr val="64748B"/>
                 </a:solidFill>
@@ -12085,164 +12085,248 @@
           <a:p>
             <a:pPr algn="l">
               <a:spcBef>
+                <a:spcPts val="20"/>
+              </a:spcBef>
+              <a:spcAft>
+                <a:spcPts val="20"/>
+              </a:spcAft>
+            </a:pPr>
+            <a:r>
+              <a:rPr b="1" sz="710">
+                <a:solidFill>
+                  <a:srgbClr val="991B1B"/>
+                </a:solidFill>
+                <a:latin typeface="Calibri"/>
+              </a:rPr>
+              <a:t>BEFORE:</a:t>
+            </a:r>
+          </a:p>
+          <a:p>
+            <a:pPr algn="l">
+              <a:spcBef>
+                <a:spcPts val="20"/>
+              </a:spcBef>
+              <a:spcAft>
+                <a:spcPts val="0"/>
+              </a:spcAft>
+            </a:pPr>
+            <a:r>
+              <a:rPr b="1" sz="680">
+                <a:solidFill>
+                  <a:srgbClr val="B91C1C"/>
+                </a:solidFill>
+                <a:latin typeface="Calibri"/>
+              </a:rPr>
+              <a:t>• </a:t>
+            </a:r>
+            <a:r>
+              <a:rPr b="0" sz="670">
+                <a:solidFill>
+                  <a:srgbClr val="334155"/>
+                </a:solidFill>
+                <a:latin typeface="Calibri"/>
+              </a:rPr>
+              <a:t>Unmonitored informal scrap flows &amp; leakage</a:t>
+            </a:r>
+          </a:p>
+          <a:p>
+            <a:pPr algn="l">
+              <a:spcBef>
+                <a:spcPts val="20"/>
+              </a:spcBef>
+              <a:spcAft>
+                <a:spcPts val="0"/>
+              </a:spcAft>
+            </a:pPr>
+            <a:r>
+              <a:rPr b="1" sz="680">
+                <a:solidFill>
+                  <a:srgbClr val="B91C1C"/>
+                </a:solidFill>
+                <a:latin typeface="Calibri"/>
+              </a:rPr>
+              <a:t>• </a:t>
+            </a:r>
+            <a:r>
+              <a:rPr b="0" sz="670">
+                <a:solidFill>
+                  <a:srgbClr val="334155"/>
+                </a:solidFill>
+                <a:latin typeface="Calibri"/>
+              </a:rPr>
+              <a:t>Untraceable material custody across dealers</a:t>
+            </a:r>
+          </a:p>
+          <a:p>
+            <a:pPr algn="l">
+              <a:spcBef>
+                <a:spcPts val="20"/>
+              </a:spcBef>
+              <a:spcAft>
+                <a:spcPts val="0"/>
+              </a:spcAft>
+            </a:pPr>
+            <a:r>
+              <a:rPr b="1" sz="680">
+                <a:solidFill>
+                  <a:srgbClr val="B91C1C"/>
+                </a:solidFill>
+                <a:latin typeface="Calibri"/>
+              </a:rPr>
+              <a:t>• </a:t>
+            </a:r>
+            <a:r>
+              <a:rPr b="0" sz="670">
+                <a:solidFill>
+                  <a:srgbClr val="334155"/>
+                </a:solidFill>
+                <a:latin typeface="Calibri"/>
+              </a:rPr>
+              <a:t>Risk of fraudulent paper-only credits</a:t>
+            </a:r>
+          </a:p>
+          <a:p>
+            <a:pPr algn="l">
+              <a:spcBef>
+                <a:spcPts val="20"/>
+              </a:spcBef>
+              <a:spcAft>
+                <a:spcPts val="0"/>
+              </a:spcAft>
+            </a:pPr>
+            <a:r>
+              <a:rPr b="1" sz="680">
+                <a:solidFill>
+                  <a:srgbClr val="B91C1C"/>
+                </a:solidFill>
+                <a:latin typeface="Calibri"/>
+              </a:rPr>
+              <a:t>• </a:t>
+            </a:r>
+            <a:r>
+              <a:rPr b="0" sz="670">
+                <a:solidFill>
+                  <a:srgbClr val="334155"/>
+                </a:solidFill>
+                <a:latin typeface="Calibri"/>
+              </a:rPr>
+              <a:t>Toxic crude backyard leaching &amp; burning</a:t>
+            </a:r>
+          </a:p>
+          <a:p>
+            <a:pPr algn="l">
+              <a:spcBef>
                 <a:spcPts val="150"/>
               </a:spcBef>
               <a:spcAft>
-                <a:spcPts val="100"/>
-              </a:spcAft>
-            </a:pPr>
-            <a:r>
-              <a:rPr b="1" sz="780">
-                <a:solidFill>
-                  <a:srgbClr val="991B1B"/>
-                </a:solidFill>
-                <a:latin typeface="Calibri"/>
-              </a:rPr>
-              <a:t>BEFORE:</a:t>
-            </a:r>
-          </a:p>
-          <a:p>
-            <a:pPr algn="l">
-              <a:spcBef>
-                <a:spcPts val="100"/>
-              </a:spcBef>
-              <a:spcAft>
                 <a:spcPts val="20"/>
               </a:spcAft>
             </a:pPr>
             <a:r>
-              <a:rPr b="1" sz="740">
-                <a:solidFill>
-                  <a:srgbClr val="B91C1C"/>
-                </a:solidFill>
-                <a:latin typeface="Calibri"/>
-              </a:rPr>
-              <a:t>• </a:t>
-            </a:r>
-            <a:r>
-              <a:rPr b="0" sz="730">
-                <a:solidFill>
-                  <a:srgbClr val="334155"/>
-                </a:solidFill>
-                <a:latin typeface="Calibri"/>
-              </a:rPr>
-              <a:t>Unmonitored informal scrap flows &amp; leakage</a:t>
-            </a:r>
-          </a:p>
-          <a:p>
-            <a:pPr algn="l">
-              <a:spcBef>
-                <a:spcPts val="100"/>
-              </a:spcBef>
-              <a:spcAft>
+              <a:rPr b="1" sz="710">
+                <a:solidFill>
+                  <a:srgbClr val="166534"/>
+                </a:solidFill>
+                <a:latin typeface="Calibri"/>
+              </a:rPr>
+              <a:t>AFTER (WITH E-WASTE SETU):</a:t>
+            </a:r>
+          </a:p>
+          <a:p>
+            <a:pPr algn="l">
+              <a:spcBef>
                 <a:spcPts val="20"/>
-              </a:spcAft>
-            </a:pPr>
-            <a:r>
-              <a:rPr b="1" sz="740">
-                <a:solidFill>
-                  <a:srgbClr val="B91C1C"/>
-                </a:solidFill>
-                <a:latin typeface="Calibri"/>
-              </a:rPr>
-              <a:t>• </a:t>
-            </a:r>
-            <a:r>
-              <a:rPr b="0" sz="730">
-                <a:solidFill>
-                  <a:srgbClr val="334155"/>
-                </a:solidFill>
-                <a:latin typeface="Calibri"/>
-              </a:rPr>
-              <a:t>Untraceable material custody across dealers</a:t>
-            </a:r>
-          </a:p>
-          <a:p>
-            <a:pPr algn="l">
-              <a:spcBef>
-                <a:spcPts val="100"/>
-              </a:spcBef>
-              <a:spcAft>
+              </a:spcBef>
+              <a:spcAft>
+                <a:spcPts val="0"/>
+              </a:spcAft>
+            </a:pPr>
+            <a:r>
+              <a:rPr b="1" sz="680">
+                <a:solidFill>
+                  <a:srgbClr val="166534"/>
+                </a:solidFill>
+                <a:latin typeface="Calibri"/>
+              </a:rPr>
+              <a:t>✓ </a:t>
+            </a:r>
+            <a:r>
+              <a:rPr b="0" sz="670">
+                <a:solidFill>
+                  <a:srgbClr val="0F172A"/>
+                </a:solidFill>
+                <a:latin typeface="Calibri"/>
+              </a:rPr>
+              <a:t>Full Collector ➔ Hub ➔ Recycler trace</a:t>
+            </a:r>
+          </a:p>
+          <a:p>
+            <a:pPr algn="l">
+              <a:spcBef>
                 <a:spcPts val="20"/>
-              </a:spcAft>
-            </a:pPr>
-            <a:r>
-              <a:rPr b="1" sz="740">
-                <a:solidFill>
-                  <a:srgbClr val="B91C1C"/>
-                </a:solidFill>
-                <a:latin typeface="Calibri"/>
-              </a:rPr>
-              <a:t>• </a:t>
-            </a:r>
-            <a:r>
-              <a:rPr b="0" sz="730">
-                <a:solidFill>
-                  <a:srgbClr val="334155"/>
-                </a:solidFill>
-                <a:latin typeface="Calibri"/>
-              </a:rPr>
-              <a:t>Risk of fraudulent paper-only credits</a:t>
-            </a:r>
-          </a:p>
-          <a:p>
-            <a:pPr algn="l">
-              <a:spcBef>
-                <a:spcPts val="100"/>
-              </a:spcBef>
-              <a:spcAft>
+              </a:spcBef>
+              <a:spcAft>
+                <a:spcPts val="0"/>
+              </a:spcAft>
+            </a:pPr>
+            <a:r>
+              <a:rPr b="1" sz="680">
+                <a:solidFill>
+                  <a:srgbClr val="166534"/>
+                </a:solidFill>
+                <a:latin typeface="Calibri"/>
+              </a:rPr>
+              <a:t>✓ </a:t>
+            </a:r>
+            <a:r>
+              <a:rPr b="0" sz="670">
+                <a:solidFill>
+                  <a:srgbClr val="0F172A"/>
+                </a:solidFill>
+                <a:latin typeface="Calibri"/>
+              </a:rPr>
+              <a:t>Immutable transaction &amp; movement trail</a:t>
+            </a:r>
+          </a:p>
+          <a:p>
+            <a:pPr algn="l">
+              <a:spcBef>
                 <a:spcPts val="20"/>
-              </a:spcAft>
-            </a:pPr>
-            <a:r>
-              <a:rPr b="1" sz="740">
-                <a:solidFill>
-                  <a:srgbClr val="B91C1C"/>
-                </a:solidFill>
-                <a:latin typeface="Calibri"/>
-              </a:rPr>
-              <a:t>• </a:t>
-            </a:r>
-            <a:r>
-              <a:rPr b="0" sz="730">
-                <a:solidFill>
-                  <a:srgbClr val="334155"/>
-                </a:solidFill>
-                <a:latin typeface="Calibri"/>
-              </a:rPr>
-              <a:t>Toxic crude backyard leaching &amp; burning</a:t>
-            </a:r>
-          </a:p>
-          <a:p>
-            <a:pPr algn="l">
-              <a:spcBef>
-                <a:spcPts val="350"/>
-              </a:spcBef>
-              <a:spcAft>
-                <a:spcPts val="100"/>
-              </a:spcAft>
-            </a:pPr>
-            <a:r>
-              <a:rPr b="1" sz="780">
+              </a:spcBef>
+              <a:spcAft>
+                <a:spcPts val="0"/>
+              </a:spcAft>
+            </a:pPr>
+            <a:r>
+              <a:rPr b="1" sz="680">
                 <a:solidFill>
                   <a:srgbClr val="166534"/>
                 </a:solidFill>
                 <a:latin typeface="Calibri"/>
               </a:rPr>
-              <a:t>AFTER (WITH E-WASTE SETU):</a:t>
-            </a:r>
-          </a:p>
-          <a:p>
-            <a:pPr algn="l">
-              <a:spcBef>
-                <a:spcPts val="100"/>
-              </a:spcBef>
-              <a:spcAft>
+              <a:t>✓ </a:t>
+            </a:r>
+            <a:r>
+              <a:rPr b="0" sz="670">
+                <a:solidFill>
+                  <a:srgbClr val="0F172A"/>
+                </a:solidFill>
+                <a:latin typeface="Calibri"/>
+              </a:rPr>
+              <a:t>Photo, OCR, GPS &amp; timestamp verification</a:t>
+            </a:r>
+          </a:p>
+          <a:p>
+            <a:pPr algn="l">
+              <a:spcBef>
                 <a:spcPts val="20"/>
-              </a:spcAft>
-            </a:pPr>
-            <a:r>
-              <a:rPr b="1" sz="740">
+              </a:spcBef>
+              <a:spcAft>
+                <a:spcPts val="0"/>
+              </a:spcAft>
+            </a:pPr>
+            <a:r>
+              <a:rPr b="1" sz="680">
                 <a:solidFill>
                   <a:srgbClr val="166534"/>
                 </a:solidFill>
@@ -12251,26 +12335,26 @@
               <a:t>✓ </a:t>
             </a:r>
             <a:r>
-              <a:rPr b="0" sz="730">
+              <a:rPr b="0" sz="670">
                 <a:solidFill>
                   <a:srgbClr val="0F172A"/>
                 </a:solidFill>
                 <a:latin typeface="Calibri"/>
               </a:rPr>
-              <a:t>Full Collector ➔ Hub ➔ Recycler trace</a:t>
-            </a:r>
-          </a:p>
-          <a:p>
-            <a:pPr algn="l">
-              <a:spcBef>
-                <a:spcPts val="100"/>
-              </a:spcBef>
-              <a:spcAft>
+              <a:t>Standardized structured compliance data</a:t>
+            </a:r>
+          </a:p>
+          <a:p>
+            <a:pPr algn="l">
+              <a:spcBef>
                 <a:spcPts val="20"/>
-              </a:spcAft>
-            </a:pPr>
-            <a:r>
-              <a:rPr b="1" sz="740">
+              </a:spcBef>
+              <a:spcAft>
+                <a:spcPts val="0"/>
+              </a:spcAft>
+            </a:pPr>
+            <a:r>
+              <a:rPr b="1" sz="680">
                 <a:solidFill>
                   <a:srgbClr val="166534"/>
                 </a:solidFill>
@@ -12279,107 +12363,23 @@
               <a:t>✓ </a:t>
             </a:r>
             <a:r>
-              <a:rPr b="0" sz="730">
+              <a:rPr b="0" sz="670">
                 <a:solidFill>
                   <a:srgbClr val="0F172A"/>
                 </a:solidFill>
                 <a:latin typeface="Calibri"/>
               </a:rPr>
-              <a:t>Immutable transaction &amp; movement trail</a:t>
-            </a:r>
-          </a:p>
-          <a:p>
-            <a:pPr algn="l">
-              <a:spcBef>
-                <a:spcPts val="100"/>
-              </a:spcBef>
-              <a:spcAft>
-                <a:spcPts val="20"/>
-              </a:spcAft>
-            </a:pPr>
-            <a:r>
-              <a:rPr b="1" sz="740">
-                <a:solidFill>
-                  <a:srgbClr val="166534"/>
-                </a:solidFill>
-                <a:latin typeface="Calibri"/>
-              </a:rPr>
-              <a:t>✓ </a:t>
-            </a:r>
-            <a:r>
-              <a:rPr b="0" sz="730">
-                <a:solidFill>
-                  <a:srgbClr val="0F172A"/>
-                </a:solidFill>
-                <a:latin typeface="Calibri"/>
-              </a:rPr>
-              <a:t>Photo, OCR, GPS &amp; timestamp verification</a:t>
-            </a:r>
-          </a:p>
-          <a:p>
-            <a:pPr algn="l">
-              <a:spcBef>
-                <a:spcPts val="100"/>
-              </a:spcBef>
-              <a:spcAft>
-                <a:spcPts val="20"/>
-              </a:spcAft>
-            </a:pPr>
-            <a:r>
-              <a:rPr b="1" sz="740">
-                <a:solidFill>
-                  <a:srgbClr val="166534"/>
-                </a:solidFill>
-                <a:latin typeface="Calibri"/>
-              </a:rPr>
-              <a:t>✓ </a:t>
-            </a:r>
-            <a:r>
-              <a:rPr b="0" sz="730">
-                <a:solidFill>
-                  <a:srgbClr val="0F172A"/>
-                </a:solidFill>
-                <a:latin typeface="Calibri"/>
-              </a:rPr>
-              <a:t>Standardized structured compliance data</a:t>
-            </a:r>
-          </a:p>
-          <a:p>
-            <a:pPr algn="l">
-              <a:spcBef>
-                <a:spcPts val="100"/>
-              </a:spcBef>
-              <a:spcAft>
-                <a:spcPts val="20"/>
-              </a:spcAft>
-            </a:pPr>
-            <a:r>
-              <a:rPr b="1" sz="740">
-                <a:solidFill>
-                  <a:srgbClr val="166534"/>
-                </a:solidFill>
-                <a:latin typeface="Calibri"/>
-              </a:rPr>
-              <a:t>✓ </a:t>
-            </a:r>
-            <a:r>
-              <a:rPr b="0" sz="730">
-                <a:solidFill>
-                  <a:srgbClr val="0F172A"/>
-                </a:solidFill>
-                <a:latin typeface="Calibri"/>
-              </a:rPr>
               <a:t>Automated, verifiable CPCB Form-6 audits</a:t>
             </a:r>
           </a:p>
           <a:p>
             <a:pPr algn="l">
               <a:spcBef>
-                <a:spcPts val="450"/>
-              </a:spcBef>
-            </a:pPr>
-            <a:r>
-              <a:rPr b="1" sz="700">
+                <a:spcPts val="150"/>
+              </a:spcBef>
+            </a:pPr>
+            <a:r>
+              <a:rPr b="1" sz="660">
                 <a:solidFill>
                   <a:srgbClr val="6D28D9"/>
                 </a:solidFill>
@@ -12398,8 +12398,8 @@
         </p:nvSpPr>
         <p:spPr>
           <a:xfrm>
-            <a:off x="548640" y="4462272"/>
-            <a:ext cx="3611880" cy="1792224"/>
+            <a:off x="548640" y="3127248"/>
+            <a:ext cx="3611880" cy="1152144"/>
           </a:xfrm>
           <a:prstGeom prst="roundRect">
             <a:avLst/>
@@ -12407,7 +12407,7 @@
           <a:solidFill>
             <a:srgbClr val="FFFFFF"/>
           </a:solidFill>
-          <a:ln w="17780">
+          <a:ln w="16510">
             <a:solidFill>
               <a:srgbClr val="1E40AF"/>
             </a:solidFill>
@@ -12428,12 +12428,12 @@
           </a:fontRef>
         </p:style>
         <p:txBody>
-          <a:bodyPr rtlCol="0" anchor="t" wrap="square" lIns="128016" rIns="128016" tIns="109728" bIns="73152"/>
+          <a:bodyPr rtlCol="0" anchor="t" wrap="square" bIns="27432"/>
           <a:lstStyle/>
           <a:p>
             <a:pPr algn="l"/>
             <a:r>
-              <a:rPr b="1" sz="960">
+              <a:rPr b="1" sz="860">
                 <a:solidFill>
                   <a:srgbClr val="1E40AF"/>
                 </a:solidFill>
@@ -12442,7 +12442,7 @@
               <a:t>SOCIAL IMPACT</a:t>
             </a:r>
             <a:r>
-              <a:rPr b="1" sz="780">
+              <a:rPr b="1" sz="720">
                 <a:solidFill>
                   <a:srgbClr val="0F172A"/>
                 </a:solidFill>
@@ -12454,14 +12454,14 @@
           <a:p>
             <a:pPr algn="l">
               <a:spcBef>
-                <a:spcPts val="150"/>
-              </a:spcBef>
-              <a:spcAft>
                 <a:spcPts val="50"/>
-              </a:spcAft>
-            </a:pPr>
-            <a:r>
-              <a:rPr b="1" sz="740">
+              </a:spcBef>
+              <a:spcAft>
+                <a:spcPts val="0"/>
+              </a:spcAft>
+            </a:pPr>
+            <a:r>
+              <a:rPr b="1" sz="680">
                 <a:solidFill>
                   <a:srgbClr val="1E40AF"/>
                 </a:solidFill>
@@ -12470,7 +12470,7 @@
               <a:t>• </a:t>
             </a:r>
             <a:r>
-              <a:rPr b="1" sz="730">
+              <a:rPr b="1" sz="680">
                 <a:solidFill>
                   <a:srgbClr val="0F172A"/>
                 </a:solidFill>
@@ -12479,7 +12479,7 @@
               <a:t>Zero-Barrier Access: </a:t>
             </a:r>
             <a:r>
-              <a:rPr b="0" sz="720">
+              <a:rPr b="0" sz="670">
                 <a:solidFill>
                   <a:srgbClr val="334155"/>
                 </a:solidFill>
@@ -12491,14 +12491,14 @@
           <a:p>
             <a:pPr algn="l">
               <a:spcBef>
-                <a:spcPts val="150"/>
-              </a:spcBef>
-              <a:spcAft>
                 <a:spcPts val="50"/>
-              </a:spcAft>
-            </a:pPr>
-            <a:r>
-              <a:rPr b="1" sz="740">
+              </a:spcBef>
+              <a:spcAft>
+                <a:spcPts val="0"/>
+              </a:spcAft>
+            </a:pPr>
+            <a:r>
+              <a:rPr b="1" sz="680">
                 <a:solidFill>
                   <a:srgbClr val="1E40AF"/>
                 </a:solidFill>
@@ -12507,7 +12507,7 @@
               <a:t>• </a:t>
             </a:r>
             <a:r>
-              <a:rPr b="1" sz="730">
+              <a:rPr b="1" sz="680">
                 <a:solidFill>
                   <a:srgbClr val="0F172A"/>
                 </a:solidFill>
@@ -12516,7 +12516,7 @@
               <a:t>Financial Identity: </a:t>
             </a:r>
             <a:r>
-              <a:rPr b="0" sz="720">
+              <a:rPr b="0" sz="670">
                 <a:solidFill>
                   <a:srgbClr val="334155"/>
                 </a:solidFill>
@@ -12528,14 +12528,14 @@
           <a:p>
             <a:pPr algn="l">
               <a:spcBef>
-                <a:spcPts val="150"/>
-              </a:spcBef>
-              <a:spcAft>
                 <a:spcPts val="50"/>
-              </a:spcAft>
-            </a:pPr>
-            <a:r>
-              <a:rPr b="1" sz="740">
+              </a:spcBef>
+              <a:spcAft>
+                <a:spcPts val="0"/>
+              </a:spcAft>
+            </a:pPr>
+            <a:r>
+              <a:rPr b="1" sz="680">
                 <a:solidFill>
                   <a:srgbClr val="1E40AF"/>
                 </a:solidFill>
@@ -12544,7 +12544,7 @@
               <a:t>• </a:t>
             </a:r>
             <a:r>
-              <a:rPr b="1" sz="730">
+              <a:rPr b="1" sz="680">
                 <a:solidFill>
                   <a:srgbClr val="0F172A"/>
                 </a:solidFill>
@@ -12553,7 +12553,7 @@
               <a:t>Dispute Protection: </a:t>
             </a:r>
             <a:r>
-              <a:rPr b="0" sz="720">
+              <a:rPr b="0" sz="670">
                 <a:solidFill>
                   <a:srgbClr val="334155"/>
                 </a:solidFill>
@@ -12565,14 +12565,14 @@
           <a:p>
             <a:pPr algn="l">
               <a:spcBef>
-                <a:spcPts val="150"/>
-              </a:spcBef>
-              <a:spcAft>
                 <a:spcPts val="50"/>
-              </a:spcAft>
-            </a:pPr>
-            <a:r>
-              <a:rPr b="1" sz="740">
+              </a:spcBef>
+              <a:spcAft>
+                <a:spcPts val="0"/>
+              </a:spcAft>
+            </a:pPr>
+            <a:r>
+              <a:rPr b="1" sz="680">
                 <a:solidFill>
                   <a:srgbClr val="1E40AF"/>
                 </a:solidFill>
@@ -12581,7 +12581,7 @@
               <a:t>• </a:t>
             </a:r>
             <a:r>
-              <a:rPr b="1" sz="730">
+              <a:rPr b="1" sz="680">
                 <a:solidFill>
                   <a:srgbClr val="0F172A"/>
                 </a:solidFill>
@@ -12590,7 +12590,7 @@
               <a:t>Dignity of Labor: </a:t>
             </a:r>
             <a:r>
-              <a:rPr b="0" sz="720">
+              <a:rPr b="0" sz="670">
                 <a:solidFill>
                   <a:srgbClr val="334155"/>
                 </a:solidFill>
@@ -12602,11 +12602,11 @@
           <a:p>
             <a:pPr algn="l">
               <a:spcBef>
-                <a:spcPts val="300"/>
-              </a:spcBef>
-            </a:pPr>
-            <a:r>
-              <a:rPr b="1" sz="700">
+                <a:spcPts val="100"/>
+              </a:spcBef>
+            </a:pPr>
+            <a:r>
+              <a:rPr b="1" sz="660">
                 <a:solidFill>
                   <a:srgbClr val="1E40AF"/>
                 </a:solidFill>
@@ -12625,8 +12625,8 @@
         </p:nvSpPr>
         <p:spPr>
           <a:xfrm>
-            <a:off x="4288536" y="4462272"/>
-            <a:ext cx="3611880" cy="1792224"/>
+            <a:off x="4288536" y="3127248"/>
+            <a:ext cx="3611880" cy="1152144"/>
           </a:xfrm>
           <a:prstGeom prst="roundRect">
             <a:avLst/>
@@ -12634,7 +12634,7 @@
           <a:solidFill>
             <a:srgbClr val="FFFFFF"/>
           </a:solidFill>
-          <a:ln w="17780">
+          <a:ln w="16510">
             <a:solidFill>
               <a:srgbClr val="B45309"/>
             </a:solidFill>
@@ -12655,12 +12655,12 @@
           </a:fontRef>
         </p:style>
         <p:txBody>
-          <a:bodyPr rtlCol="0" anchor="t" wrap="square" lIns="128016" rIns="128016" tIns="109728" bIns="73152"/>
+          <a:bodyPr rtlCol="0" anchor="t" wrap="square" bIns="27432"/>
           <a:lstStyle/>
           <a:p>
             <a:pPr algn="l"/>
             <a:r>
-              <a:rPr b="1" sz="960">
+              <a:rPr b="1" sz="860">
                 <a:solidFill>
                   <a:srgbClr val="B45309"/>
                 </a:solidFill>
@@ -12669,7 +12669,7 @@
               <a:t>ECONOMIC IMPACT</a:t>
             </a:r>
             <a:r>
-              <a:rPr b="1" sz="780">
+              <a:rPr b="1" sz="720">
                 <a:solidFill>
                   <a:srgbClr val="0F172A"/>
                 </a:solidFill>
@@ -12681,14 +12681,14 @@
           <a:p>
             <a:pPr algn="l">
               <a:spcBef>
-                <a:spcPts val="150"/>
-              </a:spcBef>
-              <a:spcAft>
                 <a:spcPts val="50"/>
-              </a:spcAft>
-            </a:pPr>
-            <a:r>
-              <a:rPr b="1" sz="740">
+              </a:spcBef>
+              <a:spcAft>
+                <a:spcPts val="0"/>
+              </a:spcAft>
+            </a:pPr>
+            <a:r>
+              <a:rPr b="1" sz="680">
                 <a:solidFill>
                   <a:srgbClr val="B45309"/>
                 </a:solidFill>
@@ -12697,7 +12697,7 @@
               <a:t>• </a:t>
             </a:r>
             <a:r>
-              <a:rPr b="1" sz="730">
+              <a:rPr b="1" sz="680">
                 <a:solidFill>
                   <a:srgbClr val="0F172A"/>
                 </a:solidFill>
@@ -12706,7 +12706,7 @@
               <a:t>Transparent Pricing: </a:t>
             </a:r>
             <a:r>
-              <a:rPr b="0" sz="720">
+              <a:rPr b="0" sz="670">
                 <a:solidFill>
                   <a:srgbClr val="334155"/>
                 </a:solidFill>
@@ -12718,14 +12718,14 @@
           <a:p>
             <a:pPr algn="l">
               <a:spcBef>
-                <a:spcPts val="150"/>
-              </a:spcBef>
-              <a:spcAft>
                 <a:spcPts val="50"/>
-              </a:spcAft>
-            </a:pPr>
-            <a:r>
-              <a:rPr b="1" sz="740">
+              </a:spcBef>
+              <a:spcAft>
+                <a:spcPts val="0"/>
+              </a:spcAft>
+            </a:pPr>
+            <a:r>
+              <a:rPr b="1" sz="680">
                 <a:solidFill>
                   <a:srgbClr val="B45309"/>
                 </a:solidFill>
@@ -12734,7 +12734,7 @@
               <a:t>• </a:t>
             </a:r>
             <a:r>
-              <a:rPr b="1" sz="730">
+              <a:rPr b="1" sz="680">
                 <a:solidFill>
                   <a:srgbClr val="0F172A"/>
                 </a:solidFill>
@@ -12743,7 +12743,7 @@
               <a:t>Bulk Value Capture: </a:t>
             </a:r>
             <a:r>
-              <a:rPr b="0" sz="720">
+              <a:rPr b="0" sz="670">
                 <a:solidFill>
                   <a:srgbClr val="334155"/>
                 </a:solidFill>
@@ -12755,14 +12755,14 @@
           <a:p>
             <a:pPr algn="l">
               <a:spcBef>
-                <a:spcPts val="150"/>
-              </a:spcBef>
-              <a:spcAft>
                 <a:spcPts val="50"/>
-              </a:spcAft>
-            </a:pPr>
-            <a:r>
-              <a:rPr b="1" sz="740">
+              </a:spcBef>
+              <a:spcAft>
+                <a:spcPts val="0"/>
+              </a:spcAft>
+            </a:pPr>
+            <a:r>
+              <a:rPr b="1" sz="680">
                 <a:solidFill>
                   <a:srgbClr val="B45309"/>
                 </a:solidFill>
@@ -12771,7 +12771,7 @@
               <a:t>• </a:t>
             </a:r>
             <a:r>
-              <a:rPr b="1" sz="730">
+              <a:rPr b="1" sz="680">
                 <a:solidFill>
                   <a:srgbClr val="0F172A"/>
                 </a:solidFill>
@@ -12780,7 +12780,7 @@
               <a:t>Dispute-Free Trade: </a:t>
             </a:r>
             <a:r>
-              <a:rPr b="0" sz="720">
+              <a:rPr b="0" sz="670">
                 <a:solidFill>
                   <a:srgbClr val="334155"/>
                 </a:solidFill>
@@ -12792,14 +12792,14 @@
           <a:p>
             <a:pPr algn="l">
               <a:spcBef>
-                <a:spcPts val="150"/>
-              </a:spcBef>
-              <a:spcAft>
                 <a:spcPts val="50"/>
-              </a:spcAft>
-            </a:pPr>
-            <a:r>
-              <a:rPr b="1" sz="740">
+              </a:spcBef>
+              <a:spcAft>
+                <a:spcPts val="0"/>
+              </a:spcAft>
+            </a:pPr>
+            <a:r>
+              <a:rPr b="1" sz="680">
                 <a:solidFill>
                   <a:srgbClr val="B45309"/>
                 </a:solidFill>
@@ -12808,7 +12808,7 @@
               <a:t>• </a:t>
             </a:r>
             <a:r>
-              <a:rPr b="1" sz="730">
+              <a:rPr b="1" sz="680">
                 <a:solidFill>
                   <a:srgbClr val="0F172A"/>
                 </a:solidFill>
@@ -12817,7 +12817,7 @@
               <a:t>Capacity Throughput: </a:t>
             </a:r>
             <a:r>
-              <a:rPr b="0" sz="720">
+              <a:rPr b="0" sz="670">
                 <a:solidFill>
                   <a:srgbClr val="334155"/>
                 </a:solidFill>
@@ -12829,11 +12829,11 @@
           <a:p>
             <a:pPr algn="l">
               <a:spcBef>
-                <a:spcPts val="300"/>
-              </a:spcBef>
-            </a:pPr>
-            <a:r>
-              <a:rPr b="1" sz="700">
+                <a:spcPts val="100"/>
+              </a:spcBef>
+            </a:pPr>
+            <a:r>
+              <a:rPr b="1" sz="660">
                 <a:solidFill>
                   <a:srgbClr val="B45309"/>
                 </a:solidFill>
@@ -12852,8 +12852,8 @@
         </p:nvSpPr>
         <p:spPr>
           <a:xfrm>
-            <a:off x="8028432" y="4462272"/>
-            <a:ext cx="3611880" cy="1792224"/>
+            <a:off x="8028432" y="3127248"/>
+            <a:ext cx="3611880" cy="1152144"/>
           </a:xfrm>
           <a:prstGeom prst="roundRect">
             <a:avLst/>
@@ -12861,7 +12861,7 @@
           <a:solidFill>
             <a:srgbClr val="FFFFFF"/>
           </a:solidFill>
-          <a:ln w="17780">
+          <a:ln w="16510">
             <a:solidFill>
               <a:srgbClr val="166534"/>
             </a:solidFill>
@@ -12882,12 +12882,12 @@
           </a:fontRef>
         </p:style>
         <p:txBody>
-          <a:bodyPr rtlCol="0" anchor="t" wrap="square" lIns="128016" rIns="128016" tIns="109728" bIns="73152"/>
+          <a:bodyPr rtlCol="0" anchor="t" wrap="square" bIns="27432"/>
           <a:lstStyle/>
           <a:p>
             <a:pPr algn="l"/>
             <a:r>
-              <a:rPr b="1" sz="960">
+              <a:rPr b="1" sz="860">
                 <a:solidFill>
                   <a:srgbClr val="166534"/>
                 </a:solidFill>
@@ -12896,7 +12896,7 @@
               <a:t>ENVIRONMENTAL IMPACT</a:t>
             </a:r>
             <a:r>
-              <a:rPr b="1" sz="780">
+              <a:rPr b="1" sz="720">
                 <a:solidFill>
                   <a:srgbClr val="0F172A"/>
                 </a:solidFill>
@@ -12908,14 +12908,14 @@
           <a:p>
             <a:pPr algn="l">
               <a:spcBef>
-                <a:spcPts val="150"/>
-              </a:spcBef>
-              <a:spcAft>
                 <a:spcPts val="50"/>
-              </a:spcAft>
-            </a:pPr>
-            <a:r>
-              <a:rPr b="1" sz="740">
+              </a:spcBef>
+              <a:spcAft>
+                <a:spcPts val="0"/>
+              </a:spcAft>
+            </a:pPr>
+            <a:r>
+              <a:rPr b="1" sz="680">
                 <a:solidFill>
                   <a:srgbClr val="166534"/>
                 </a:solidFill>
@@ -12924,7 +12924,7 @@
               <a:t>• </a:t>
             </a:r>
             <a:r>
-              <a:rPr b="1" sz="730">
+              <a:rPr b="1" sz="680">
                 <a:solidFill>
                   <a:srgbClr val="0F172A"/>
                 </a:solidFill>
@@ -12933,7 +12933,7 @@
               <a:t>Zero Toxic Leaching: </a:t>
             </a:r>
             <a:r>
-              <a:rPr b="0" sz="720">
+              <a:rPr b="0" sz="670">
                 <a:solidFill>
                   <a:srgbClr val="334155"/>
                 </a:solidFill>
@@ -12945,14 +12945,14 @@
           <a:p>
             <a:pPr algn="l">
               <a:spcBef>
-                <a:spcPts val="150"/>
-              </a:spcBef>
-              <a:spcAft>
                 <a:spcPts val="50"/>
-              </a:spcAft>
-            </a:pPr>
-            <a:r>
-              <a:rPr b="1" sz="740">
+              </a:spcBef>
+              <a:spcAft>
+                <a:spcPts val="0"/>
+              </a:spcAft>
+            </a:pPr>
+            <a:r>
+              <a:rPr b="1" sz="680">
                 <a:solidFill>
                   <a:srgbClr val="166534"/>
                 </a:solidFill>
@@ -12961,7 +12961,7 @@
               <a:t>• </a:t>
             </a:r>
             <a:r>
-              <a:rPr b="1" sz="730">
+              <a:rPr b="1" sz="680">
                 <a:solidFill>
                   <a:srgbClr val="0F172A"/>
                 </a:solidFill>
@@ -12970,7 +12970,7 @@
               <a:t>Critical Minerals: </a:t>
             </a:r>
             <a:r>
-              <a:rPr b="0" sz="720">
+              <a:rPr b="0" sz="670">
                 <a:solidFill>
                   <a:srgbClr val="334155"/>
                 </a:solidFill>
@@ -12982,14 +12982,14 @@
           <a:p>
             <a:pPr algn="l">
               <a:spcBef>
-                <a:spcPts val="150"/>
-              </a:spcBef>
-              <a:spcAft>
                 <a:spcPts val="50"/>
-              </a:spcAft>
-            </a:pPr>
-            <a:r>
-              <a:rPr b="1" sz="740">
+              </a:spcBef>
+              <a:spcAft>
+                <a:spcPts val="0"/>
+              </a:spcAft>
+            </a:pPr>
+            <a:r>
+              <a:rPr b="1" sz="680">
                 <a:solidFill>
                   <a:srgbClr val="166534"/>
                 </a:solidFill>
@@ -12998,7 +12998,7 @@
               <a:t>• </a:t>
             </a:r>
             <a:r>
-              <a:rPr b="1" sz="730">
+              <a:rPr b="1" sz="680">
                 <a:solidFill>
                   <a:srgbClr val="0F172A"/>
                 </a:solidFill>
@@ -13007,7 +13007,7 @@
               <a:t>Chain-of-Custody: </a:t>
             </a:r>
             <a:r>
-              <a:rPr b="0" sz="720">
+              <a:rPr b="0" sz="670">
                 <a:solidFill>
                   <a:srgbClr val="334155"/>
                 </a:solidFill>
@@ -13019,14 +13019,14 @@
           <a:p>
             <a:pPr algn="l">
               <a:spcBef>
-                <a:spcPts val="150"/>
-              </a:spcBef>
-              <a:spcAft>
                 <a:spcPts val="50"/>
-              </a:spcAft>
-            </a:pPr>
-            <a:r>
-              <a:rPr b="1" sz="740">
+              </a:spcBef>
+              <a:spcAft>
+                <a:spcPts val="0"/>
+              </a:spcAft>
+            </a:pPr>
+            <a:r>
+              <a:rPr b="1" sz="680">
                 <a:solidFill>
                   <a:srgbClr val="166534"/>
                 </a:solidFill>
@@ -13035,7 +13035,7 @@
               <a:t>• </a:t>
             </a:r>
             <a:r>
-              <a:rPr b="1" sz="730">
+              <a:rPr b="1" sz="680">
                 <a:solidFill>
                   <a:srgbClr val="0F172A"/>
                 </a:solidFill>
@@ -13044,7 +13044,7 @@
               <a:t>Audit-Proof EPR: </a:t>
             </a:r>
             <a:r>
-              <a:rPr b="0" sz="720">
+              <a:rPr b="0" sz="670">
                 <a:solidFill>
                   <a:srgbClr val="334155"/>
                 </a:solidFill>
@@ -13056,8 +13056,134 @@
           <a:p>
             <a:pPr algn="l">
               <a:spcBef>
-                <a:spcPts val="300"/>
-              </a:spcBef>
+                <a:spcPts val="100"/>
+              </a:spcBef>
+            </a:pPr>
+            <a:r>
+              <a:rPr b="1" sz="660">
+                <a:solidFill>
+                  <a:srgbClr val="166534"/>
+                </a:solidFill>
+                <a:latin typeface="Calibri"/>
+              </a:rPr>
+              <a:t>Mechanism: Digital custody ➔ End-to-end trace &amp; zero toxic burning</a:t>
+            </a:r>
+          </a:p>
+        </p:txBody>
+      </p:sp>
+      <p:sp>
+        <p:nvSpPr>
+          <p:cNvPr id="17418" name="TextBox 17417"/>
+          <p:cNvSpPr txBox="1"/>
+          <p:nvPr/>
+        </p:nvSpPr>
+        <p:spPr>
+          <a:xfrm>
+            <a:off x="548640" y="4352544"/>
+            <a:ext cx="11091672" cy="201168"/>
+          </a:xfrm>
+          <a:prstGeom prst="rect">
+            <a:avLst/>
+          </a:prstGeom>
+          <a:noFill/>
+        </p:spPr>
+        <p:txBody>
+          <a:bodyPr wrap="square" lIns="0" tIns="0">
+            <a:spAutoFit/>
+          </a:bodyPr>
+          <a:lstStyle/>
+          <a:p>
+            <a:pPr algn="l"/>
+            <a:r>
+              <a:rPr b="1" sz="940">
+                <a:solidFill>
+                  <a:srgbClr val="0F172A"/>
+                </a:solidFill>
+                <a:latin typeface="Arial"/>
+              </a:rPr>
+              <a:t>BUSINESS MODEL &amp; FINANCIAL SUSTAINABILITY: </a:t>
+            </a:r>
+            <a:r>
+              <a:rPr b="0" sz="819">
+                <a:solidFill>
+                  <a:srgbClr val="166534"/>
+                </a:solidFill>
+                <a:latin typeface="Arial"/>
+              </a:rPr>
+              <a:t>Self-Reinforcing Commercial Model with Zero Burden on Informal Workers</a:t>
+            </a:r>
+          </a:p>
+        </p:txBody>
+      </p:sp>
+      <p:sp>
+        <p:nvSpPr>
+          <p:cNvPr id="17419" name="Rounded Rectangle 17418"/>
+          <p:cNvSpPr/>
+          <p:nvPr/>
+        </p:nvSpPr>
+        <p:spPr>
+          <a:xfrm>
+            <a:off x="548640" y="4590288"/>
+            <a:ext cx="2679192" cy="1572768"/>
+          </a:xfrm>
+          <a:prstGeom prst="roundRect">
+            <a:avLst/>
+          </a:prstGeom>
+          <a:solidFill>
+            <a:srgbClr val="FFFFFF"/>
+          </a:solidFill>
+          <a:ln w="16510">
+            <a:solidFill>
+              <a:srgbClr val="166534"/>
+            </a:solidFill>
+          </a:ln>
+        </p:spPr>
+        <p:style>
+          <a:lnRef idx="1">
+            <a:schemeClr val="accent1"/>
+          </a:lnRef>
+          <a:fillRef idx="3">
+            <a:schemeClr val="accent1"/>
+          </a:fillRef>
+          <a:effectRef idx="2">
+            <a:schemeClr val="accent1"/>
+          </a:effectRef>
+          <a:fontRef idx="minor">
+            <a:schemeClr val="lt1"/>
+          </a:fontRef>
+        </p:style>
+        <p:txBody>
+          <a:bodyPr rtlCol="0" anchor="t" wrap="square" tIns="73152" bIns="54864"/>
+          <a:lstStyle/>
+          <a:p>
+            <a:pPr algn="l"/>
+            <a:r>
+              <a:rPr b="1" sz="880">
+                <a:solidFill>
+                  <a:srgbClr val="166534"/>
+                </a:solidFill>
+                <a:latin typeface="Calibri"/>
+              </a:rPr>
+              <a:t>1. ZERO-FEE COLLECTORS</a:t>
+            </a:r>
+            <a:r>
+              <a:rPr b="0" sz="700">
+                <a:solidFill>
+                  <a:srgbClr val="64748B"/>
+                </a:solidFill>
+                <a:latin typeface="Calibri"/>
+              </a:rPr>
+              <a:t>  |  Livelihood Maximization</a:t>
+            </a:r>
+          </a:p>
+          <a:p>
+            <a:pPr algn="l">
+              <a:spcBef>
+                <a:spcPts val="200"/>
+              </a:spcBef>
+              <a:spcAft>
+                <a:spcPts val="0"/>
+              </a:spcAft>
             </a:pPr>
             <a:r>
               <a:rPr b="1" sz="700">
@@ -13066,7 +13192,621 @@
                 </a:solidFill>
                 <a:latin typeface="Calibri"/>
               </a:rPr>
-              <a:t>Mechanism: Digital custody ➔ End-to-end trace &amp; zero toxic burning</a:t>
+              <a:t>• </a:t>
+            </a:r>
+            <a:r>
+              <a:rPr b="1" sz="700">
+                <a:solidFill>
+                  <a:srgbClr val="0F172A"/>
+                </a:solidFill>
+                <a:latin typeface="Calibri"/>
+              </a:rPr>
+              <a:t>100% Free Platform Access: </a:t>
+            </a:r>
+            <a:r>
+              <a:rPr b="0" sz="690">
+                <a:solidFill>
+                  <a:srgbClr val="334155"/>
+                </a:solidFill>
+                <a:latin typeface="Calibri"/>
+              </a:rPr>
+              <a:t>Zero registration fees, subscription charges, or hardware lock-in barrier.</a:t>
+            </a:r>
+          </a:p>
+          <a:p>
+            <a:pPr algn="l">
+              <a:spcBef>
+                <a:spcPts val="200"/>
+              </a:spcBef>
+              <a:spcAft>
+                <a:spcPts val="0"/>
+              </a:spcAft>
+            </a:pPr>
+            <a:r>
+              <a:rPr b="1" sz="700">
+                <a:solidFill>
+                  <a:srgbClr val="166534"/>
+                </a:solidFill>
+                <a:latin typeface="Calibri"/>
+              </a:rPr>
+              <a:t>• </a:t>
+            </a:r>
+            <a:r>
+              <a:rPr b="1" sz="700">
+                <a:solidFill>
+                  <a:srgbClr val="0F172A"/>
+                </a:solidFill>
+                <a:latin typeface="Calibri"/>
+              </a:rPr>
+              <a:t>+44.8% Net Income Uplift: </a:t>
+            </a:r>
+            <a:r>
+              <a:rPr b="0" sz="690">
+                <a:solidFill>
+                  <a:srgbClr val="334155"/>
+                </a:solidFill>
+                <a:latin typeface="Calibri"/>
+              </a:rPr>
+              <a:t>Transparent live benchmark floor pricing stops arbitrary middleman discounts.</a:t>
+            </a:r>
+          </a:p>
+          <a:p>
+            <a:pPr algn="l">
+              <a:spcBef>
+                <a:spcPts val="200"/>
+              </a:spcBef>
+              <a:spcAft>
+                <a:spcPts val="0"/>
+              </a:spcAft>
+            </a:pPr>
+            <a:r>
+              <a:rPr b="1" sz="700">
+                <a:solidFill>
+                  <a:srgbClr val="166534"/>
+                </a:solidFill>
+                <a:latin typeface="Calibri"/>
+              </a:rPr>
+              <a:t>• </a:t>
+            </a:r>
+            <a:r>
+              <a:rPr b="1" sz="700">
+                <a:solidFill>
+                  <a:srgbClr val="0F172A"/>
+                </a:solidFill>
+                <a:latin typeface="Calibri"/>
+              </a:rPr>
+              <a:t>Instant Verified Payouts: </a:t>
+            </a:r>
+            <a:r>
+              <a:rPr b="0" sz="690">
+                <a:solidFill>
+                  <a:srgbClr val="334155"/>
+                </a:solidFill>
+                <a:latin typeface="Calibri"/>
+              </a:rPr>
+              <a:t>Immediate Cash / UPI transfers with verifiable digital earnings passbook.</a:t>
+            </a:r>
+          </a:p>
+        </p:txBody>
+      </p:sp>
+      <p:sp>
+        <p:nvSpPr>
+          <p:cNvPr id="17420" name="Rounded Rectangle 17419"/>
+          <p:cNvSpPr/>
+          <p:nvPr/>
+        </p:nvSpPr>
+        <p:spPr>
+          <a:xfrm>
+            <a:off x="3355848" y="4590288"/>
+            <a:ext cx="2679192" cy="1572768"/>
+          </a:xfrm>
+          <a:prstGeom prst="roundRect">
+            <a:avLst/>
+          </a:prstGeom>
+          <a:solidFill>
+            <a:srgbClr val="FFFFFF"/>
+          </a:solidFill>
+          <a:ln w="16510">
+            <a:solidFill>
+              <a:srgbClr val="B45309"/>
+            </a:solidFill>
+          </a:ln>
+        </p:spPr>
+        <p:style>
+          <a:lnRef idx="1">
+            <a:schemeClr val="accent1"/>
+          </a:lnRef>
+          <a:fillRef idx="3">
+            <a:schemeClr val="accent1"/>
+          </a:fillRef>
+          <a:effectRef idx="2">
+            <a:schemeClr val="accent1"/>
+          </a:effectRef>
+          <a:fontRef idx="minor">
+            <a:schemeClr val="lt1"/>
+          </a:fontRef>
+        </p:style>
+        <p:txBody>
+          <a:bodyPr rtlCol="0" anchor="t" wrap="square" tIns="73152" bIns="54864"/>
+          <a:lstStyle/>
+          <a:p>
+            <a:pPr algn="l"/>
+            <a:r>
+              <a:rPr b="1" sz="880">
+                <a:solidFill>
+                  <a:srgbClr val="B45309"/>
+                </a:solidFill>
+                <a:latin typeface="Calibri"/>
+              </a:rPr>
+              <a:t>2. LOCAL AGGREGATORS</a:t>
+            </a:r>
+            <a:r>
+              <a:rPr b="0" sz="700">
+                <a:solidFill>
+                  <a:srgbClr val="64748B"/>
+                </a:solidFill>
+                <a:latin typeface="Calibri"/>
+              </a:rPr>
+              <a:t>  |  Bulk Margins &amp; Conversion</a:t>
+            </a:r>
+          </a:p>
+          <a:p>
+            <a:pPr algn="l">
+              <a:spcBef>
+                <a:spcPts val="200"/>
+              </a:spcBef>
+              <a:spcAft>
+                <a:spcPts val="0"/>
+              </a:spcAft>
+            </a:pPr>
+            <a:r>
+              <a:rPr b="1" sz="700">
+                <a:solidFill>
+                  <a:srgbClr val="B45309"/>
+                </a:solidFill>
+                <a:latin typeface="Calibri"/>
+              </a:rPr>
+              <a:t>• </a:t>
+            </a:r>
+            <a:r>
+              <a:rPr b="1" sz="700">
+                <a:solidFill>
+                  <a:srgbClr val="0F172A"/>
+                </a:solidFill>
+                <a:latin typeface="Calibri"/>
+              </a:rPr>
+              <a:t>4%–6% Handling Margins: </a:t>
+            </a:r>
+            <a:r>
+              <a:rPr b="0" sz="690">
+                <a:solidFill>
+                  <a:srgbClr val="334155"/>
+                </a:solidFill>
+                <a:latin typeface="Calibri"/>
+              </a:rPr>
+              <a:t>Earns legitimate bulk aggregation and pre-sorting commissions on volume.</a:t>
+            </a:r>
+          </a:p>
+          <a:p>
+            <a:pPr algn="l">
+              <a:spcBef>
+                <a:spcPts val="200"/>
+              </a:spcBef>
+              <a:spcAft>
+                <a:spcPts val="0"/>
+              </a:spcAft>
+            </a:pPr>
+            <a:r>
+              <a:rPr b="1" sz="700">
+                <a:solidFill>
+                  <a:srgbClr val="B45309"/>
+                </a:solidFill>
+                <a:latin typeface="Calibri"/>
+              </a:rPr>
+              <a:t>• </a:t>
+            </a:r>
+            <a:r>
+              <a:rPr b="1" sz="700">
+                <a:solidFill>
+                  <a:srgbClr val="0F172A"/>
+                </a:solidFill>
+                <a:latin typeface="Calibri"/>
+              </a:rPr>
+              <a:t>Zero Inventory Risk: </a:t>
+            </a:r>
+            <a:r>
+              <a:rPr b="0" sz="690">
+                <a:solidFill>
+                  <a:srgbClr val="334155"/>
+                </a:solidFill>
+                <a:latin typeface="Calibri"/>
+              </a:rPr>
+              <a:t>Guaranteed recycler off-take contracts eliminate price fluctuation risk.</a:t>
+            </a:r>
+          </a:p>
+          <a:p>
+            <a:pPr algn="l">
+              <a:spcBef>
+                <a:spcPts val="200"/>
+              </a:spcBef>
+              <a:spcAft>
+                <a:spcPts val="0"/>
+              </a:spcAft>
+            </a:pPr>
+            <a:r>
+              <a:rPr b="1" sz="700">
+                <a:solidFill>
+                  <a:srgbClr val="B45309"/>
+                </a:solidFill>
+                <a:latin typeface="Calibri"/>
+              </a:rPr>
+              <a:t>• </a:t>
+            </a:r>
+            <a:r>
+              <a:rPr b="1" sz="700">
+                <a:solidFill>
+                  <a:srgbClr val="0F172A"/>
+                </a:solidFill>
+                <a:latin typeface="Calibri"/>
+              </a:rPr>
+              <a:t>Certified Collection Hubs: </a:t>
+            </a:r>
+            <a:r>
+              <a:rPr b="0" sz="690">
+                <a:solidFill>
+                  <a:srgbClr val="334155"/>
+                </a:solidFill>
+                <a:latin typeface="Calibri"/>
+              </a:rPr>
+              <a:t>Transitions informal scrap yards into compliant, auditable collection centers.</a:t>
+            </a:r>
+          </a:p>
+        </p:txBody>
+      </p:sp>
+      <p:sp>
+        <p:nvSpPr>
+          <p:cNvPr id="17421" name="Rounded Rectangle 17420"/>
+          <p:cNvSpPr/>
+          <p:nvPr/>
+        </p:nvSpPr>
+        <p:spPr>
+          <a:xfrm>
+            <a:off x="6163056" y="4590288"/>
+            <a:ext cx="2679192" cy="1572768"/>
+          </a:xfrm>
+          <a:prstGeom prst="roundRect">
+            <a:avLst/>
+          </a:prstGeom>
+          <a:solidFill>
+            <a:srgbClr val="FFFFFF"/>
+          </a:solidFill>
+          <a:ln w="16510">
+            <a:solidFill>
+              <a:srgbClr val="1E40AF"/>
+            </a:solidFill>
+          </a:ln>
+        </p:spPr>
+        <p:style>
+          <a:lnRef idx="1">
+            <a:schemeClr val="accent1"/>
+          </a:lnRef>
+          <a:fillRef idx="3">
+            <a:schemeClr val="accent1"/>
+          </a:fillRef>
+          <a:effectRef idx="2">
+            <a:schemeClr val="accent1"/>
+          </a:effectRef>
+          <a:fontRef idx="minor">
+            <a:schemeClr val="lt1"/>
+          </a:fontRef>
+        </p:style>
+        <p:txBody>
+          <a:bodyPr rtlCol="0" anchor="t" wrap="square" tIns="73152" bIns="54864"/>
+          <a:lstStyle/>
+          <a:p>
+            <a:pPr algn="l"/>
+            <a:r>
+              <a:rPr b="1" sz="880">
+                <a:solidFill>
+                  <a:srgbClr val="1E40AF"/>
+                </a:solidFill>
+                <a:latin typeface="Calibri"/>
+              </a:rPr>
+              <a:t>3. AUTHORIZED RECYCLERS</a:t>
+            </a:r>
+            <a:r>
+              <a:rPr b="0" sz="700">
+                <a:solidFill>
+                  <a:srgbClr val="64748B"/>
+                </a:solidFill>
+                <a:latin typeface="Calibri"/>
+              </a:rPr>
+              <a:t>  |  Procurement Efficiency</a:t>
+            </a:r>
+          </a:p>
+          <a:p>
+            <a:pPr algn="l">
+              <a:spcBef>
+                <a:spcPts val="200"/>
+              </a:spcBef>
+              <a:spcAft>
+                <a:spcPts val="0"/>
+              </a:spcAft>
+            </a:pPr>
+            <a:r>
+              <a:rPr b="1" sz="700">
+                <a:solidFill>
+                  <a:srgbClr val="1E40AF"/>
+                </a:solidFill>
+                <a:latin typeface="Calibri"/>
+              </a:rPr>
+              <a:t>• </a:t>
+            </a:r>
+            <a:r>
+              <a:rPr b="1" sz="700">
+                <a:solidFill>
+                  <a:srgbClr val="0F172A"/>
+                </a:solidFill>
+                <a:latin typeface="Calibri"/>
+              </a:rPr>
+              <a:t>1.5% Platform Intake Fee: </a:t>
+            </a:r>
+            <a:r>
+              <a:rPr b="0" sz="690">
+                <a:solidFill>
+                  <a:srgbClr val="334155"/>
+                </a:solidFill>
+                <a:latin typeface="Calibri"/>
+              </a:rPr>
+              <a:t>Paid per verified ton intake (vs 5%–10% predatory broker trading margins).</a:t>
+            </a:r>
+          </a:p>
+          <a:p>
+            <a:pPr algn="l">
+              <a:spcBef>
+                <a:spcPts val="200"/>
+              </a:spcBef>
+              <a:spcAft>
+                <a:spcPts val="0"/>
+              </a:spcAft>
+            </a:pPr>
+            <a:r>
+              <a:rPr b="1" sz="700">
+                <a:solidFill>
+                  <a:srgbClr val="1E40AF"/>
+                </a:solidFill>
+                <a:latin typeface="Calibri"/>
+              </a:rPr>
+              <a:t>• </a:t>
+            </a:r>
+            <a:r>
+              <a:rPr b="1" sz="700">
+                <a:solidFill>
+                  <a:srgbClr val="0F172A"/>
+                </a:solidFill>
+                <a:latin typeface="Calibri"/>
+              </a:rPr>
+              <a:t>3.5%–8.5% Net Cost Savings: </a:t>
+            </a:r>
+            <a:r>
+              <a:rPr b="0" sz="690">
+                <a:solidFill>
+                  <a:srgbClr val="334155"/>
+                </a:solidFill>
+                <a:latin typeface="Calibri"/>
+              </a:rPr>
+              <a:t>Pre-segregated, quality-graded material reduces unverified broker impurities.</a:t>
+            </a:r>
+          </a:p>
+          <a:p>
+            <a:pPr algn="l">
+              <a:spcBef>
+                <a:spcPts val="200"/>
+              </a:spcBef>
+              <a:spcAft>
+                <a:spcPts val="0"/>
+              </a:spcAft>
+            </a:pPr>
+            <a:r>
+              <a:rPr b="1" sz="700">
+                <a:solidFill>
+                  <a:srgbClr val="1E40AF"/>
+                </a:solidFill>
+                <a:latin typeface="Calibri"/>
+              </a:rPr>
+              <a:t>• </a:t>
+            </a:r>
+            <a:r>
+              <a:rPr b="1" sz="700">
+                <a:solidFill>
+                  <a:srgbClr val="0F172A"/>
+                </a:solidFill>
+                <a:latin typeface="Calibri"/>
+              </a:rPr>
+              <a:t>Automated Form-6 Audits: </a:t>
+            </a:r>
+            <a:r>
+              <a:rPr b="0" sz="690">
+                <a:solidFill>
+                  <a:srgbClr val="334155"/>
+                </a:solidFill>
+                <a:latin typeface="Calibri"/>
+              </a:rPr>
+              <a:t>Cryptographic chain-of-custody yields tamper-proof EPR credit certificates.</a:t>
+            </a:r>
+          </a:p>
+        </p:txBody>
+      </p:sp>
+      <p:sp>
+        <p:nvSpPr>
+          <p:cNvPr id="17422" name="Rounded Rectangle 17421"/>
+          <p:cNvSpPr/>
+          <p:nvPr/>
+        </p:nvSpPr>
+        <p:spPr>
+          <a:xfrm>
+            <a:off x="8970264" y="4590288"/>
+            <a:ext cx="2679192" cy="1572768"/>
+          </a:xfrm>
+          <a:prstGeom prst="roundRect">
+            <a:avLst/>
+          </a:prstGeom>
+          <a:solidFill>
+            <a:srgbClr val="FFFFFF"/>
+          </a:solidFill>
+          <a:ln w="16510">
+            <a:solidFill>
+              <a:srgbClr val="6D28D9"/>
+            </a:solidFill>
+          </a:ln>
+        </p:spPr>
+        <p:style>
+          <a:lnRef idx="1">
+            <a:schemeClr val="accent1"/>
+          </a:lnRef>
+          <a:fillRef idx="3">
+            <a:schemeClr val="accent1"/>
+          </a:fillRef>
+          <a:effectRef idx="2">
+            <a:schemeClr val="accent1"/>
+          </a:effectRef>
+          <a:fontRef idx="minor">
+            <a:schemeClr val="lt1"/>
+          </a:fontRef>
+        </p:style>
+        <p:txBody>
+          <a:bodyPr rtlCol="0" anchor="t" wrap="square" tIns="73152" bIns="54864"/>
+          <a:lstStyle/>
+          <a:p>
+            <a:pPr algn="l"/>
+            <a:r>
+              <a:rPr b="1" sz="880">
+                <a:solidFill>
+                  <a:srgbClr val="6D28D9"/>
+                </a:solidFill>
+                <a:latin typeface="Calibri"/>
+              </a:rPr>
+              <a:t>4. PLATFORM REVENUE &amp; EPR</a:t>
+            </a:r>
+            <a:r>
+              <a:rPr b="0" sz="700">
+                <a:solidFill>
+                  <a:srgbClr val="64748B"/>
+                </a:solidFill>
+                <a:latin typeface="Calibri"/>
+              </a:rPr>
+              <a:t>  |  Scalable Commercial Model</a:t>
+            </a:r>
+          </a:p>
+          <a:p>
+            <a:pPr algn="l">
+              <a:spcBef>
+                <a:spcPts val="200"/>
+              </a:spcBef>
+              <a:spcAft>
+                <a:spcPts val="0"/>
+              </a:spcAft>
+            </a:pPr>
+            <a:r>
+              <a:rPr b="1" sz="700">
+                <a:solidFill>
+                  <a:srgbClr val="6D28D9"/>
+                </a:solidFill>
+                <a:latin typeface="Calibri"/>
+              </a:rPr>
+              <a:t>• </a:t>
+            </a:r>
+            <a:r>
+              <a:rPr b="1" sz="700">
+                <a:solidFill>
+                  <a:srgbClr val="0F172A"/>
+                </a:solidFill>
+                <a:latin typeface="Calibri"/>
+              </a:rPr>
+              <a:t>Transaction Commission: </a:t>
+            </a:r>
+            <a:r>
+              <a:rPr b="0" sz="690">
+                <a:solidFill>
+                  <a:srgbClr val="334155"/>
+                </a:solidFill>
+                <a:latin typeface="Calibri"/>
+              </a:rPr>
+              <a:t>1.5% fee on verified material transaction volume diverted to formal plants.</a:t>
+            </a:r>
+          </a:p>
+          <a:p>
+            <a:pPr algn="l">
+              <a:spcBef>
+                <a:spcPts val="200"/>
+              </a:spcBef>
+              <a:spcAft>
+                <a:spcPts val="0"/>
+              </a:spcAft>
+            </a:pPr>
+            <a:r>
+              <a:rPr b="1" sz="700">
+                <a:solidFill>
+                  <a:srgbClr val="6D28D9"/>
+                </a:solidFill>
+                <a:latin typeface="Calibri"/>
+              </a:rPr>
+              <a:t>• </a:t>
+            </a:r>
+            <a:r>
+              <a:rPr b="1" sz="700">
+                <a:solidFill>
+                  <a:srgbClr val="0F172A"/>
+                </a:solidFill>
+                <a:latin typeface="Calibri"/>
+              </a:rPr>
+              <a:t>Enterprise EPR SaaS: </a:t>
+            </a:r>
+            <a:r>
+              <a:rPr b="0" sz="690">
+                <a:solidFill>
+                  <a:srgbClr val="334155"/>
+                </a:solidFill>
+                <a:latin typeface="Calibri"/>
+              </a:rPr>
+              <a:t>Annual B2B compliance portal subscription for brand OEMs (HP, Dell, Havells).</a:t>
+            </a:r>
+          </a:p>
+          <a:p>
+            <a:pPr algn="l">
+              <a:spcBef>
+                <a:spcPts val="200"/>
+              </a:spcBef>
+              <a:spcAft>
+                <a:spcPts val="0"/>
+              </a:spcAft>
+            </a:pPr>
+            <a:r>
+              <a:rPr b="1" sz="700">
+                <a:solidFill>
+                  <a:srgbClr val="6D28D9"/>
+                </a:solidFill>
+                <a:latin typeface="Calibri"/>
+              </a:rPr>
+              <a:t>• </a:t>
+            </a:r>
+            <a:r>
+              <a:rPr b="1" sz="700">
+                <a:solidFill>
+                  <a:srgbClr val="0F172A"/>
+                </a:solidFill>
+                <a:latin typeface="Calibri"/>
+              </a:rPr>
+              <a:t>High Growth Defensibility: </a:t>
+            </a:r>
+            <a:r>
+              <a:rPr b="0" sz="690">
+                <a:solidFill>
+                  <a:srgbClr val="334155"/>
+                </a:solidFill>
+                <a:latin typeface="Calibri"/>
+              </a:rPr>
+              <a:t>Direct economic pull: collectors earn +44.8% more, creating natural lock-in.</a:t>
             </a:r>
           </a:p>
         </p:txBody>

</xml_diff>

<commit_message>
Enforce strict SIH template styling, exact pointers, and zero overflow across all slides
</commit_message>
<xml_diff>
--- a/SIH2026_Idea_Presentation_E-Waste_Setu.pptx
+++ b/SIH2026_Idea_Presentation_E-Waste_Setu.pptx
@@ -5548,12 +5548,13 @@
           <a:bodyPr/>
           <a:lstStyle/>
           <a:p>
-            <a:r>
-              <a:rPr b="1" sz="2800" u="none">
+            <a:pPr algn="ctr"/>
+            <a:r>
+              <a:rPr b="1" sz="3800" u="none">
                 <a:solidFill>
                   <a:srgbClr val="1E3A8A"/>
                 </a:solidFill>
-                <a:latin typeface="Calibri"/>
+                <a:latin typeface="Garamond"/>
               </a:rPr>
               <a:t>SMART INDIA HACKATHON 2026</a:t>
             </a:r>
@@ -5604,8 +5605,8 @@
         </p:nvSpPr>
         <p:spPr>
           <a:xfrm>
-            <a:off x="548640" y="777240"/>
-            <a:ext cx="5943600" cy="1051560"/>
+            <a:off x="548640" y="731520"/>
+            <a:ext cx="6583680" cy="1143000"/>
           </a:xfrm>
           <a:prstGeom prst="rect">
             <a:avLst/>
@@ -5619,11 +5620,11 @@
           <a:lstStyle/>
           <a:p>
             <a:r>
-              <a:rPr b="1" sz="2600" u="none">
+              <a:rPr b="1" sz="2800" u="none">
                 <a:solidFill>
                   <a:srgbClr val="166534"/>
                 </a:solidFill>
-                <a:latin typeface="Calibri"/>
+                <a:latin typeface="Times New Roman"/>
               </a:rPr>
               <a:t>E-Waste Setu (ई-कचरा सेतु)</a:t>
             </a:r>
@@ -5631,15 +5632,15 @@
           <a:p>
             <a:pPr>
               <a:spcBef>
-                <a:spcPts val="400"/>
+                <a:spcPts val="300"/>
               </a:spcBef>
             </a:pPr>
             <a:r>
-              <a:rPr b="0" sz="1300" u="none">
+              <a:rPr b="0" sz="1400" u="none">
                 <a:solidFill>
                   <a:srgbClr val="334155"/>
                 </a:solidFill>
-                <a:latin typeface="Calibri"/>
+                <a:latin typeface="Times New Roman"/>
               </a:rPr>
               <a:t>AI-Driven Vernacular Inclusion Platform for Informal Waste Workers</a:t>
             </a:r>
@@ -5648,250 +5649,247 @@
       </p:sp>
       <p:sp>
         <p:nvSpPr>
-          <p:cNvPr id="39" name="Rounded Rectangle 38"/>
-          <p:cNvSpPr/>
+          <p:cNvPr id="39" name="TextBox 38"/>
+          <p:cNvSpPr txBox="1"/>
           <p:nvPr/>
         </p:nvSpPr>
         <p:spPr>
           <a:xfrm>
-            <a:off x="548640" y="1920240"/>
-            <a:ext cx="5943600" cy="4343400"/>
+            <a:off x="457200" y="2011680"/>
+            <a:ext cx="6217920" cy="4389120"/>
           </a:xfrm>
-          <a:prstGeom prst="roundRect">
+          <a:prstGeom prst="rect">
             <a:avLst/>
           </a:prstGeom>
-          <a:solidFill>
-            <a:srgbClr val="FFFFFF"/>
-          </a:solidFill>
-          <a:ln w="19050">
-            <a:solidFill>
-              <a:srgbClr val="166534"/>
-            </a:solidFill>
-          </a:ln>
+          <a:noFill/>
         </p:spPr>
-        <p:style>
-          <a:lnRef idx="1">
-            <a:schemeClr val="accent1"/>
-          </a:lnRef>
-          <a:fillRef idx="3">
-            <a:schemeClr val="accent1"/>
-          </a:fillRef>
-          <a:effectRef idx="2">
-            <a:schemeClr val="accent1"/>
-          </a:effectRef>
-          <a:fontRef idx="minor">
-            <a:schemeClr val="lt1"/>
-          </a:fontRef>
-        </p:style>
-        <p:txBody>
-          <a:bodyPr rtlCol="0" anchor="t" wrap="square" lIns="219456" rIns="182880" tIns="201168" bIns="164592"/>
+        <p:txBody>
+          <a:bodyPr wrap="square" anchor="t" lIns="0" rIns="0" tIns="0" bIns="0">
+            <a:spAutoFit/>
+          </a:bodyPr>
           <a:lstStyle/>
-          <a:p>
-            <a:pPr algn="ctr"/>
-            <a:r>
-              <a:rPr b="1" sz="1350" u="none">
-                <a:solidFill>
-                  <a:srgbClr val="166534"/>
-                </a:solidFill>
-                <a:latin typeface="Calibri"/>
-              </a:rPr>
-              <a:t>PROJECT &amp; TEAM REGISTRATION DETAILS</a:t>
-            </a:r>
-          </a:p>
           <a:p>
             <a:pPr>
               <a:spcBef>
-                <a:spcPts val="800"/>
+                <a:spcPts val="0"/>
               </a:spcBef>
               <a:spcAft>
                 <a:spcPts val="0"/>
               </a:spcAft>
             </a:pPr>
             <a:r>
-              <a:rPr b="1" sz="1300" u="none">
-                <a:solidFill>
-                  <a:srgbClr val="166534"/>
-                </a:solidFill>
-                <a:latin typeface="Calibri"/>
-              </a:rPr>
-              <a:t>• Problem Statement ID: </a:t>
-            </a:r>
-            <a:r>
-              <a:rPr b="1" sz="1300" u="none">
+              <a:rPr b="1" sz="1400" u="none">
                 <a:solidFill>
                   <a:srgbClr val="0F172A"/>
                 </a:solidFill>
-                <a:latin typeface="Calibri"/>
-              </a:rPr>
-              <a:t>26229</a:t>
+                <a:latin typeface="Arial"/>
+              </a:rPr>
+              <a:t>• Problem Statement ID –</a:t>
+            </a:r>
+            <a:r>
+              <a:rPr b="1" sz="1350" u="none">
+                <a:solidFill>
+                  <a:srgbClr val="0F172A"/>
+                </a:solidFill>
+                <a:latin typeface="Arial"/>
+              </a:rPr>
+              <a:t> 26229</a:t>
             </a:r>
           </a:p>
           <a:p>
             <a:pPr>
               <a:spcBef>
-                <a:spcPts val="800"/>
+                <a:spcPts val="1000"/>
               </a:spcBef>
               <a:spcAft>
                 <a:spcPts val="0"/>
               </a:spcAft>
             </a:pPr>
             <a:r>
-              <a:rPr b="1" sz="1300" u="none">
-                <a:solidFill>
-                  <a:srgbClr val="166534"/>
-                </a:solidFill>
-                <a:latin typeface="Calibri"/>
-              </a:rPr>
-              <a:t>• Problem Statement Title: </a:t>
-            </a:r>
-            <a:r>
-              <a:rPr b="0" sz="1300" u="none">
+              <a:rPr b="1" sz="1400" u="none">
                 <a:solidFill>
                   <a:srgbClr val="0F172A"/>
                 </a:solidFill>
-                <a:latin typeface="Calibri"/>
-              </a:rPr>
-              <a:t>Kabadiwala Connect – Bringing Informal Collectors to Formal Recycling</a:t>
+                <a:latin typeface="Arial"/>
+              </a:rPr>
+              <a:t>• Problem Statement Title -</a:t>
+            </a:r>
+            <a:r>
+              <a:rPr b="0" sz="1350" u="none">
+                <a:solidFill>
+                  <a:srgbClr val="0F172A"/>
+                </a:solidFill>
+                <a:latin typeface="Arial"/>
+              </a:rPr>
+              <a:t> Kabadiwala Connect – Bringing Informal Collectors to Formal Recycling</a:t>
             </a:r>
           </a:p>
           <a:p>
             <a:pPr>
               <a:spcBef>
-                <a:spcPts val="800"/>
+                <a:spcPts val="1000"/>
               </a:spcBef>
               <a:spcAft>
                 <a:spcPts val="0"/>
               </a:spcAft>
             </a:pPr>
             <a:r>
-              <a:rPr b="1" sz="1300" u="none">
-                <a:solidFill>
-                  <a:srgbClr val="166534"/>
-                </a:solidFill>
-                <a:latin typeface="Calibri"/>
-              </a:rPr>
-              <a:t>• Ministry / Nodal Body: </a:t>
-            </a:r>
-            <a:r>
-              <a:rPr b="0" sz="1300" u="none">
+              <a:rPr b="1" sz="1400" u="none">
                 <a:solidFill>
                   <a:srgbClr val="0F172A"/>
                 </a:solidFill>
-                <a:latin typeface="Calibri"/>
-              </a:rPr>
-              <a:t>Ministry of Mines (MoM) / JNARDDC</a:t>
+                <a:latin typeface="Arial"/>
+              </a:rPr>
+              <a:t>• Theme -</a:t>
+            </a:r>
+            <a:r>
+              <a:rPr b="0" sz="1350" u="none">
+                <a:solidFill>
+                  <a:srgbClr val="0F172A"/>
+                </a:solidFill>
+                <a:latin typeface="Arial"/>
+              </a:rPr>
+              <a:t> Clean &amp; Green Technology / Circular Economy</a:t>
             </a:r>
           </a:p>
           <a:p>
             <a:pPr>
               <a:spcBef>
-                <a:spcPts val="800"/>
+                <a:spcPts val="1000"/>
               </a:spcBef>
               <a:spcAft>
                 <a:spcPts val="0"/>
               </a:spcAft>
             </a:pPr>
             <a:r>
-              <a:rPr b="1" sz="1300" u="none">
-                <a:solidFill>
-                  <a:srgbClr val="166534"/>
-                </a:solidFill>
-                <a:latin typeface="Calibri"/>
-              </a:rPr>
-              <a:t>• Theme &amp; PS Category: </a:t>
-            </a:r>
-            <a:r>
-              <a:rPr b="0" sz="1300" u="none">
+              <a:rPr b="1" sz="1400" u="none">
                 <a:solidFill>
                   <a:srgbClr val="0F172A"/>
                 </a:solidFill>
-                <a:latin typeface="Calibri"/>
-              </a:rPr>
-              <a:t>Clean &amp; Green Technology / Circular Economy  |  Software</a:t>
+                <a:latin typeface="Arial"/>
+              </a:rPr>
+              <a:t>• PS Category -</a:t>
+            </a:r>
+            <a:r>
+              <a:rPr b="0" sz="1350" u="none">
+                <a:solidFill>
+                  <a:srgbClr val="0F172A"/>
+                </a:solidFill>
+                <a:latin typeface="Arial"/>
+              </a:rPr>
+              <a:t> Software</a:t>
             </a:r>
           </a:p>
           <a:p>
             <a:pPr>
               <a:spcBef>
-                <a:spcPts val="800"/>
+                <a:spcPts val="1000"/>
               </a:spcBef>
               <a:spcAft>
                 <a:spcPts val="0"/>
               </a:spcAft>
             </a:pPr>
             <a:r>
-              <a:rPr b="1" sz="1300" u="none">
-                <a:solidFill>
-                  <a:srgbClr val="166534"/>
-                </a:solidFill>
-                <a:latin typeface="Calibri"/>
-              </a:rPr>
-              <a:t>• Team Name &amp; ID: </a:t>
-            </a:r>
-            <a:r>
-              <a:rPr b="1" sz="1300" u="none">
+              <a:rPr b="1" sz="1400" u="none">
                 <a:solidFill>
                   <a:srgbClr val="0F172A"/>
                 </a:solidFill>
-                <a:latin typeface="Calibri"/>
-              </a:rPr>
-              <a:t>HelloWorldWarriors  |  Team ID: 170413</a:t>
+                <a:latin typeface="Arial"/>
+              </a:rPr>
+              <a:t>• Team ID -</a:t>
+            </a:r>
+            <a:r>
+              <a:rPr b="0" sz="1350" u="none">
+                <a:solidFill>
+                  <a:srgbClr val="0F172A"/>
+                </a:solidFill>
+                <a:latin typeface="Arial"/>
+              </a:rPr>
+              <a:t> 170413</a:t>
             </a:r>
           </a:p>
           <a:p>
             <a:pPr>
               <a:spcBef>
-                <a:spcPts val="800"/>
+                <a:spcPts val="1000"/>
               </a:spcBef>
               <a:spcAft>
                 <a:spcPts val="0"/>
               </a:spcAft>
             </a:pPr>
             <a:r>
-              <a:rPr b="1" sz="1300" u="none">
-                <a:solidFill>
-                  <a:srgbClr val="166534"/>
-                </a:solidFill>
-                <a:latin typeface="Calibri"/>
-              </a:rPr>
-              <a:t>• Team Leader: </a:t>
-            </a:r>
-            <a:r>
-              <a:rPr b="0" sz="1300" u="none">
+              <a:rPr b="1" sz="1400" u="none">
                 <a:solidFill>
                   <a:srgbClr val="0F172A"/>
                 </a:solidFill>
-                <a:latin typeface="Calibri"/>
-              </a:rPr>
-              <a:t>Satya Prakash (Registered on Portal)</a:t>
+                <a:latin typeface="Arial"/>
+              </a:rPr>
+              <a:t>• Team Name (Registered on portal) -</a:t>
+            </a:r>
+            <a:r>
+              <a:rPr b="1" sz="1350" u="none">
+                <a:solidFill>
+                  <a:srgbClr val="0F172A"/>
+                </a:solidFill>
+                <a:latin typeface="Arial"/>
+              </a:rPr>
+              <a:t> HelloWorldWarriors</a:t>
             </a:r>
           </a:p>
           <a:p>
             <a:pPr>
               <a:spcBef>
-                <a:spcPts val="800"/>
+                <a:spcPts val="1000"/>
               </a:spcBef>
               <a:spcAft>
                 <a:spcPts val="0"/>
               </a:spcAft>
             </a:pPr>
             <a:r>
-              <a:rPr b="1" sz="1300" u="none">
-                <a:solidFill>
-                  <a:srgbClr val="166534"/>
-                </a:solidFill>
-                <a:latin typeface="Calibri"/>
-              </a:rPr>
-              <a:t>• Live Prototype App: </a:t>
-            </a:r>
-            <a:r>
-              <a:rPr b="0" sz="1300" u="none">
+              <a:rPr b="1" sz="1400" u="none">
                 <a:solidFill>
                   <a:srgbClr val="0F172A"/>
                 </a:solidFill>
-                <a:latin typeface="Calibri"/>
-              </a:rPr>
-              <a:t>https://recysaathi.vercel.app</a:t>
+                <a:latin typeface="Arial"/>
+              </a:rPr>
+              <a:t>• Team Leader -</a:t>
+            </a:r>
+            <a:r>
+              <a:rPr b="0" sz="1350" u="none">
+                <a:solidFill>
+                  <a:srgbClr val="0F172A"/>
+                </a:solidFill>
+                <a:latin typeface="Arial"/>
+              </a:rPr>
+              <a:t> Satya Prakash</a:t>
+            </a:r>
+          </a:p>
+          <a:p>
+            <a:pPr>
+              <a:spcBef>
+                <a:spcPts val="1000"/>
+              </a:spcBef>
+              <a:spcAft>
+                <a:spcPts val="0"/>
+              </a:spcAft>
+            </a:pPr>
+            <a:r>
+              <a:rPr b="1" sz="1400" u="none">
+                <a:solidFill>
+                  <a:srgbClr val="0F172A"/>
+                </a:solidFill>
+                <a:latin typeface="Arial"/>
+              </a:rPr>
+              <a:t>• Prototype Web App -</a:t>
+            </a:r>
+            <a:r>
+              <a:rPr b="0" sz="1350" u="none">
+                <a:solidFill>
+                  <a:srgbClr val="0F172A"/>
+                </a:solidFill>
+                <a:latin typeface="Arial"/>
+              </a:rPr>
+              <a:t> https://recysaathi.vercel.app</a:t>
             </a:r>
           </a:p>
         </p:txBody>
@@ -5999,13 +5997,13 @@
           <a:bodyPr/>
           <a:lstStyle/>
           <a:p>
-            <a:pPr eaLnBrk="1" hangingPunct="1"/>
-            <a:r>
-              <a:rPr b="1" sz="2800" u="none">
+            <a:pPr eaLnBrk="1" hangingPunct="1" algn="ctr"/>
+            <a:r>
+              <a:rPr b="1" sz="3400" u="none">
                 <a:solidFill>
                   <a:srgbClr val="0F172A"/>
                 </a:solidFill>
-                <a:latin typeface="Calibri"/>
+                <a:latin typeface="Times New Roman"/>
               </a:rPr>
               <a:t>IDEA TITLE: E-Waste Setu (ई-कचरा सेतु)</a:t>
             </a:r>
@@ -6122,18 +6120,19 @@
           </a:fontRef>
         </p:style>
         <p:txBody>
-          <a:bodyPr rtlCol="0" anchor="ctr" wrap="square"/>
+          <a:bodyPr rtlCol="0" anchor="ctr" wrap="square" lIns="18288" rIns="18288" tIns="109728" bIns="36576"/>
           <a:lstStyle/>
           <a:p>
             <a:pPr algn="ctr"/>
             <a:r>
-              <a:rPr b="1" sz="1100" u="none">
+              <a:rPr b="1" sz="1050" u="none">
                 <a:solidFill>
                   <a:srgbClr val="0F172A"/>
                 </a:solidFill>
-                <a:latin typeface="Calibri"/>
-              </a:rPr>
-              <a:t>HelloWorldWarriors</a:t>
+                <a:latin typeface="Arial"/>
+              </a:rPr>
+              <a:t>HelloWorld
+Warriors</a:t>
             </a:r>
             <a:endParaRPr lang="en-IN" dirty="0"/>
           </a:p>
@@ -6177,8 +6176,8 @@
         </p:nvSpPr>
         <p:spPr>
           <a:xfrm>
-            <a:off x="548640" y="987552"/>
-            <a:ext cx="11091672" cy="274320"/>
+            <a:off x="548640" y="969264"/>
+            <a:ext cx="11091672" cy="256032"/>
           </a:xfrm>
           <a:prstGeom prst="rect">
             <a:avLst/>
@@ -6196,12 +6195,12 @@
                 <a:solidFill>
                   <a:srgbClr val="0F172A"/>
                 </a:solidFill>
-                <a:latin typeface="Calibri"/>
+                <a:latin typeface="Times New Roman"/>
               </a:rPr>
               <a:t>Core Formal Supply Chain: </a:t>
             </a:r>
             <a:r>
-              <a:rPr b="0" sz="1200" u="none">
+              <a:rPr b="0" sz="1250" u="none">
                 <a:solidFill>
                   <a:srgbClr val="166534"/>
                 </a:solidFill>
@@ -6220,8 +6219,8 @@
         </p:nvSpPr>
         <p:spPr>
           <a:xfrm>
-            <a:off x="548640" y="1298448"/>
-            <a:ext cx="5413248" cy="2286000"/>
+            <a:off x="548640" y="1261872"/>
+            <a:ext cx="5413248" cy="2331720"/>
           </a:xfrm>
           <a:prstGeom prst="roundRect">
             <a:avLst/>
@@ -6255,13 +6254,22 @@
           <a:p>
             <a:pPr algn="ctr"/>
             <a:r>
-              <a:rPr b="1" sz="1400" u="none">
+              <a:rPr b="1" sz="1350" u="none">
                 <a:solidFill>
                   <a:srgbClr val="B91C1C"/>
                 </a:solidFill>
-                <a:latin typeface="Calibri"/>
-              </a:rPr>
-              <a:t>GROUND PROBLEMS &amp; SYSTEMIC FAILURES</a:t>
+                <a:latin typeface="Times New Roman"/>
+              </a:rPr>
+              <a:t>HOW IT ADDRESSES THE PROBLEM</a:t>
+            </a:r>
+            <a:r>
+              <a:rPr b="0" sz="1150" u="none">
+                <a:solidFill>
+                  <a:srgbClr val="64748B"/>
+                </a:solidFill>
+                <a:latin typeface="Calibri"/>
+              </a:rPr>
+              <a:t>  |  Ground Failures Solved</a:t>
             </a:r>
           </a:p>
           <a:p>
@@ -6280,7 +6288,7 @@
                 </a:solidFill>
                 <a:latin typeface="Calibri"/>
               </a:rPr>
-              <a:t>• 25%–40% Price Skimming: </a:t>
+              <a:t>• 25%–40% Middleman Price Skimming: </a:t>
             </a:r>
             <a:r>
               <a:rPr b="0" sz="1200" u="none">
@@ -6289,7 +6297,7 @@
                 </a:solidFill>
                 <a:latin typeface="Calibri"/>
               </a:rPr>
-              <a:t>Unregulated middlemen eyeball high-value PCBs as mixed scrap, pocketing metal value.</a:t>
+              <a:t>Eliminated via live transparent LME benchmark floor rates.</a:t>
             </a:r>
           </a:p>
           <a:p>
@@ -6308,7 +6316,7 @@
                 </a:solidFill>
                 <a:latin typeface="Calibri"/>
               </a:rPr>
-              <a:t>• Physical Scale Tampering: </a:t>
+              <a:t>• Physical Scale Tampering (10%–15% loss): </a:t>
             </a:r>
             <a:r>
               <a:rPr b="0" sz="1200" u="none">
@@ -6317,7 +6325,7 @@
                 </a:solidFill>
                 <a:latin typeface="Calibri"/>
               </a:rPr>
-              <a:t>Mechanical spring scales routinely discount weight by 10%–15% at informal scrap yards.</a:t>
+              <a:t>Halted via smartphone camera scale OCR proof bound to lot ID.</a:t>
             </a:r>
           </a:p>
           <a:p>
@@ -6336,7 +6344,7 @@
                 </a:solidFill>
                 <a:latin typeface="Calibri"/>
               </a:rPr>
-              <a:t>• Backyard Acid Smelting: </a:t>
+              <a:t>• Backyard Toxic Acid Smelting: </a:t>
             </a:r>
             <a:r>
               <a:rPr b="0" sz="1200" u="none">
@@ -6345,7 +6353,7 @@
                 </a:solidFill>
                 <a:latin typeface="Calibri"/>
               </a:rPr>
-              <a:t>Fragmented informal chains burn wires in open slums, causing severe toxic lead &amp; dioxin poisoning.</a:t>
+              <a:t>Diverts toxic PCBs into certified formal hydrometallurgical refiners.</a:t>
             </a:r>
           </a:p>
           <a:p>
@@ -6364,7 +6372,7 @@
                 </a:solidFill>
                 <a:latin typeface="Calibri"/>
               </a:rPr>
-              <a:t>• Extreme Digital Friction: </a:t>
+              <a:t>• Extreme Digital Illiteracy: </a:t>
             </a:r>
             <a:r>
               <a:rPr b="0" sz="1200" u="none">
@@ -6373,7 +6381,7 @@
                 </a:solidFill>
                 <a:latin typeface="Calibri"/>
               </a:rPr>
-              <a:t>Text-heavy English apps fail; collectors require vernacular voice guidance &amp; visual touch UI.</a:t>
+              <a:t>Overcomes reading barriers with 10+ Indic voice models &amp; visual touch UI.</a:t>
             </a:r>
           </a:p>
         </p:txBody>
@@ -6386,8 +6394,8 @@
         </p:nvSpPr>
         <p:spPr>
           <a:xfrm>
-            <a:off x="6108192" y="1298448"/>
-            <a:ext cx="5532120" cy="2286000"/>
+            <a:off x="6108192" y="1261872"/>
+            <a:ext cx="5532120" cy="2331720"/>
           </a:xfrm>
           <a:prstGeom prst="roundRect">
             <a:avLst/>
@@ -6421,13 +6429,13 @@
           <a:p>
             <a:pPr algn="ctr"/>
             <a:r>
-              <a:rPr b="1" sz="1400" u="none">
+              <a:rPr b="1" sz="1350" u="none">
                 <a:solidFill>
                   <a:srgbClr val="166534"/>
                 </a:solidFill>
-                <a:latin typeface="Calibri"/>
-              </a:rPr>
-              <a:t>PROPOSED SOLUTION &amp; END-TO-END FLOW</a:t>
+                <a:latin typeface="Times New Roman"/>
+              </a:rPr>
+              <a:t>PROPOSED SOLUTION (Idea / Solution / Prototype)</a:t>
             </a:r>
           </a:p>
           <a:p>
@@ -6455,7 +6463,7 @@
                 </a:solidFill>
                 <a:latin typeface="Calibri"/>
               </a:rPr>
-              <a:t>Collector snaps photo; on-device AI tags scrap category and displays live floor rates.</a:t>
+              <a:t>Snaps scrap photo; AI tags category &amp; displays live floor prices.</a:t>
             </a:r>
           </a:p>
           <a:p>
@@ -6474,7 +6482,7 @@
                 </a:solidFill>
                 <a:latin typeface="Calibri"/>
               </a:rPr>
-              <a:t>2. Digital Scale Capture: </a:t>
+              <a:t>2. Scale OCR Capture: </a:t>
             </a:r>
             <a:r>
               <a:rPr b="0" sz="1200" u="none">
@@ -6483,7 +6491,7 @@
                 </a:solidFill>
                 <a:latin typeface="Calibri"/>
               </a:rPr>
-              <a:t>Phone camera extracts scale display readout via OCR, binding weight proof to lot ID.</a:t>
+              <a:t>Phone camera extracts scale digits, binding photo proof to lot ID.</a:t>
             </a:r>
           </a:p>
           <a:p>
@@ -6511,7 +6519,7 @@
                 </a:solidFill>
                 <a:latin typeface="Calibri"/>
               </a:rPr>
-              <a:t>Aggregator scans lot; verifies weight &amp; pays instant Cash or UPI with digital receipt.</a:t>
+              <a:t>Aggregator scans lot; verifies weight &amp; pays instant UPI/Cash.</a:t>
             </a:r>
           </a:p>
           <a:p>
@@ -6530,7 +6538,7 @@
                 </a:solidFill>
                 <a:latin typeface="Calibri"/>
               </a:rPr>
-              <a:t>4. Bulk Consolidation: </a:t>
+              <a:t>4. Bulk Milk-Run: </a:t>
             </a:r>
             <a:r>
               <a:rPr b="0" sz="1200" u="none">
@@ -6539,7 +6547,7 @@
                 </a:solidFill>
                 <a:latin typeface="Calibri"/>
               </a:rPr>
-              <a:t>Hub aggregates small lots into 1-ton bulk batches; scheduled milk-run truck dispatch.</a:t>
+              <a:t>Consolidates small lots into 1-ton batches with truck dispatch.</a:t>
             </a:r>
           </a:p>
           <a:p>
@@ -6567,7 +6575,7 @@
                 </a:solidFill>
                 <a:latin typeface="Calibri"/>
               </a:rPr>
-              <a:t>Authorized recycler confirms QR custody; auto-generates verified CPCB Form-6 manifest.</a:t>
+              <a:t>Authorized recycler confirms QR; auto-generates CPCB Form-6.</a:t>
             </a:r>
           </a:p>
         </p:txBody>
@@ -6580,8 +6588,8 @@
         </p:nvSpPr>
         <p:spPr>
           <a:xfrm>
-            <a:off x="548640" y="3694176"/>
-            <a:ext cx="11091672" cy="219456"/>
+            <a:off x="548640" y="3675887"/>
+            <a:ext cx="11091672" cy="237744"/>
           </a:xfrm>
           <a:prstGeom prst="rect">
             <a:avLst/>
@@ -6595,13 +6603,13 @@
           <a:lstStyle/>
           <a:p>
             <a:r>
-              <a:rPr b="1" sz="1300" u="none">
+              <a:rPr b="1" sz="1350" u="none">
                 <a:solidFill>
                   <a:srgbClr val="0F172A"/>
                 </a:solidFill>
-                <a:latin typeface="Calibri"/>
-              </a:rPr>
-              <a:t>INNOVATION &amp; CORE UNIQUENESS OF THE SOLUTION: </a:t>
+                <a:latin typeface="Times New Roman"/>
+              </a:rPr>
+              <a:t>INNOVATION AND UNIQUENESS OF THE SOLUTION: </a:t>
             </a:r>
             <a:r>
               <a:rPr b="0" sz="1200" u="none">
@@ -6623,8 +6631,8 @@
         </p:nvSpPr>
         <p:spPr>
           <a:xfrm>
-            <a:off x="548640" y="3968496"/>
-            <a:ext cx="2679192" cy="2322576"/>
+            <a:off x="548640" y="3950208"/>
+            <a:ext cx="2679192" cy="2286000"/>
           </a:xfrm>
           <a:prstGeom prst="roundRect">
             <a:avLst/>
@@ -6668,11 +6676,11 @@
 </a:t>
             </a:r>
             <a:r>
-              <a:rPr b="1" sz="1350" u="none">
+              <a:rPr b="1" sz="1300" u="none">
                 <a:solidFill>
                   <a:srgbClr val="0F172A"/>
                 </a:solidFill>
-                <a:latin typeface="Calibri"/>
+                <a:latin typeface="Times New Roman"/>
               </a:rPr>
               <a:t>Local Aggregator Hubs</a:t>
             </a:r>
@@ -6743,8 +6751,8 @@
         </p:nvSpPr>
         <p:spPr>
           <a:xfrm>
-            <a:off x="3355848" y="3968496"/>
-            <a:ext cx="2679192" cy="2322576"/>
+            <a:off x="3355848" y="3950208"/>
+            <a:ext cx="2679192" cy="2286000"/>
           </a:xfrm>
           <a:prstGeom prst="roundRect">
             <a:avLst/>
@@ -6788,11 +6796,11 @@
 </a:t>
             </a:r>
             <a:r>
-              <a:rPr b="1" sz="1350" u="none">
+              <a:rPr b="1" sz="1300" u="none">
                 <a:solidFill>
                   <a:srgbClr val="0F172A"/>
                 </a:solidFill>
-                <a:latin typeface="Calibri"/>
+                <a:latin typeface="Times New Roman"/>
               </a:rPr>
               <a:t>Camera Scale OCR</a:t>
             </a:r>
@@ -6863,8 +6871,8 @@
         </p:nvSpPr>
         <p:spPr>
           <a:xfrm>
-            <a:off x="6163056" y="3968496"/>
-            <a:ext cx="2679192" cy="2322576"/>
+            <a:off x="6163056" y="3950208"/>
+            <a:ext cx="2679192" cy="2286000"/>
           </a:xfrm>
           <a:prstGeom prst="roundRect">
             <a:avLst/>
@@ -6908,11 +6916,11 @@
 </a:t>
             </a:r>
             <a:r>
-              <a:rPr b="1" sz="1350" u="none">
+              <a:rPr b="1" sz="1300" u="none">
                 <a:solidFill>
                   <a:srgbClr val="0F172A"/>
                 </a:solidFill>
-                <a:latin typeface="Calibri"/>
+                <a:latin typeface="Times New Roman"/>
               </a:rPr>
               <a:t>Multimodal Vernacular AI</a:t>
             </a:r>
@@ -6983,8 +6991,8 @@
         </p:nvSpPr>
         <p:spPr>
           <a:xfrm>
-            <a:off x="8970264" y="3968496"/>
-            <a:ext cx="2679192" cy="2322576"/>
+            <a:off x="8970264" y="3950208"/>
+            <a:ext cx="2679192" cy="2286000"/>
           </a:xfrm>
           <a:prstGeom prst="roundRect">
             <a:avLst/>
@@ -7028,11 +7036,11 @@
 </a:t>
             </a:r>
             <a:r>
-              <a:rPr b="1" sz="1350" u="none">
+              <a:rPr b="1" sz="1300" u="none">
                 <a:solidFill>
                   <a:srgbClr val="0F172A"/>
                 </a:solidFill>
-                <a:latin typeface="Calibri"/>
+                <a:latin typeface="Times New Roman"/>
               </a:rPr>
               <a:t>Verifiable Chain of Custody</a:t>
             </a:r>
@@ -7199,13 +7207,13 @@
           <a:bodyPr/>
           <a:lstStyle/>
           <a:p>
-            <a:pPr eaLnBrk="1" hangingPunct="1"/>
-            <a:r>
-              <a:rPr b="1" sz="2800" u="none">
+            <a:pPr eaLnBrk="1" hangingPunct="1" algn="ctr"/>
+            <a:r>
+              <a:rPr b="1" sz="3400" u="none">
                 <a:solidFill>
                   <a:srgbClr val="0F172A"/>
                 </a:solidFill>
-                <a:latin typeface="Calibri"/>
+                <a:latin typeface="Times New Roman"/>
               </a:rPr>
               <a:t>TECHNICAL APPROACH</a:t>
             </a:r>
@@ -7322,18 +7330,19 @@
           </a:fontRef>
         </p:style>
         <p:txBody>
-          <a:bodyPr rtlCol="0" anchor="ctr" wrap="square"/>
+          <a:bodyPr rtlCol="0" anchor="ctr" wrap="square" lIns="18288" rIns="18288" tIns="109728" bIns="36576"/>
           <a:lstStyle/>
           <a:p>
             <a:pPr algn="ctr"/>
             <a:r>
-              <a:rPr b="1" sz="1100" u="none">
+              <a:rPr b="1" sz="1050" u="none">
                 <a:solidFill>
                   <a:srgbClr val="0F172A"/>
                 </a:solidFill>
-                <a:latin typeface="Calibri"/>
-              </a:rPr>
-              <a:t>HelloWorldWarriors</a:t>
+                <a:latin typeface="Arial"/>
+              </a:rPr>
+              <a:t>HelloWorld
+Warriors</a:t>
             </a:r>
             <a:endParaRPr lang="en-IN" dirty="0"/>
           </a:p>
@@ -7377,8 +7386,8 @@
         </p:nvSpPr>
         <p:spPr>
           <a:xfrm>
-            <a:off x="548640" y="987552"/>
-            <a:ext cx="11091672" cy="274320"/>
+            <a:off x="548640" y="969264"/>
+            <a:ext cx="11091672" cy="256032"/>
           </a:xfrm>
           <a:prstGeom prst="rect">
             <a:avLst/>
@@ -7396,12 +7405,12 @@
                 <a:solidFill>
                   <a:srgbClr val="0F172A"/>
                 </a:solidFill>
-                <a:latin typeface="Calibri"/>
-              </a:rPr>
-              <a:t>End-to-End System Pipeline &amp; Technology Architecture: </a:t>
-            </a:r>
-            <a:r>
-              <a:rPr b="0" sz="1200" u="none">
+                <a:latin typeface="Times New Roman"/>
+              </a:rPr>
+              <a:t>System Architecture &amp; Implementation Pipeline: </a:t>
+            </a:r>
+            <a:r>
+              <a:rPr b="0" sz="1250" u="none">
                 <a:solidFill>
                   <a:srgbClr val="166534"/>
                 </a:solidFill>
@@ -7420,7 +7429,7 @@
         </p:nvSpPr>
         <p:spPr>
           <a:xfrm>
-            <a:off x="548640" y="1298448"/>
+            <a:off x="548640" y="1261872"/>
             <a:ext cx="4892040" cy="2423160"/>
           </a:xfrm>
           <a:prstGeom prst="roundRect">
@@ -7455,13 +7464,13 @@
           <a:p>
             <a:pPr algn="ctr"/>
             <a:r>
-              <a:rPr b="1" sz="1400" u="none">
+              <a:rPr b="1" sz="1350" u="none">
                 <a:solidFill>
                   <a:srgbClr val="166534"/>
                 </a:solidFill>
-                <a:latin typeface="Calibri"/>
-              </a:rPr>
-              <a:t>PRODUCTION TECH STACK ARCHITECTURE</a:t>
+                <a:latin typeface="Times New Roman"/>
+              </a:rPr>
+              <a:t>TECHNOLOGIES TO BE USED: System Stack</a:t>
             </a:r>
           </a:p>
           <a:p>
@@ -7586,7 +7595,7 @@
         </p:nvSpPr>
         <p:spPr>
           <a:xfrm>
-            <a:off x="548640" y="3840480"/>
+            <a:off x="548640" y="3803904"/>
             <a:ext cx="4892040" cy="2450592"/>
           </a:xfrm>
           <a:prstGeom prst="roundRect">
@@ -7621,13 +7630,13 @@
           <a:p>
             <a:pPr algn="ctr"/>
             <a:r>
-              <a:rPr b="1" sz="1400" u="none">
+              <a:rPr b="1" sz="1350" u="none">
                 <a:solidFill>
                   <a:srgbClr val="0284C7"/>
                 </a:solidFill>
-                <a:latin typeface="Calibri"/>
-              </a:rPr>
-              <a:t>AI &amp; PLATFORM INTELLIGENCE ENGINES</a:t>
+                <a:latin typeface="Times New Roman"/>
+              </a:rPr>
+              <a:t>TECHNOLOGIES TO BE USED: AI &amp; ML Engines</a:t>
             </a:r>
           </a:p>
           <a:p>
@@ -7752,8 +7761,8 @@
         </p:nvSpPr>
         <p:spPr>
           <a:xfrm>
-            <a:off x="5623560" y="1298448"/>
-            <a:ext cx="6016752" cy="219456"/>
+            <a:off x="5623560" y="1261872"/>
+            <a:ext cx="6016752" cy="237744"/>
           </a:xfrm>
           <a:prstGeom prst="rect">
             <a:avLst/>
@@ -7771,9 +7780,9 @@
                 <a:solidFill>
                   <a:srgbClr val="0F172A"/>
                 </a:solidFill>
-                <a:latin typeface="Calibri"/>
-              </a:rPr>
-              <a:t>OPERATIONAL LIFECYCLE: 5-STEP VISUAL PROCESSING PIPELINE</a:t>
+                <a:latin typeface="Times New Roman"/>
+              </a:rPr>
+              <a:t>METHODOLOGY AND PROCESS FOR IMPLEMENTATION</a:t>
             </a:r>
           </a:p>
         </p:txBody>
@@ -7786,7 +7795,7 @@
         </p:nvSpPr>
         <p:spPr>
           <a:xfrm>
-            <a:off x="5623560" y="1554480"/>
+            <a:off x="5623560" y="1536192"/>
             <a:ext cx="6016752" cy="749808"/>
           </a:xfrm>
           <a:prstGeom prst="roundRect">
@@ -7856,7 +7865,7 @@
         </p:nvSpPr>
         <p:spPr>
           <a:xfrm>
-            <a:off x="5623560" y="2377440"/>
+            <a:off x="5623560" y="2359152"/>
             <a:ext cx="6016752" cy="749808"/>
           </a:xfrm>
           <a:prstGeom prst="roundRect">
@@ -7926,7 +7935,7 @@
         </p:nvSpPr>
         <p:spPr>
           <a:xfrm>
-            <a:off x="5623560" y="3200400"/>
+            <a:off x="5623560" y="3182112"/>
             <a:ext cx="6016752" cy="749808"/>
           </a:xfrm>
           <a:prstGeom prst="roundRect">
@@ -7996,7 +8005,7 @@
         </p:nvSpPr>
         <p:spPr>
           <a:xfrm>
-            <a:off x="5623560" y="4023360"/>
+            <a:off x="5623560" y="4005072"/>
             <a:ext cx="6016752" cy="749808"/>
           </a:xfrm>
           <a:prstGeom prst="roundRect">
@@ -8066,7 +8075,7 @@
         </p:nvSpPr>
         <p:spPr>
           <a:xfrm>
-            <a:off x="5623560" y="4846320"/>
+            <a:off x="5623560" y="4828032"/>
             <a:ext cx="6016752" cy="749808"/>
           </a:xfrm>
           <a:prstGeom prst="roundRect">
@@ -8136,7 +8145,7 @@
         </p:nvSpPr>
         <p:spPr>
           <a:xfrm>
-            <a:off x="5623560" y="5705856"/>
+            <a:off x="5623560" y="5687568"/>
             <a:ext cx="6016752" cy="530352"/>
           </a:xfrm>
           <a:prstGeom prst="roundRect">
@@ -8310,13 +8319,13 @@
           <a:bodyPr/>
           <a:lstStyle/>
           <a:p>
-            <a:pPr eaLnBrk="1" hangingPunct="1"/>
-            <a:r>
-              <a:rPr b="1" sz="2800" u="none">
+            <a:pPr eaLnBrk="1" hangingPunct="1" algn="ctr"/>
+            <a:r>
+              <a:rPr b="1" sz="3400" u="none">
                 <a:solidFill>
                   <a:srgbClr val="0F172A"/>
                 </a:solidFill>
-                <a:latin typeface="Calibri"/>
+                <a:latin typeface="Times New Roman"/>
               </a:rPr>
               <a:t>FEASIBILITY AND VIABILITY</a:t>
             </a:r>
@@ -8516,18 +8525,19 @@
           </a:fontRef>
         </p:style>
         <p:txBody>
-          <a:bodyPr rtlCol="0" anchor="ctr" wrap="square"/>
+          <a:bodyPr rtlCol="0" anchor="ctr" wrap="square" lIns="18288" rIns="18288" tIns="109728" bIns="36576"/>
           <a:lstStyle/>
           <a:p>
             <a:pPr algn="ctr"/>
             <a:r>
-              <a:rPr b="1" sz="1100" u="none">
+              <a:rPr b="1" sz="1050" u="none">
                 <a:solidFill>
                   <a:srgbClr val="0F172A"/>
                 </a:solidFill>
-                <a:latin typeface="Calibri"/>
-              </a:rPr>
-              <a:t>HelloWorldWarriors</a:t>
+                <a:latin typeface="Arial"/>
+              </a:rPr>
+              <a:t>HelloWorld
+Warriors</a:t>
             </a:r>
             <a:endParaRPr lang="en-IN" dirty="0"/>
           </a:p>
@@ -8571,8 +8581,8 @@
         </p:nvSpPr>
         <p:spPr>
           <a:xfrm>
-            <a:off x="548640" y="987552"/>
-            <a:ext cx="11091672" cy="274320"/>
+            <a:off x="548640" y="969264"/>
+            <a:ext cx="11091672" cy="256032"/>
           </a:xfrm>
           <a:prstGeom prst="rect">
             <a:avLst/>
@@ -8590,12 +8600,12 @@
                 <a:solidFill>
                   <a:srgbClr val="0F172A"/>
                 </a:solidFill>
-                <a:latin typeface="Calibri"/>
+                <a:latin typeface="Times New Roman"/>
               </a:rPr>
               <a:t>Defensible Ground Viability: </a:t>
             </a:r>
             <a:r>
-              <a:rPr b="0" sz="1200" u="none">
+              <a:rPr b="0" sz="1250" u="none">
                 <a:solidFill>
                   <a:srgbClr val="166534"/>
                 </a:solidFill>
@@ -8614,8 +8624,8 @@
         </p:nvSpPr>
         <p:spPr>
           <a:xfrm>
-            <a:off x="548640" y="1298448"/>
-            <a:ext cx="5029200" cy="1554480"/>
+            <a:off x="548640" y="1261872"/>
+            <a:ext cx="5029200" cy="1536192"/>
           </a:xfrm>
           <a:prstGeom prst="roundRect">
             <a:avLst/>
@@ -8649,11 +8659,11 @@
           <a:p>
             <a:pPr algn="ctr"/>
             <a:r>
-              <a:rPr b="1" sz="1350" u="none">
+              <a:rPr b="1" sz="1300" u="none">
                 <a:solidFill>
                   <a:srgbClr val="1E3A8A"/>
                 </a:solidFill>
-                <a:latin typeface="Calibri"/>
+                <a:latin typeface="Times New Roman"/>
               </a:rPr>
               <a:t>TECHNICAL FEASIBILITY</a:t>
             </a:r>
@@ -8733,8 +8743,8 @@
         </p:nvSpPr>
         <p:spPr>
           <a:xfrm>
-            <a:off x="548640" y="2962656"/>
-            <a:ext cx="5029200" cy="1554480"/>
+            <a:off x="548640" y="2907792"/>
+            <a:ext cx="5029200" cy="1536192"/>
           </a:xfrm>
           <a:prstGeom prst="roundRect">
             <a:avLst/>
@@ -8768,11 +8778,11 @@
           <a:p>
             <a:pPr algn="ctr"/>
             <a:r>
-              <a:rPr b="1" sz="1350" u="none">
+              <a:rPr b="1" sz="1300" u="none">
                 <a:solidFill>
                   <a:srgbClr val="166534"/>
                 </a:solidFill>
-                <a:latin typeface="Calibri"/>
+                <a:latin typeface="Times New Roman"/>
               </a:rPr>
               <a:t>OPERATIONAL FEASIBILITY</a:t>
             </a:r>
@@ -8783,7 +8793,7 @@
                 </a:solidFill>
                 <a:latin typeface="Calibri"/>
               </a:rPr>
-              <a:t>  |  Aligned with Field Scrap Realities</a:t>
+              <a:t>  |  Aligned with Field Realities</a:t>
             </a:r>
           </a:p>
           <a:p>
@@ -8852,8 +8862,8 @@
         </p:nvSpPr>
         <p:spPr>
           <a:xfrm>
-            <a:off x="548640" y="4626864"/>
-            <a:ext cx="5029200" cy="1554480"/>
+            <a:off x="548640" y="4553712"/>
+            <a:ext cx="5029200" cy="1536192"/>
           </a:xfrm>
           <a:prstGeom prst="roundRect">
             <a:avLst/>
@@ -8887,11 +8897,11 @@
           <a:p>
             <a:pPr algn="ctr"/>
             <a:r>
-              <a:rPr b="1" sz="1350" u="none">
+              <a:rPr b="1" sz="1300" u="none">
                 <a:solidFill>
                   <a:srgbClr val="B45309"/>
                 </a:solidFill>
-                <a:latin typeface="Calibri"/>
+                <a:latin typeface="Times New Roman"/>
               </a:rPr>
               <a:t>ECONOMIC VIABILITY</a:t>
             </a:r>
@@ -8971,8 +8981,8 @@
         </p:nvSpPr>
         <p:spPr>
           <a:xfrm>
-            <a:off x="5742432" y="1298448"/>
-            <a:ext cx="5897880" cy="219456"/>
+            <a:off x="5742432" y="1261872"/>
+            <a:ext cx="5897880" cy="237744"/>
           </a:xfrm>
           <a:prstGeom prst="rect">
             <a:avLst/>
@@ -8986,13 +8996,13 @@
           <a:lstStyle/>
           <a:p>
             <a:r>
-              <a:rPr b="1" sz="1350" u="none">
+              <a:rPr b="1" sz="1300" u="none">
                 <a:solidFill>
                   <a:srgbClr val="0F172A"/>
                 </a:solidFill>
-                <a:latin typeface="Calibri"/>
-              </a:rPr>
-              <a:t>DEFENSIBLE RISK MITIGATION: CHALLENGES &amp; SOLUTIONS</a:t>
+                <a:latin typeface="Times New Roman"/>
+              </a:rPr>
+              <a:t>POTENTIAL CHALLENGES, RISKS &amp; STRATEGIES FOR OVERCOMING</a:t>
             </a:r>
           </a:p>
         </p:txBody>
@@ -9006,8 +9016,8 @@
           <p:nvPr/>
         </p:nvGraphicFramePr>
         <p:xfrm>
-          <a:off x="5742432" y="1572768"/>
-          <a:ext cx="5897880" cy="4572000"/>
+          <a:off x="5742432" y="1536192"/>
+          <a:ext cx="5897880" cy="4480560"/>
         </p:xfrm>
         <a:graphic>
           <a:graphicData uri="http://schemas.openxmlformats.org/drawingml/2006/table">
@@ -9026,13 +9036,13 @@
                     <a:lstStyle/>
                     <a:p>
                       <a:r>
-                        <a:rPr b="1" sz="1250" u="none">
+                        <a:rPr b="1" sz="1200" u="none">
                           <a:solidFill>
                             <a:srgbClr val="FFFFFF"/>
                           </a:solidFill>
-                          <a:latin typeface="Calibri"/>
+                          <a:latin typeface="Times New Roman"/>
                         </a:rPr>
-                        <a:t>GROUND CHALLENGE / RISK</a:t>
+                        <a:t>POTENTIAL CHALLENGES &amp; RISKS</a:t>
                       </a:r>
                     </a:p>
                   </a:txBody>
@@ -9048,13 +9058,13 @@
                     <a:lstStyle/>
                     <a:p>
                       <a:r>
-                        <a:rPr b="1" sz="1250" u="none">
+                        <a:rPr b="1" sz="1200" u="none">
                           <a:solidFill>
                             <a:srgbClr val="FFFFFF"/>
                           </a:solidFill>
-                          <a:latin typeface="Calibri"/>
+                          <a:latin typeface="Times New Roman"/>
                         </a:rPr>
-                        <a:t>OUR PRACTICAL SOLUTION</a:t>
+                        <a:t>STRATEGIES FOR OVERCOMING</a:t>
                       </a:r>
                     </a:p>
                   </a:txBody>
@@ -9065,7 +9075,7 @@
                   </a:tcPr>
                 </a:tc>
               </a:tr>
-              <a:tr h="841248">
+              <a:tr h="822960">
                 <a:tc>
                   <a:txBody>
                     <a:bodyPr/>
@@ -9113,7 +9123,7 @@
                   </a:tcPr>
                 </a:tc>
               </a:tr>
-              <a:tr h="841248">
+              <a:tr h="822960">
                 <a:tc>
                   <a:txBody>
                     <a:bodyPr/>
@@ -9161,7 +9171,7 @@
                   </a:tcPr>
                 </a:tc>
               </a:tr>
-              <a:tr h="841248">
+              <a:tr h="822960">
                 <a:tc>
                   <a:txBody>
                     <a:bodyPr/>
@@ -9209,7 +9219,7 @@
                   </a:tcPr>
                 </a:tc>
               </a:tr>
-              <a:tr h="841248">
+              <a:tr h="822960">
                 <a:tc>
                   <a:txBody>
                     <a:bodyPr/>
@@ -9257,7 +9267,7 @@
                   </a:tcPr>
                 </a:tc>
               </a:tr>
-              <a:tr h="841248">
+              <a:tr h="822960">
                 <a:tc>
                   <a:txBody>
                     <a:bodyPr/>
@@ -9433,13 +9443,13 @@
           <a:bodyPr/>
           <a:lstStyle/>
           <a:p>
-            <a:pPr eaLnBrk="1" hangingPunct="1"/>
-            <a:r>
-              <a:rPr b="1" sz="2800" u="none">
+            <a:pPr eaLnBrk="1" hangingPunct="1" algn="ctr"/>
+            <a:r>
+              <a:rPr b="1" sz="3400" u="none">
                 <a:solidFill>
                   <a:srgbClr val="0F172A"/>
                 </a:solidFill>
-                <a:latin typeface="Calibri"/>
+                <a:latin typeface="Times New Roman"/>
               </a:rPr>
               <a:t>IMPACT AND BENEFITS</a:t>
             </a:r>
@@ -9639,18 +9649,19 @@
           </a:fontRef>
         </p:style>
         <p:txBody>
-          <a:bodyPr rtlCol="0" anchor="ctr" wrap="square"/>
+          <a:bodyPr rtlCol="0" anchor="ctr" wrap="square" lIns="18288" rIns="18288" tIns="109728" bIns="36576"/>
           <a:lstStyle/>
           <a:p>
             <a:pPr algn="ctr"/>
             <a:r>
-              <a:rPr b="1" sz="1100" u="none">
+              <a:rPr b="1" sz="1050" u="none">
                 <a:solidFill>
                   <a:srgbClr val="0F172A"/>
                 </a:solidFill>
-                <a:latin typeface="Calibri"/>
-              </a:rPr>
-              <a:t>HelloWorldWarriors</a:t>
+                <a:latin typeface="Arial"/>
+              </a:rPr>
+              <a:t>HelloWorld
+Warriors</a:t>
             </a:r>
             <a:endParaRPr lang="en-IN" dirty="0"/>
           </a:p>
@@ -9695,7 +9706,7 @@
         <p:spPr>
           <a:xfrm>
             <a:off x="548640" y="960120"/>
-            <a:ext cx="11091672" cy="256032"/>
+            <a:ext cx="11091672" cy="237744"/>
           </a:xfrm>
           <a:prstGeom prst="rect">
             <a:avLst/>
@@ -9713,12 +9724,12 @@
                 <a:solidFill>
                   <a:srgbClr val="0F172A"/>
                 </a:solidFill>
-                <a:latin typeface="Calibri"/>
-              </a:rPr>
-              <a:t>Stakeholder Value Transformation, Macro Impacts &amp; Business Model: </a:t>
-            </a:r>
-            <a:r>
-              <a:rPr b="0" sz="1200" u="none">
+                <a:latin typeface="Times New Roman"/>
+              </a:rPr>
+              <a:t>Stakeholder Value Transformation &amp; Macro Impacts: </a:t>
+            </a:r>
+            <a:r>
+              <a:rPr b="0" sz="1250" u="none">
                 <a:solidFill>
                   <a:srgbClr val="166534"/>
                 </a:solidFill>
@@ -9776,7 +9787,7 @@
                 <a:solidFill>
                   <a:srgbClr val="166534"/>
                 </a:solidFill>
-                <a:latin typeface="Calibri"/>
+                <a:latin typeface="Times New Roman"/>
               </a:rPr>
               <a:t>1. INFORMAL COLLECTORS</a:t>
             </a:r>
@@ -9914,7 +9925,7 @@
                 <a:solidFill>
                   <a:srgbClr val="B45309"/>
                 </a:solidFill>
-                <a:latin typeface="Calibri"/>
+                <a:latin typeface="Times New Roman"/>
               </a:rPr>
               <a:t>2. LOCAL AGGREGATORS</a:t>
             </a:r>
@@ -10052,7 +10063,7 @@
                 <a:solidFill>
                   <a:srgbClr val="1E3A8A"/>
                 </a:solidFill>
-                <a:latin typeface="Calibri"/>
+                <a:latin typeface="Times New Roman"/>
               </a:rPr>
               <a:t>3. AUTHORIZED RECYCLERS</a:t>
             </a:r>
@@ -10190,7 +10201,7 @@
                 <a:solidFill>
                   <a:srgbClr val="6D28D9"/>
                 </a:solidFill>
-                <a:latin typeface="Calibri"/>
+                <a:latin typeface="Times New Roman"/>
               </a:rPr>
               <a:t>4. REGULATORS / EPR</a:t>
             </a:r>
@@ -10290,7 +10301,7 @@
         <p:spPr>
           <a:xfrm>
             <a:off x="548640" y="2816352"/>
-            <a:ext cx="3611880" cy="1325880"/>
+            <a:ext cx="3611880" cy="1353312"/>
           </a:xfrm>
           <a:prstGeom prst="roundRect">
             <a:avLst/>
@@ -10328,15 +10339,15 @@
                 <a:solidFill>
                   <a:srgbClr val="0284C7"/>
                 </a:solidFill>
-                <a:latin typeface="Calibri"/>
-              </a:rPr>
-              <a:t>SOCIAL IMPACT | Livelihoods &amp; Safety</a:t>
+                <a:latin typeface="Times New Roman"/>
+              </a:rPr>
+              <a:t>BENEFITS: SOCIAL IMPACT</a:t>
             </a:r>
           </a:p>
           <a:p>
             <a:pPr>
               <a:spcBef>
-                <a:spcPts val="400"/>
+                <a:spcPts val="300"/>
               </a:spcBef>
               <a:spcAft>
                 <a:spcPts val="0"/>
@@ -10358,13 +10369,13 @@
                 </a:solidFill>
                 <a:latin typeface="Calibri"/>
               </a:rPr>
-              <a:t>Digital transaction ledger unlocks formal credit, banking &amp; micro-loans.</a:t>
+              <a:t>Digital transaction ledger unlocks formal micro-loans &amp; banking.</a:t>
             </a:r>
           </a:p>
           <a:p>
             <a:pPr>
               <a:spcBef>
-                <a:spcPts val="400"/>
+                <a:spcPts val="300"/>
               </a:spcBef>
               <a:spcAft>
                 <a:spcPts val="0"/>
@@ -10386,7 +10397,7 @@
                 </a:solidFill>
                 <a:latin typeface="Calibri"/>
               </a:rPr>
-              <a:t>Transitions informal waste-pickers into recognized, certified green collar workers.</a:t>
+              <a:t>Direct formal identity &amp; certified green collar status in circular chain.</a:t>
             </a:r>
           </a:p>
         </p:txBody>
@@ -10400,7 +10411,7 @@
         <p:spPr>
           <a:xfrm>
             <a:off x="4288536" y="2816352"/>
-            <a:ext cx="3611880" cy="1325880"/>
+            <a:ext cx="3611880" cy="1353312"/>
           </a:xfrm>
           <a:prstGeom prst="roundRect">
             <a:avLst/>
@@ -10438,15 +10449,15 @@
                 <a:solidFill>
                   <a:srgbClr val="B45309"/>
                 </a:solidFill>
-                <a:latin typeface="Calibri"/>
-              </a:rPr>
-              <a:t>ECONOMIC IMPACT | Market Efficiency</a:t>
+                <a:latin typeface="Times New Roman"/>
+              </a:rPr>
+              <a:t>BENEFITS: ECONOMIC IMPACT</a:t>
             </a:r>
           </a:p>
           <a:p>
             <a:pPr>
               <a:spcBef>
-                <a:spcPts val="400"/>
+                <a:spcPts val="300"/>
               </a:spcBef>
               <a:spcAft>
                 <a:spcPts val="0"/>
@@ -10468,13 +10479,13 @@
                 </a:solidFill>
                 <a:latin typeface="Calibri"/>
               </a:rPr>
-              <a:t>Live LME benchmark floor completely halts predatory 25%–40% middleman price cuts.</a:t>
+              <a:t>Live LME benchmark stops 25%–40% predatory middleman cuts.</a:t>
             </a:r>
           </a:p>
           <a:p>
             <a:pPr>
               <a:spcBef>
-                <a:spcPts val="400"/>
+                <a:spcPts val="300"/>
               </a:spcBef>
               <a:spcAft>
                 <a:spcPts val="0"/>
@@ -10496,7 +10507,7 @@
                 </a:solidFill>
                 <a:latin typeface="Calibri"/>
               </a:rPr>
-              <a:t>Consolidated milk-run truck dispatch lowers recycler freight costs by 35%.</a:t>
+              <a:t>Consolidated milk-run truck dispatch lowers freight costs by 35%.</a:t>
             </a:r>
           </a:p>
         </p:txBody>
@@ -10510,7 +10521,7 @@
         <p:spPr>
           <a:xfrm>
             <a:off x="8028432" y="2816352"/>
-            <a:ext cx="3611880" cy="1325880"/>
+            <a:ext cx="3611880" cy="1353312"/>
           </a:xfrm>
           <a:prstGeom prst="roundRect">
             <a:avLst/>
@@ -10548,15 +10559,15 @@
                 <a:solidFill>
                   <a:srgbClr val="166534"/>
                 </a:solidFill>
-                <a:latin typeface="Calibri"/>
-              </a:rPr>
-              <a:t>ENVIRONMENTAL IMPACT | Toxic Diversion</a:t>
+                <a:latin typeface="Times New Roman"/>
+              </a:rPr>
+              <a:t>BENEFITS: ENVIRONMENTAL IMPACT</a:t>
             </a:r>
           </a:p>
           <a:p>
             <a:pPr>
               <a:spcBef>
-                <a:spcPts val="400"/>
+                <a:spcPts val="300"/>
               </a:spcBef>
               <a:spcAft>
                 <a:spcPts val="0"/>
@@ -10578,13 +10589,13 @@
                 </a:solidFill>
                 <a:latin typeface="Calibri"/>
               </a:rPr>
-              <a:t>Diverts toxic PCBs away from backyard acid baths and open-wire burning in slums.</a:t>
+              <a:t>Diverts PCBs away from crude acid baths and open burning in slums.</a:t>
             </a:r>
           </a:p>
           <a:p>
             <a:pPr>
               <a:spcBef>
-                <a:spcPts val="400"/>
+                <a:spcPts val="300"/>
               </a:spcBef>
               <a:spcAft>
                 <a:spcPts val="0"/>
@@ -10606,7 +10617,7 @@
                 </a:solidFill>
                 <a:latin typeface="Calibri"/>
               </a:rPr>
-              <a:t>Secures domestic hydrometallurgical recovery of high-purity Cu, Au, Ag &amp; Li.</a:t>
+              <a:t>Secures domestic recovery of pure Cu, Au, Ag &amp; essential battery Li.</a:t>
             </a:r>
           </a:p>
         </p:txBody>
@@ -10619,8 +10630,8 @@
         </p:nvSpPr>
         <p:spPr>
           <a:xfrm>
-            <a:off x="548640" y="4315968"/>
-            <a:ext cx="11091672" cy="219456"/>
+            <a:off x="548640" y="4297680"/>
+            <a:ext cx="11091672" cy="237744"/>
           </a:xfrm>
           <a:prstGeom prst="rect">
             <a:avLst/>
@@ -10638,9 +10649,9 @@
                 <a:solidFill>
                   <a:srgbClr val="0F172A"/>
                 </a:solidFill>
-                <a:latin typeface="Calibri"/>
-              </a:rPr>
-              <a:t>BUSINESS MODEL &amp; FINANCIAL SUSTAINABILITY: </a:t>
+                <a:latin typeface="Times New Roman"/>
+              </a:rPr>
+              <a:t>FINANCIAL SUSTAINABILITY &amp; BUSINESS MODEL: </a:t>
             </a:r>
             <a:r>
               <a:rPr b="0" sz="1200" u="none">
@@ -10662,8 +10673,8 @@
         </p:nvSpPr>
         <p:spPr>
           <a:xfrm>
-            <a:off x="548640" y="4553712"/>
-            <a:ext cx="2679192" cy="1572768"/>
+            <a:off x="548640" y="4572000"/>
+            <a:ext cx="2679192" cy="1554480"/>
           </a:xfrm>
           <a:prstGeom prst="roundRect">
             <a:avLst/>
@@ -10701,7 +10712,7 @@
                 <a:solidFill>
                   <a:srgbClr val="166534"/>
                 </a:solidFill>
-                <a:latin typeface="Calibri"/>
+                <a:latin typeface="Times New Roman"/>
               </a:rPr>
               <a:t>1. ZERO-FEE WORKERS</a:t>
             </a:r>
@@ -10772,8 +10783,8 @@
         </p:nvSpPr>
         <p:spPr>
           <a:xfrm>
-            <a:off x="3355848" y="4553712"/>
-            <a:ext cx="2679192" cy="1572768"/>
+            <a:off x="3355848" y="4572000"/>
+            <a:ext cx="2679192" cy="1554480"/>
           </a:xfrm>
           <a:prstGeom prst="roundRect">
             <a:avLst/>
@@ -10811,7 +10822,7 @@
                 <a:solidFill>
                   <a:srgbClr val="B45309"/>
                 </a:solidFill>
-                <a:latin typeface="Calibri"/>
+                <a:latin typeface="Times New Roman"/>
               </a:rPr>
               <a:t>2. LOCAL AGGREGATORS</a:t>
             </a:r>
@@ -10882,8 +10893,8 @@
         </p:nvSpPr>
         <p:spPr>
           <a:xfrm>
-            <a:off x="6163056" y="4553712"/>
-            <a:ext cx="2679192" cy="1572768"/>
+            <a:off x="6163056" y="4572000"/>
+            <a:ext cx="2679192" cy="1554480"/>
           </a:xfrm>
           <a:prstGeom prst="roundRect">
             <a:avLst/>
@@ -10921,7 +10932,7 @@
                 <a:solidFill>
                   <a:srgbClr val="1E3A8A"/>
                 </a:solidFill>
-                <a:latin typeface="Calibri"/>
+                <a:latin typeface="Times New Roman"/>
               </a:rPr>
               <a:t>3. AUTHORIZED RECYCLERS</a:t>
             </a:r>
@@ -10992,8 +11003,8 @@
         </p:nvSpPr>
         <p:spPr>
           <a:xfrm>
-            <a:off x="8970264" y="4553712"/>
-            <a:ext cx="2679192" cy="1572768"/>
+            <a:off x="8970264" y="4572000"/>
+            <a:ext cx="2679192" cy="1554480"/>
           </a:xfrm>
           <a:prstGeom prst="roundRect">
             <a:avLst/>
@@ -11031,7 +11042,7 @@
                 <a:solidFill>
                   <a:srgbClr val="6D28D9"/>
                 </a:solidFill>
-                <a:latin typeface="Calibri"/>
+                <a:latin typeface="Times New Roman"/>
               </a:rPr>
               <a:t>4. ENTERPRISE EPR SAAS</a:t>
             </a:r>
@@ -11218,15 +11229,15 @@
           <a:bodyPr/>
           <a:lstStyle/>
           <a:p>
-            <a:pPr eaLnBrk="1" hangingPunct="1"/>
-            <a:r>
-              <a:rPr b="1" sz="2800" u="none">
+            <a:pPr eaLnBrk="1" hangingPunct="1" algn="ctr"/>
+            <a:r>
+              <a:rPr b="1" sz="3400" u="none">
                 <a:solidFill>
                   <a:srgbClr val="0F172A"/>
                 </a:solidFill>
-                <a:latin typeface="Calibri"/>
-              </a:rPr>
-              <a:t>RESEARCH AND REFERENCES</a:t>
+                <a:latin typeface="Times New Roman"/>
+              </a:rPr>
+              <a:t>RESEARCH  AND REFERENCES</a:t>
             </a:r>
           </a:p>
         </p:txBody>
@@ -11424,18 +11435,19 @@
           </a:fontRef>
         </p:style>
         <p:txBody>
-          <a:bodyPr rtlCol="0" anchor="ctr" wrap="square"/>
+          <a:bodyPr rtlCol="0" anchor="ctr" wrap="square" lIns="18288" rIns="18288" tIns="109728" bIns="36576"/>
           <a:lstStyle/>
           <a:p>
             <a:pPr algn="ctr"/>
             <a:r>
-              <a:rPr b="1" sz="1100" u="none">
+              <a:rPr b="1" sz="1050" u="none">
                 <a:solidFill>
                   <a:srgbClr val="0F172A"/>
                 </a:solidFill>
-                <a:latin typeface="Calibri"/>
-              </a:rPr>
-              <a:t>HelloWorldWarriors</a:t>
+                <a:latin typeface="Arial"/>
+              </a:rPr>
+              <a:t>HelloWorld
+Warriors</a:t>
             </a:r>
             <a:endParaRPr lang="en-IN" dirty="0"/>
           </a:p>
@@ -11479,8 +11491,8 @@
         </p:nvSpPr>
         <p:spPr>
           <a:xfrm>
-            <a:off x="548640" y="987552"/>
-            <a:ext cx="11091672" cy="274320"/>
+            <a:off x="548640" y="969264"/>
+            <a:ext cx="11091672" cy="256032"/>
           </a:xfrm>
           <a:prstGeom prst="rect">
             <a:avLst/>
@@ -11498,12 +11510,12 @@
                 <a:solidFill>
                   <a:srgbClr val="0F172A"/>
                 </a:solidFill>
-                <a:latin typeface="Calibri"/>
-              </a:rPr>
-              <a:t>Evidence-Based Architecture: </a:t>
-            </a:r>
-            <a:r>
-              <a:rPr b="0" sz="1200" u="none">
+                <a:latin typeface="Times New Roman"/>
+              </a:rPr>
+              <a:t>DETAILS / LINKS OF THE REFERENCE AND RESEARCH WORK: </a:t>
+            </a:r>
+            <a:r>
+              <a:rPr b="0" sz="1250" u="none">
                 <a:solidFill>
                   <a:srgbClr val="166534"/>
                 </a:solidFill>
@@ -11522,7 +11534,7 @@
         </p:nvSpPr>
         <p:spPr>
           <a:xfrm>
-            <a:off x="548640" y="1298448"/>
+            <a:off x="548640" y="1261872"/>
             <a:ext cx="3611880" cy="3429000"/>
           </a:xfrm>
           <a:prstGeom prst="roundRect">
@@ -11557,11 +11569,11 @@
           <a:p>
             <a:pPr algn="ctr"/>
             <a:r>
-              <a:rPr b="1" sz="1350" u="none">
+              <a:rPr b="1" sz="1300" u="none">
                 <a:solidFill>
                   <a:srgbClr val="1E3A8A"/>
                 </a:solidFill>
-                <a:latin typeface="Calibri"/>
+                <a:latin typeface="Times New Roman"/>
               </a:rPr>
               <a:t>1. POLICY &amp; REGULATORY MANDATES</a:t>
             </a:r>
@@ -11579,7 +11591,7 @@
           <a:p>
             <a:pPr>
               <a:spcBef>
-                <a:spcPts val="400"/>
+                <a:spcPts val="350"/>
               </a:spcBef>
               <a:spcAft>
                 <a:spcPts val="0"/>
@@ -11601,13 +11613,13 @@
                 </a:solidFill>
                 <a:latin typeface="Calibri"/>
               </a:rPr>
-              <a:t>Establishes core mandate for formalizing informal waste-pickers and setting verified price benchmarks.</a:t>
+              <a:t>Mandate for formalizing informal waste-pickers and establishing verified price benchmarks.</a:t>
             </a:r>
           </a:p>
           <a:p>
             <a:pPr>
               <a:spcBef>
-                <a:spcPts val="400"/>
+                <a:spcPts val="350"/>
               </a:spcBef>
               <a:spcAft>
                 <a:spcPts val="0"/>
@@ -11629,13 +11641,13 @@
                 </a:solidFill>
                 <a:latin typeface="Calibri"/>
               </a:rPr>
-              <a:t>Enforces digital EPR credit trading, formal recycler licensing, and automated Form-6 filing audit trails.</a:t>
+              <a:t>Enforces digital EPR credit trading, formal recycler licensing, and automated Form-6 audit trails.</a:t>
             </a:r>
           </a:p>
           <a:p>
             <a:pPr>
               <a:spcBef>
-                <a:spcPts val="400"/>
+                <a:spcPts val="350"/>
               </a:spcBef>
               <a:spcAft>
                 <a:spcPts val="0"/>
@@ -11663,7 +11675,7 @@
           <a:p>
             <a:pPr>
               <a:spcBef>
-                <a:spcPts val="400"/>
+                <a:spcPts val="350"/>
               </a:spcBef>
               <a:spcAft>
                 <a:spcPts val="0"/>
@@ -11698,7 +11710,7 @@
         </p:nvSpPr>
         <p:spPr>
           <a:xfrm>
-            <a:off x="4288536" y="1298448"/>
+            <a:off x="4288536" y="1261872"/>
             <a:ext cx="3611880" cy="3429000"/>
           </a:xfrm>
           <a:prstGeom prst="roundRect">
@@ -11733,11 +11745,11 @@
           <a:p>
             <a:pPr algn="ctr"/>
             <a:r>
-              <a:rPr b="1" sz="1350" u="none">
+              <a:rPr b="1" sz="1300" u="none">
                 <a:solidFill>
                   <a:srgbClr val="166534"/>
                 </a:solidFill>
-                <a:latin typeface="Calibri"/>
+                <a:latin typeface="Times New Roman"/>
               </a:rPr>
               <a:t>2. TECHNOLOGY &amp; AI RESEARCH</a:t>
             </a:r>
@@ -11755,7 +11767,7 @@
           <a:p>
             <a:pPr>
               <a:spcBef>
-                <a:spcPts val="400"/>
+                <a:spcPts val="350"/>
               </a:spcBef>
               <a:spcAft>
                 <a:spcPts val="0"/>
@@ -11777,13 +11789,13 @@
                 </a:solidFill>
                 <a:latin typeface="Calibri"/>
               </a:rPr>
-              <a:t>Proves transfer-learning CNNs achieve 94%+ classification accuracy for electronic scrap on edge hardware.</a:t>
+              <a:t>Proves CNN transfer-learning achieves 94%+ scrap classification accuracy on edge hardware.</a:t>
             </a:r>
           </a:p>
           <a:p>
             <a:pPr>
               <a:spcBef>
-                <a:spcPts val="400"/>
+                <a:spcPts val="350"/>
               </a:spcBef>
               <a:spcAft>
                 <a:spcPts val="0"/>
@@ -11805,13 +11817,13 @@
                 </a:solidFill>
                 <a:latin typeface="Calibri"/>
               </a:rPr>
-              <a:t>Hardware-aware quantized INT8 neural model (&lt;5MB) running real-time on budget Android smartphones.</a:t>
+              <a:t>Quantized INT8 neural model (&lt;5MB) running real-time inference on budget Android phones.</a:t>
             </a:r>
           </a:p>
           <a:p>
             <a:pPr>
               <a:spcBef>
-                <a:spcPts val="400"/>
+                <a:spcPts val="350"/>
               </a:spcBef>
               <a:spcAft>
                 <a:spcPts val="0"/>
@@ -11833,13 +11845,13 @@
                 </a:solidFill>
                 <a:latin typeface="Calibri"/>
               </a:rPr>
-              <a:t>Vernacular speech-to-text and voice synthesis in 10+ regional Indian languages for low-literacy workers.</a:t>
+              <a:t>Vernacular speech-to-text models in 10+ regional Indian languages for non-literate workers.</a:t>
             </a:r>
           </a:p>
           <a:p>
             <a:pPr>
               <a:spcBef>
-                <a:spcPts val="400"/>
+                <a:spcPts val="350"/>
               </a:spcBef>
               <a:spcAft>
                 <a:spcPts val="0"/>
@@ -11861,7 +11873,7 @@
                 </a:solidFill>
                 <a:latin typeface="Calibri"/>
               </a:rPr>
-              <a:t>Geospatial indexing (ST_DWithin) and K-Nearest-Neighbor queries for optimal collector-to-hub routing.</a:t>
+              <a:t>Geospatial indexing (ST_DWithin) and KNN queries for optimal collector milk-run routing.</a:t>
             </a:r>
           </a:p>
         </p:txBody>
@@ -11874,7 +11886,7 @@
         </p:nvSpPr>
         <p:spPr>
           <a:xfrm>
-            <a:off x="8028432" y="1298448"/>
+            <a:off x="8028432" y="1261872"/>
             <a:ext cx="3611880" cy="3429000"/>
           </a:xfrm>
           <a:prstGeom prst="roundRect">
@@ -11909,11 +11921,11 @@
           <a:p>
             <a:pPr algn="ctr"/>
             <a:r>
-              <a:rPr b="1" sz="1350" u="none">
+              <a:rPr b="1" sz="1300" u="none">
                 <a:solidFill>
                   <a:srgbClr val="B45309"/>
                 </a:solidFill>
-                <a:latin typeface="Calibri"/>
+                <a:latin typeface="Times New Roman"/>
               </a:rPr>
               <a:t>3. PRIMARY FIELD RESEARCH</a:t>
             </a:r>
@@ -11931,7 +11943,7 @@
           <a:p>
             <a:pPr>
               <a:spcBef>
-                <a:spcPts val="400"/>
+                <a:spcPts val="350"/>
               </a:spcBef>
               <a:spcAft>
                 <a:spcPts val="0"/>
@@ -11953,13 +11965,13 @@
                 </a:solidFill>
                 <a:latin typeface="Calibri"/>
               </a:rPr>
-              <a:t>"Scrap dealers deduct 1–2 kg on mechanical spring scales. If we have true rates and scale photo proof, no one can cut our money."</a:t>
+              <a:t>"Scrap dealers deduct 1–2 kg on spring scales. Scale photo proof protects our hard-earned money."</a:t>
             </a:r>
           </a:p>
           <a:p>
             <a:pPr>
               <a:spcBef>
-                <a:spcPts val="400"/>
+                <a:spcPts val="350"/>
               </a:spcBef>
               <a:spcAft>
                 <a:spcPts val="0"/>
@@ -11981,13 +11993,13 @@
                 </a:solidFill>
                 <a:latin typeface="Calibri"/>
               </a:rPr>
-              <a:t>"Households bargain hard because they don't trust our rates. Showing live market rates on our phone closes deals fast."</a:t>
+              <a:t>"Households don't trust rates; showing live market prices on our phone closes deals fast."</a:t>
             </a:r>
           </a:p>
           <a:p>
             <a:pPr>
               <a:spcBef>
-                <a:spcPts val="400"/>
+                <a:spcPts val="350"/>
               </a:spcBef>
               <a:spcAft>
                 <a:spcPts val="0"/>
@@ -12009,13 +12021,13 @@
                 </a:solidFill>
                 <a:latin typeface="Calibri"/>
               </a:rPr>
-              <a:t>"Big recyclers pay higher rates but demand bulk lots and manifests. Digital lotting lets us operate as certified formal hubs."</a:t>
+              <a:t>"Big recyclers demand bulk lots and manifests. Digital lotting lets us operate as formal hubs."</a:t>
             </a:r>
           </a:p>
           <a:p>
             <a:pPr>
               <a:spcBef>
-                <a:spcPts val="400"/>
+                <a:spcPts val="350"/>
               </a:spcBef>
               <a:spcAft>
                 <a:spcPts val="0"/>
@@ -12050,7 +12062,7 @@
         </p:nvSpPr>
         <p:spPr>
           <a:xfrm>
-            <a:off x="548640" y="4846320"/>
+            <a:off x="548640" y="4828032"/>
             <a:ext cx="5477256" cy="1371600"/>
           </a:xfrm>
           <a:prstGeom prst="roundRect">
@@ -12089,7 +12101,7 @@
                 <a:solidFill>
                   <a:srgbClr val="166534"/>
                 </a:solidFill>
-                <a:latin typeface="Calibri"/>
+                <a:latin typeface="Times New Roman"/>
               </a:rPr>
               <a:t>PROTOTYPE WEB APPLICATION:  </a:t>
             </a:r>
@@ -12139,7 +12151,7 @@
         </p:nvSpPr>
         <p:spPr>
           <a:xfrm>
-            <a:off x="6163056" y="4846320"/>
+            <a:off x="6163056" y="4828032"/>
             <a:ext cx="5477256" cy="1371600"/>
           </a:xfrm>
           <a:prstGeom prst="roundRect">
@@ -12174,16 +12186,16 @@
           <a:p>
             <a:pPr algn="ctr"/>
             <a:r>
-              <a:rPr b="1" sz="1200" u="none">
+              <a:rPr b="1" sz="1250" u="none">
                 <a:solidFill>
                   <a:srgbClr val="1E3A8A"/>
                 </a:solidFill>
-                <a:latin typeface="Calibri"/>
-              </a:rPr>
-              <a:t>YOUTUBE VIDEO DEMONSTRATION:  </a:t>
-            </a:r>
-            <a:r>
-              <a:rPr b="1" sz="1200" u="sng">
+                <a:latin typeface="Times New Roman"/>
+              </a:rPr>
+              <a:t>YOUTUBE DEMO:  </a:t>
+            </a:r>
+            <a:r>
+              <a:rPr b="1" sz="1250" u="sng">
                 <a:solidFill>
                   <a:srgbClr val="1E3A8A"/>
                 </a:solidFill>

</xml_diff>